<commit_message>
Generate and update comprehensive 12-slide HireLens defense presentation
</commit_message>
<xml_diff>
--- a/HireLens_Presentation.pptx
+++ b/HireLens_Presentation.pptx
@@ -15,6 +15,8 @@
     <p:sldId id="263" r:id="rId14"/>
     <p:sldId id="264" r:id="rId15"/>
     <p:sldId id="265" r:id="rId16"/>
+    <p:sldId id="266" r:id="rId17"/>
+    <p:sldId id="267" r:id="rId18"/>
   </p:sldIdLst>
   <p:sldSz cx="12191695" cy="6858000" type="screen4x3"/>
   <p:notesSz cx="6858000" cy="9144000"/>
@@ -3113,8 +3115,8 @@
         </p:nvSpPr>
         <p:spPr>
           <a:xfrm>
-            <a:off x="914400" y="914400"/>
-            <a:ext cx="10362895" cy="5029200"/>
+            <a:off x="731520" y="731520"/>
+            <a:ext cx="10728655" cy="5394960"/>
           </a:xfrm>
           <a:prstGeom prst="rect">
             <a:avLst/>
@@ -3158,8 +3160,8 @@
         </p:nvSpPr>
         <p:spPr>
           <a:xfrm>
-            <a:off x="1371600" y="1280160"/>
-            <a:ext cx="9448495" cy="4114800"/>
+            <a:off x="1097280" y="1005840"/>
+            <a:ext cx="10058400" cy="4846320"/>
           </a:xfrm>
           <a:prstGeom prst="rect">
             <a:avLst/>
@@ -3174,7 +3176,7 @@
           <a:p>
             <a:pPr>
               <a:spcAft>
-                <a:spcPts val="1000"/>
+                <a:spcPts val="600"/>
               </a:spcAft>
               <a:defRPr sz="4400" b="1">
                 <a:solidFill>
@@ -3189,47 +3191,64 @@
           <a:p>
             <a:pPr>
               <a:spcAft>
+                <a:spcPts val="2000"/>
+              </a:spcAft>
+              <a:defRPr sz="2200" b="1">
+                <a:solidFill>
+                  <a:srgbClr val="FFFFFF"/>
+                </a:solidFill>
+              </a:defRPr>
+            </a:pPr>
+            <a:r>
+              <a:t>AI-Powered Resume Screening, Skill Gap Analysis &amp; Job Matching System</a:t>
+            </a:r>
+          </a:p>
+          <a:p>
+            <a:pPr>
+              <a:spcAft>
                 <a:spcPts val="2500"/>
               </a:spcAft>
-              <a:defRPr sz="2200" b="1">
+              <a:defRPr sz="1400">
+                <a:solidFill>
+                  <a:srgbClr val="38BDF8"/>
+                </a:solidFill>
+              </a:defRPr>
+            </a:pPr>
+            <a:r>
+              <a:t>Minor Project 1 • Bachelor of Technology (B.Tech 3rd Year) in AI &amp; ML</a:t>
+            </a:r>
+          </a:p>
+          <a:p>
+            <a:pPr>
+              <a:defRPr sz="1300">
                 <a:solidFill>
                   <a:srgbClr val="FFFFFF"/>
                 </a:solidFill>
               </a:defRPr>
             </a:pPr>
             <a:r>
-              <a:t>AI-Powered Resume Screening, Skill Gap Analysis &amp; Job Matching System</a:t>
-            </a:r>
-          </a:p>
-          <a:p>
-            <a:pPr>
-              <a:spcAft>
-                <a:spcPts val="3000"/>
-              </a:spcAft>
-              <a:defRPr sz="1400">
-                <a:solidFill>
-                  <a:srgbClr val="38BDF8"/>
-                </a:solidFill>
-              </a:defRPr>
-            </a:pPr>
-            <a:r>
-              <a:t>Minor Project 1 Presentation • Department of Artificial Intelligence &amp; Machine Learning</a:t>
-            </a:r>
-          </a:p>
-          <a:p>
-            <a:pPr>
-              <a:defRPr sz="1400" b="1">
-                <a:solidFill>
-                  <a:srgbClr val="FFFFFF"/>
-                </a:solidFill>
-              </a:defRPr>
-            </a:pPr>
-            <a:r>
-              <a:t>👥 Project Team:  Aryan (Roll: 28240533)  |  Nitish (Roll: 28240529)</a:t>
+              <a:t>👥 Project Team Members:</a:t>
             </a:r>
             <a:br/>
             <a:r>
+              <a:t>• Aryan  (Roll No: 28240533)</a:t>
+            </a:r>
+            <a:br/>
+            <a:r>
+              <a:t>• Nitish  (Roll No: 28240529)</a:t>
+            </a:r>
+            <a:br/>
+            <a:br/>
+            <a:r>
               <a:t>🏛️ Institution: Panipat Institute of Engineering &amp; Technology (PIET)</a:t>
+            </a:r>
+            <a:br/>
+            <a:r>
+              <a:t>🌐 Live Demo: https://aryan8182-hirelens-ai-resume-analyzer-app-p2fpgo.streamlit.app/</a:t>
+            </a:r>
+            <a:br/>
+            <a:r>
+              <a:t>🔗 GitHub: https://github.com/Aryan8182/Hirelens-ai-resume-analyzer</a:t>
             </a:r>
           </a:p>
         </p:txBody>
@@ -3262,14 +3281,84 @@
       <p:grpSpPr/>
       <p:sp>
         <p:nvSpPr>
-          <p:cNvPr id="2" name="Rectangle 1"/>
+          <p:cNvPr id="2" name="TextBox 1"/>
+          <p:cNvSpPr txBox="1"/>
+          <p:nvPr/>
+        </p:nvSpPr>
+        <p:spPr>
+          <a:xfrm>
+            <a:off x="731520" y="320040"/>
+            <a:ext cx="10058400" cy="320040"/>
+          </a:xfrm>
+          <a:prstGeom prst="rect">
+            <a:avLst/>
+          </a:prstGeom>
+          <a:noFill/>
+        </p:spPr>
+        <p:txBody>
+          <a:bodyPr wrap="none">
+            <a:spAutoFit/>
+          </a:bodyPr>
+          <a:lstStyle/>
+          <a:p>
+            <a:pPr>
+              <a:defRPr sz="1100" b="1">
+                <a:solidFill>
+                  <a:srgbClr val="818CF8"/>
+                </a:solidFill>
+              </a:defRPr>
+            </a:pPr>
+            <a:r>
+              <a:t>HIRELENS MINOR PROJECT 1</a:t>
+            </a:r>
+          </a:p>
+        </p:txBody>
+      </p:sp>
+      <p:sp>
+        <p:nvSpPr>
+          <p:cNvPr id="3" name="TextBox 2"/>
+          <p:cNvSpPr txBox="1"/>
+          <p:nvPr/>
+        </p:nvSpPr>
+        <p:spPr>
+          <a:xfrm>
+            <a:off x="731520" y="594360"/>
+            <a:ext cx="10515600" cy="640080"/>
+          </a:xfrm>
+          <a:prstGeom prst="rect">
+            <a:avLst/>
+          </a:prstGeom>
+          <a:noFill/>
+        </p:spPr>
+        <p:txBody>
+          <a:bodyPr wrap="none">
+            <a:spAutoFit/>
+          </a:bodyPr>
+          <a:lstStyle/>
+          <a:p>
+            <a:pPr>
+              <a:defRPr sz="2400" b="1">
+                <a:solidFill>
+                  <a:srgbClr val="FFFFFF"/>
+                </a:solidFill>
+              </a:defRPr>
+            </a:pPr>
+            <a:r>
+              <a:t>FastAPI REST Microservice (api.py)</a:t>
+            </a:r>
+          </a:p>
+        </p:txBody>
+      </p:sp>
+      <p:sp>
+        <p:nvSpPr>
+          <p:cNvPr id="4" name="Rectangle 3"/>
           <p:cNvSpPr/>
           <p:nvPr/>
         </p:nvSpPr>
         <p:spPr>
           <a:xfrm>
-            <a:off x="914400" y="914400"/>
-            <a:ext cx="10362895" cy="5029200"/>
+            <a:off x="731520" y="1371600"/>
+            <a:ext cx="10728655" cy="4937760"/>
           </a:xfrm>
           <a:prstGeom prst="rect">
             <a:avLst/>
@@ -3277,9 +3366,9 @@
           <a:solidFill>
             <a:srgbClr val="0F172A"/>
           </a:solidFill>
-          <a:ln w="25400">
+          <a:ln w="19050">
             <a:solidFill>
-              <a:srgbClr val="34D399"/>
+              <a:srgbClr val="38BDF8"/>
             </a:solidFill>
           </a:ln>
         </p:spPr>
@@ -3307,14 +3396,14 @@
       </p:sp>
       <p:sp>
         <p:nvSpPr>
-          <p:cNvPr id="3" name="TextBox 2"/>
+          <p:cNvPr id="5" name="TextBox 4"/>
           <p:cNvSpPr txBox="1"/>
           <p:nvPr/>
         </p:nvSpPr>
         <p:spPr>
           <a:xfrm>
-            <a:off x="1371600" y="1371600"/>
-            <a:ext cx="9448495" cy="4114800"/>
+            <a:off x="914400" y="1554480"/>
+            <a:ext cx="10362895" cy="4572000"/>
           </a:xfrm>
           <a:prstGeom prst="rect">
             <a:avLst/>
@@ -3329,16 +3418,559 @@
           <a:p>
             <a:pPr>
               <a:spcAft>
-                <a:spcPts val="1400"/>
-              </a:spcAft>
-              <a:defRPr sz="4000" b="1">
+                <a:spcPts val="1200"/>
+              </a:spcAft>
+              <a:defRPr sz="1800" b="1">
+                <a:solidFill>
+                  <a:srgbClr val="38BDF8"/>
+                </a:solidFill>
+              </a:defRPr>
+            </a:pPr>
+            <a:r>
+              <a:t>🌐 Headless OpenAPI Endpoints &amp; Integration</a:t>
+            </a:r>
+          </a:p>
+          <a:p>
+            <a:pPr>
+              <a:spcAft>
+                <a:spcPts val="200"/>
+              </a:spcAft>
+              <a:defRPr sz="1400" b="1">
                 <a:solidFill>
                   <a:srgbClr val="34D399"/>
                 </a:solidFill>
               </a:defRPr>
             </a:pPr>
             <a:r>
-              <a:t>🎓 Thank You!</a:t>
+              <a:t>• GET /:</a:t>
+            </a:r>
+          </a:p>
+          <a:p>
+            <a:pPr>
+              <a:spcAft>
+                <a:spcPts val="1000"/>
+              </a:spcAft>
+              <a:defRPr sz="1200">
+                <a:solidFill>
+                  <a:srgbClr val="CBD5E1"/>
+                </a:solidFill>
+              </a:defRPr>
+            </a:pPr>
+            <a:r>
+              <a:t>    Root health-check endpoint returning service status, project name, and API documentation link.</a:t>
+            </a:r>
+          </a:p>
+          <a:p>
+            <a:pPr>
+              <a:spcAft>
+                <a:spcPts val="200"/>
+              </a:spcAft>
+              <a:defRPr sz="1400" b="1">
+                <a:solidFill>
+                  <a:srgbClr val="34D399"/>
+                </a:solidFill>
+              </a:defRPr>
+            </a:pPr>
+            <a:r>
+              <a:t>• GET /docs:</a:t>
+            </a:r>
+          </a:p>
+          <a:p>
+            <a:pPr>
+              <a:spcAft>
+                <a:spcPts val="1000"/>
+              </a:spcAft>
+              <a:defRPr sz="1200">
+                <a:solidFill>
+                  <a:srgbClr val="CBD5E1"/>
+                </a:solidFill>
+              </a:defRPr>
+            </a:pPr>
+            <a:r>
+              <a:t>    Interactive Swagger UI documentation generated automatically by FastAPI for testing endpoints.</a:t>
+            </a:r>
+          </a:p>
+          <a:p>
+            <a:pPr>
+              <a:spcAft>
+                <a:spcPts val="200"/>
+              </a:spcAft>
+              <a:defRPr sz="1400" b="1">
+                <a:solidFill>
+                  <a:srgbClr val="34D399"/>
+                </a:solidFill>
+              </a:defRPr>
+            </a:pPr>
+            <a:r>
+              <a:t>• POST /api/v1/parse-resume:</a:t>
+            </a:r>
+          </a:p>
+          <a:p>
+            <a:pPr>
+              <a:spcAft>
+                <a:spcPts val="1000"/>
+              </a:spcAft>
+              <a:defRPr sz="1200">
+                <a:solidFill>
+                  <a:srgbClr val="CBD5E1"/>
+                </a:solidFill>
+              </a:defRPr>
+            </a:pPr>
+            <a:r>
+              <a:t>    Accepts PDF/DOCX file upload as multipart/form-data. Returns extracted raw text, text length, and clean contact audit JSON.</a:t>
+            </a:r>
+          </a:p>
+          <a:p>
+            <a:pPr>
+              <a:spcAft>
+                <a:spcPts val="200"/>
+              </a:spcAft>
+              <a:defRPr sz="1400" b="1">
+                <a:solidFill>
+                  <a:srgbClr val="34D399"/>
+                </a:solidFill>
+              </a:defRPr>
+            </a:pPr>
+            <a:r>
+              <a:t>• POST /api/v1/analyze-match:</a:t>
+            </a:r>
+          </a:p>
+          <a:p>
+            <a:pPr>
+              <a:spcAft>
+                <a:spcPts val="1000"/>
+              </a:spcAft>
+              <a:defRPr sz="1200">
+                <a:solidFill>
+                  <a:srgbClr val="CBD5E1"/>
+                </a:solidFill>
+              </a:defRPr>
+            </a:pPr>
+            <a:r>
+              <a:t>    Accepts JSON payload (resume_text + jd_text). Calculates composite ATS score, SBERT match, skill coverage, missing skills, logs to SQLite database, and returns structured JSON response.</a:t>
+            </a:r>
+          </a:p>
+        </p:txBody>
+      </p:sp>
+    </p:spTree>
+  </p:cSld>
+  <p:clrMapOvr>
+    <a:masterClrMapping/>
+  </p:clrMapOvr>
+</p:sld>
+</file>
+
+<file path=ppt/slides/slide11.xml><?xml version="1.0" encoding="utf-8"?>
+<p:sld xmlns:a="http://schemas.openxmlformats.org/drawingml/2006/main" xmlns:p="http://schemas.openxmlformats.org/presentationml/2006/main" xmlns:r="http://schemas.openxmlformats.org/officeDocument/2006/relationships">
+  <p:cSld>
+    <p:bg>
+      <p:bgPr>
+        <a:solidFill>
+          <a:srgbClr val="030712"/>
+        </a:solidFill>
+        <a:effectLst/>
+      </p:bgPr>
+    </p:bg>
+    <p:spTree>
+      <p:nvGrpSpPr>
+        <p:cNvPr id="1" name=""/>
+        <p:cNvGrpSpPr/>
+        <p:nvPr/>
+      </p:nvGrpSpPr>
+      <p:grpSpPr/>
+      <p:sp>
+        <p:nvSpPr>
+          <p:cNvPr id="2" name="TextBox 1"/>
+          <p:cNvSpPr txBox="1"/>
+          <p:nvPr/>
+        </p:nvSpPr>
+        <p:spPr>
+          <a:xfrm>
+            <a:off x="731520" y="320040"/>
+            <a:ext cx="10058400" cy="320040"/>
+          </a:xfrm>
+          <a:prstGeom prst="rect">
+            <a:avLst/>
+          </a:prstGeom>
+          <a:noFill/>
+        </p:spPr>
+        <p:txBody>
+          <a:bodyPr wrap="none">
+            <a:spAutoFit/>
+          </a:bodyPr>
+          <a:lstStyle/>
+          <a:p>
+            <a:pPr>
+              <a:defRPr sz="1100" b="1">
+                <a:solidFill>
+                  <a:srgbClr val="818CF8"/>
+                </a:solidFill>
+              </a:defRPr>
+            </a:pPr>
+            <a:r>
+              <a:t>HIRELENS MINOR PROJECT 1</a:t>
+            </a:r>
+          </a:p>
+        </p:txBody>
+      </p:sp>
+      <p:sp>
+        <p:nvSpPr>
+          <p:cNvPr id="3" name="TextBox 2"/>
+          <p:cNvSpPr txBox="1"/>
+          <p:nvPr/>
+        </p:nvSpPr>
+        <p:spPr>
+          <a:xfrm>
+            <a:off x="731520" y="594360"/>
+            <a:ext cx="10515600" cy="640080"/>
+          </a:xfrm>
+          <a:prstGeom prst="rect">
+            <a:avLst/>
+          </a:prstGeom>
+          <a:noFill/>
+        </p:spPr>
+        <p:txBody>
+          <a:bodyPr wrap="none">
+            <a:spAutoFit/>
+          </a:bodyPr>
+          <a:lstStyle/>
+          <a:p>
+            <a:pPr>
+              <a:defRPr sz="2400" b="1">
+                <a:solidFill>
+                  <a:srgbClr val="FFFFFF"/>
+                </a:solidFill>
+              </a:defRPr>
+            </a:pPr>
+            <a:r>
+              <a:t>Experimental Evaluation &amp; Sample Demonstration</a:t>
+            </a:r>
+          </a:p>
+        </p:txBody>
+      </p:sp>
+      <p:sp>
+        <p:nvSpPr>
+          <p:cNvPr id="4" name="Rectangle 3"/>
+          <p:cNvSpPr/>
+          <p:nvPr/>
+        </p:nvSpPr>
+        <p:spPr>
+          <a:xfrm>
+            <a:off x="731520" y="1371600"/>
+            <a:ext cx="10728655" cy="4937760"/>
+          </a:xfrm>
+          <a:prstGeom prst="rect">
+            <a:avLst/>
+          </a:prstGeom>
+          <a:solidFill>
+            <a:srgbClr val="0F172A"/>
+          </a:solidFill>
+          <a:ln w="19050">
+            <a:solidFill>
+              <a:srgbClr val="34D399"/>
+            </a:solidFill>
+          </a:ln>
+        </p:spPr>
+        <p:style>
+          <a:lnRef idx="1">
+            <a:schemeClr val="accent1"/>
+          </a:lnRef>
+          <a:fillRef idx="3">
+            <a:schemeClr val="accent1"/>
+          </a:fillRef>
+          <a:effectRef idx="2">
+            <a:schemeClr val="accent1"/>
+          </a:effectRef>
+          <a:fontRef idx="minor">
+            <a:schemeClr val="lt1"/>
+          </a:fontRef>
+        </p:style>
+        <p:txBody>
+          <a:bodyPr rtlCol="0" anchor="ctr"/>
+          <a:lstStyle/>
+          <a:p>
+            <a:pPr algn="ctr"/>
+          </a:p>
+        </p:txBody>
+      </p:sp>
+      <p:sp>
+        <p:nvSpPr>
+          <p:cNvPr id="5" name="TextBox 4"/>
+          <p:cNvSpPr txBox="1"/>
+          <p:nvPr/>
+        </p:nvSpPr>
+        <p:spPr>
+          <a:xfrm>
+            <a:off x="914400" y="1554480"/>
+            <a:ext cx="10362895" cy="4572000"/>
+          </a:xfrm>
+          <a:prstGeom prst="rect">
+            <a:avLst/>
+          </a:prstGeom>
+          <a:noFill/>
+        </p:spPr>
+        <p:txBody>
+          <a:bodyPr wrap="square">
+            <a:spAutoFit/>
+          </a:bodyPr>
+          <a:lstStyle/>
+          <a:p>
+            <a:pPr>
+              <a:spcAft>
+                <a:spcPts val="1200"/>
+              </a:spcAft>
+              <a:defRPr sz="1800" b="1">
+                <a:solidFill>
+                  <a:srgbClr val="34D399"/>
+                </a:solidFill>
+              </a:defRPr>
+            </a:pPr>
+            <a:r>
+              <a:t>📊 Real-World Evaluation Output (ML Engineer Role)</a:t>
+            </a:r>
+          </a:p>
+          <a:p>
+            <a:pPr>
+              <a:spcAft>
+                <a:spcPts val="600"/>
+              </a:spcAft>
+              <a:defRPr sz="1300">
+                <a:solidFill>
+                  <a:srgbClr val="FFFFFF"/>
+                </a:solidFill>
+              </a:defRPr>
+            </a:pPr>
+            <a:r>
+              <a:t>• Candidate Name &amp; Contact:  Alex (Email: alex.dev@gmail.com | Phone: +91-7058291048)</a:t>
+            </a:r>
+          </a:p>
+          <a:p>
+            <a:pPr>
+              <a:spcAft>
+                <a:spcPts val="600"/>
+              </a:spcAft>
+              <a:defRPr sz="1300">
+                <a:solidFill>
+                  <a:srgbClr val="FFFFFF"/>
+                </a:solidFill>
+              </a:defRPr>
+            </a:pPr>
+            <a:r>
+              <a:t>• Target Job Title:  Machine Learning Engineer</a:t>
+            </a:r>
+          </a:p>
+          <a:p>
+            <a:pPr>
+              <a:spcAft>
+                <a:spcPts val="600"/>
+              </a:spcAft>
+              <a:defRPr sz="1300">
+                <a:solidFill>
+                  <a:srgbClr val="FFFFFF"/>
+                </a:solidFill>
+              </a:defRPr>
+            </a:pPr>
+            <a:r>
+              <a:t>• Final Composite ATS Score:  87.5%  [Grade: Exceptional Fit]</a:t>
+            </a:r>
+          </a:p>
+          <a:p>
+            <a:pPr>
+              <a:spcAft>
+                <a:spcPts val="600"/>
+              </a:spcAft>
+              <a:defRPr sz="1300">
+                <a:solidFill>
+                  <a:srgbClr val="FFFFFF"/>
+                </a:solidFill>
+              </a:defRPr>
+            </a:pPr>
+            <a:r>
+              <a:t>• SBERT Semantic Match:  84.3%  (Dense 384D Vector Cosine Distance)</a:t>
+            </a:r>
+          </a:p>
+          <a:p>
+            <a:pPr>
+              <a:spcAft>
+                <a:spcPts val="600"/>
+              </a:spcAft>
+              <a:defRPr sz="1300">
+                <a:solidFill>
+                  <a:srgbClr val="FFFFFF"/>
+                </a:solidFill>
+              </a:defRPr>
+            </a:pPr>
+            <a:r>
+              <a:t>• Skill Coverage Ratio:  90.0%  (9 Matched Technical Skills / 10 Required)</a:t>
+            </a:r>
+          </a:p>
+          <a:p>
+            <a:pPr>
+              <a:spcAft>
+                <a:spcPts val="600"/>
+              </a:spcAft>
+              <a:defRPr sz="1300">
+                <a:solidFill>
+                  <a:srgbClr val="FFFFFF"/>
+                </a:solidFill>
+              </a:defRPr>
+            </a:pPr>
+            <a:r>
+              <a:t>• TF-IDF Keyword Similarity:  89.2%  (Term Frequency Matrix Similarity)</a:t>
+            </a:r>
+          </a:p>
+          <a:p>
+            <a:pPr>
+              <a:spcAft>
+                <a:spcPts val="600"/>
+              </a:spcAft>
+              <a:defRPr sz="1300">
+                <a:solidFill>
+                  <a:srgbClr val="FFFFFF"/>
+                </a:solidFill>
+              </a:defRPr>
+            </a:pPr>
+            <a:r>
+              <a:t>• Matched Competencies:  Python, PyTorch, TensorFlow, Scikit-Learn, Docker, Kubernetes, AWS, Git, SQL</a:t>
+            </a:r>
+          </a:p>
+          <a:p>
+            <a:pPr>
+              <a:spcAft>
+                <a:spcPts val="600"/>
+              </a:spcAft>
+              <a:defRPr sz="1300">
+                <a:solidFill>
+                  <a:srgbClr val="FFFFFF"/>
+                </a:solidFill>
+              </a:defRPr>
+            </a:pPr>
+            <a:r>
+              <a:t>• Missing Skill Alert:  MLflow (Flagged by AI recommendation engine for optimization)</a:t>
+            </a:r>
+          </a:p>
+        </p:txBody>
+      </p:sp>
+    </p:spTree>
+  </p:cSld>
+  <p:clrMapOvr>
+    <a:masterClrMapping/>
+  </p:clrMapOvr>
+</p:sld>
+</file>
+
+<file path=ppt/slides/slide12.xml><?xml version="1.0" encoding="utf-8"?>
+<p:sld xmlns:a="http://schemas.openxmlformats.org/drawingml/2006/main" xmlns:p="http://schemas.openxmlformats.org/presentationml/2006/main" xmlns:r="http://schemas.openxmlformats.org/officeDocument/2006/relationships">
+  <p:cSld>
+    <p:bg>
+      <p:bgPr>
+        <a:solidFill>
+          <a:srgbClr val="030712"/>
+        </a:solidFill>
+        <a:effectLst/>
+      </p:bgPr>
+    </p:bg>
+    <p:spTree>
+      <p:nvGrpSpPr>
+        <p:cNvPr id="1" name=""/>
+        <p:cNvGrpSpPr/>
+        <p:nvPr/>
+      </p:nvGrpSpPr>
+      <p:grpSpPr/>
+      <p:sp>
+        <p:nvSpPr>
+          <p:cNvPr id="2" name="Rectangle 1"/>
+          <p:cNvSpPr/>
+          <p:nvPr/>
+        </p:nvSpPr>
+        <p:spPr>
+          <a:xfrm>
+            <a:off x="731520" y="731520"/>
+            <a:ext cx="10728655" cy="5394960"/>
+          </a:xfrm>
+          <a:prstGeom prst="rect">
+            <a:avLst/>
+          </a:prstGeom>
+          <a:solidFill>
+            <a:srgbClr val="0F172A"/>
+          </a:solidFill>
+          <a:ln w="25400">
+            <a:solidFill>
+              <a:srgbClr val="34D399"/>
+            </a:solidFill>
+          </a:ln>
+        </p:spPr>
+        <p:style>
+          <a:lnRef idx="1">
+            <a:schemeClr val="accent1"/>
+          </a:lnRef>
+          <a:fillRef idx="3">
+            <a:schemeClr val="accent1"/>
+          </a:fillRef>
+          <a:effectRef idx="2">
+            <a:schemeClr val="accent1"/>
+          </a:effectRef>
+          <a:fontRef idx="minor">
+            <a:schemeClr val="lt1"/>
+          </a:fontRef>
+        </p:style>
+        <p:txBody>
+          <a:bodyPr rtlCol="0" anchor="ctr"/>
+          <a:lstStyle/>
+          <a:p>
+            <a:pPr algn="ctr"/>
+          </a:p>
+        </p:txBody>
+      </p:sp>
+      <p:sp>
+        <p:nvSpPr>
+          <p:cNvPr id="3" name="TextBox 2"/>
+          <p:cNvSpPr txBox="1"/>
+          <p:nvPr/>
+        </p:nvSpPr>
+        <p:spPr>
+          <a:xfrm>
+            <a:off x="1097280" y="1005840"/>
+            <a:ext cx="10058400" cy="4846320"/>
+          </a:xfrm>
+          <a:prstGeom prst="rect">
+            <a:avLst/>
+          </a:prstGeom>
+          <a:noFill/>
+        </p:spPr>
+        <p:txBody>
+          <a:bodyPr wrap="square">
+            <a:spAutoFit/>
+          </a:bodyPr>
+          <a:lstStyle/>
+          <a:p>
+            <a:pPr>
+              <a:spcAft>
+                <a:spcPts val="1000"/>
+              </a:spcAft>
+              <a:defRPr sz="3200" b="1">
+                <a:solidFill>
+                  <a:srgbClr val="34D399"/>
+                </a:solidFill>
+              </a:defRPr>
+            </a:pPr>
+            <a:r>
+              <a:t>🎓 Conclusion &amp; Future Scope</a:t>
+            </a:r>
+          </a:p>
+          <a:p>
+            <a:pPr>
+              <a:spcAft>
+                <a:spcPts val="1600"/>
+              </a:spcAft>
+              <a:defRPr sz="1400">
+                <a:solidFill>
+                  <a:srgbClr val="FFFFFF"/>
+                </a:solidFill>
+              </a:defRPr>
+            </a:pPr>
+            <a:r>
+              <a:t>HireLens delivers a transparent, AI-driven ATS screening system combining Transformer semantics, skill taxonomy matching, and explainable feedback.</a:t>
             </a:r>
           </a:p>
           <a:p>
@@ -3346,19 +3978,31 @@
               <a:spcAft>
                 <a:spcPts val="2000"/>
               </a:spcAft>
-              <a:defRPr sz="2000" b="1">
-                <a:solidFill>
-                  <a:srgbClr val="FFFFFF"/>
-                </a:solidFill>
-              </a:defRPr>
-            </a:pPr>
-            <a:r>
-              <a:t>HireLens: AI-Powered Resume Screening, Skill Gap Analysis &amp; Job Matching System</a:t>
-            </a:r>
-          </a:p>
-          <a:p>
-            <a:pPr>
-              <a:defRPr sz="1400">
+              <a:defRPr sz="1300">
+                <a:solidFill>
+                  <a:srgbClr val="38BDF8"/>
+                </a:solidFill>
+              </a:defRPr>
+            </a:pPr>
+            <a:r>
+              <a:t>🚀 Future Roadmap:</a:t>
+            </a:r>
+            <a:br/>
+            <a:r>
+              <a:t>• Domain Fine-Tuning SBERT on 100k+ technical IT resumes.</a:t>
+            </a:r>
+            <a:br/>
+            <a:r>
+              <a:t>• LLM Bullet Point Rewriter using Llama-3 / Gemini models.</a:t>
+            </a:r>
+            <a:br/>
+            <a:r>
+              <a:t>• Enterprise HRMS Connectors for Workday, Greenhouse &amp; Lever.</a:t>
+            </a:r>
+          </a:p>
+          <a:p>
+            <a:pPr>
+              <a:defRPr sz="1300" b="1">
                 <a:solidFill>
                   <a:srgbClr val="818CF8"/>
                 </a:solidFill>
@@ -3369,15 +4013,15 @@
             </a:r>
             <a:br/>
             <a:r>
-              <a:t>🏛️ Panipat Institute of Engineering &amp; Technology (PIET)</a:t>
+              <a:t>🏛️ Institution: Panipat Institute of Engineering &amp; Technology (PIET)</a:t>
             </a:r>
             <a:br/>
             <a:r>
-              <a:t>🌐 GitHub: https://github.com/Aryan8182/Hirelens-ai-resume-analyzer</a:t>
+              <a:t>🚀 Live Demo App: https://aryan8182-hirelens-ai-resume-analyzer-app-p2fpgo.streamlit.app/</a:t>
             </a:r>
             <a:br/>
             <a:r>
-              <a:t>🚀 Live Demo App: https://aryan8182-hirelens-ai-resume-analyzer-app-p2fpgo.streamlit.app/</a:t>
+              <a:t>🔗 GitHub Repository: https://github.com/Aryan8182/Hirelens-ai-resume-analyzer</a:t>
             </a:r>
           </a:p>
         </p:txBody>
@@ -3416,8 +4060,8 @@
         </p:nvSpPr>
         <p:spPr>
           <a:xfrm>
-            <a:off x="731520" y="365760"/>
-            <a:ext cx="10058400" cy="365760"/>
+            <a:off x="731520" y="320040"/>
+            <a:ext cx="10058400" cy="320040"/>
           </a:xfrm>
           <a:prstGeom prst="rect">
             <a:avLst/>
@@ -3451,8 +4095,8 @@
         </p:nvSpPr>
         <p:spPr>
           <a:xfrm>
-            <a:off x="731520" y="640080"/>
-            <a:ext cx="10515600" cy="731520"/>
+            <a:off x="731520" y="594360"/>
+            <a:ext cx="10515600" cy="640080"/>
           </a:xfrm>
           <a:prstGeom prst="rect">
             <a:avLst/>
@@ -3466,14 +4110,14 @@
           <a:lstStyle/>
           <a:p>
             <a:pPr>
-              <a:defRPr sz="2600" b="1">
+              <a:defRPr sz="2400" b="1">
                 <a:solidFill>
                   <a:srgbClr val="FFFFFF"/>
                 </a:solidFill>
               </a:defRPr>
             </a:pPr>
             <a:r>
-              <a:t>Introduction &amp; Problem Statement</a:t>
+              <a:t>Industry Background &amp; Problem Statement</a:t>
             </a:r>
           </a:p>
         </p:txBody>
@@ -3486,8 +4130,8 @@
         </p:nvSpPr>
         <p:spPr>
           <a:xfrm>
-            <a:off x="731520" y="1463040"/>
-            <a:ext cx="5120640" cy="4754880"/>
+            <a:off x="731520" y="1371600"/>
+            <a:ext cx="5120640" cy="4937760"/>
           </a:xfrm>
           <a:prstGeom prst="rect">
             <a:avLst/>
@@ -3531,8 +4175,8 @@
         </p:nvSpPr>
         <p:spPr>
           <a:xfrm>
-            <a:off x="914400" y="1645920"/>
-            <a:ext cx="4754880" cy="4389120"/>
+            <a:off x="914400" y="1554480"/>
+            <a:ext cx="4754880" cy="4572000"/>
           </a:xfrm>
           <a:prstGeom prst="rect">
             <a:avLst/>
@@ -3547,76 +4191,76 @@
           <a:p>
             <a:pPr>
               <a:spcAft>
-                <a:spcPts val="1400"/>
-              </a:spcAft>
-              <a:defRPr sz="1800" b="1">
+                <a:spcPts val="1000"/>
+              </a:spcAft>
+              <a:defRPr sz="1700" b="1">
                 <a:solidFill>
                   <a:srgbClr val="F472B6"/>
                 </a:solidFill>
               </a:defRPr>
             </a:pPr>
             <a:r>
-              <a:t>⚠️ Challenges in Modern Recruitment</a:t>
-            </a:r>
-          </a:p>
-          <a:p>
-            <a:pPr>
-              <a:spcAft>
-                <a:spcPts val="1000"/>
-              </a:spcAft>
-              <a:defRPr sz="1300">
+              <a:t>⚠️ Limitations of Traditional ATS Software</a:t>
+            </a:r>
+          </a:p>
+          <a:p>
+            <a:pPr>
+              <a:spcAft>
+                <a:spcPts val="800"/>
+              </a:spcAft>
+              <a:defRPr sz="1200">
                 <a:solidFill>
                   <a:srgbClr val="CBD5E1"/>
                 </a:solidFill>
               </a:defRPr>
             </a:pPr>
             <a:r>
-              <a:t>• High Application Volume: Recruiters receive 250+ resumes per job posting.</a:t>
-            </a:r>
-          </a:p>
-          <a:p>
-            <a:pPr>
-              <a:spcAft>
-                <a:spcPts val="1000"/>
-              </a:spcAft>
-              <a:defRPr sz="1300">
+              <a:t>• Mass Application Overload: Recruiters receive 250+ resumes per job posting.</a:t>
+            </a:r>
+          </a:p>
+          <a:p>
+            <a:pPr>
+              <a:spcAft>
+                <a:spcPts val="800"/>
+              </a:spcAft>
+              <a:defRPr sz="1200">
                 <a:solidFill>
                   <a:srgbClr val="CBD5E1"/>
                 </a:solidFill>
               </a:defRPr>
             </a:pPr>
             <a:r>
-              <a:t>• Keyword Inflexibility: Traditional ATS tools use rigid exact-string matching.</a:t>
-            </a:r>
-          </a:p>
-          <a:p>
-            <a:pPr>
-              <a:spcAft>
-                <a:spcPts val="1000"/>
-              </a:spcAft>
-              <a:defRPr sz="1300">
+              <a:t>• Rigid Keyword Matching: Traditional tools rely strictly on exact string matching.</a:t>
+            </a:r>
+          </a:p>
+          <a:p>
+            <a:pPr>
+              <a:spcAft>
+                <a:spcPts val="800"/>
+              </a:spcAft>
+              <a:defRPr sz="1200">
                 <a:solidFill>
                   <a:srgbClr val="CBD5E1"/>
                 </a:solidFill>
               </a:defRPr>
             </a:pPr>
             <a:r>
-              <a:t>• False Disqualifications: Candidates writing 'Neural Networks' get 0 score if JD says 'Deep Learning'.</a:t>
-            </a:r>
-          </a:p>
-          <a:p>
-            <a:pPr>
-              <a:spcAft>
-                <a:spcPts val="1000"/>
-              </a:spcAft>
-              <a:defRPr sz="1300">
+              <a:t>• False Negative Rejections: A candidate writing 'Neural Networks' gets 0 score if the job description asks for 'Deep Learning'.</a:t>
+            </a:r>
+          </a:p>
+          <a:p>
+            <a:pPr>
+              <a:spcAft>
+                <a:spcPts val="800"/>
+              </a:spcAft>
+              <a:defRPr sz="1200">
                 <a:solidFill>
                   <a:srgbClr val="CBD5E1"/>
                 </a:solidFill>
               </a:defRPr>
             </a:pPr>
             <a:r>
-              <a:t>• Lack of Transparency: Proprietary black-box algorithms provide zero explainability to job seekers.</a:t>
+              <a:t>• Lack of Transparency: Proprietary black-box algorithms offer zero feedback to candidates on missing skills.</a:t>
             </a:r>
           </a:p>
         </p:txBody>
@@ -3629,8 +4273,8 @@
         </p:nvSpPr>
         <p:spPr>
           <a:xfrm>
-            <a:off x="6217920" y="1463040"/>
-            <a:ext cx="5120640" cy="4754880"/>
+            <a:off x="6217920" y="1371600"/>
+            <a:ext cx="5120640" cy="4937760"/>
           </a:xfrm>
           <a:prstGeom prst="rect">
             <a:avLst/>
@@ -3674,8 +4318,8 @@
         </p:nvSpPr>
         <p:spPr>
           <a:xfrm>
-            <a:off x="6400800" y="1645920"/>
-            <a:ext cx="4754880" cy="4389120"/>
+            <a:off x="6400800" y="1554480"/>
+            <a:ext cx="4754880" cy="4572000"/>
           </a:xfrm>
           <a:prstGeom prst="rect">
             <a:avLst/>
@@ -3690,76 +4334,76 @@
           <a:p>
             <a:pPr>
               <a:spcAft>
-                <a:spcPts val="1400"/>
-              </a:spcAft>
-              <a:defRPr sz="1800" b="1">
+                <a:spcPts val="1000"/>
+              </a:spcAft>
+              <a:defRPr sz="1700" b="1">
                 <a:solidFill>
                   <a:srgbClr val="34D399"/>
                 </a:solidFill>
               </a:defRPr>
             </a:pPr>
             <a:r>
-              <a:t>✨ The HireLens AI Solution</a:t>
-            </a:r>
-          </a:p>
-          <a:p>
-            <a:pPr>
-              <a:spcAft>
-                <a:spcPts val="1000"/>
-              </a:spcAft>
-              <a:defRPr sz="1300">
+              <a:t>💡 The HireLens AI Solution</a:t>
+            </a:r>
+          </a:p>
+          <a:p>
+            <a:pPr>
+              <a:spcAft>
+                <a:spcPts val="800"/>
+              </a:spcAft>
+              <a:defRPr sz="1200">
                 <a:solidFill>
                   <a:srgbClr val="CBD5E1"/>
                 </a:solidFill>
               </a:defRPr>
             </a:pPr>
             <a:r>
-              <a:t>• Deep Semantic Vectors: Sentence-Transformers (all-MiniLM-L6-v2) for context matching.</a:t>
-            </a:r>
-          </a:p>
-          <a:p>
-            <a:pPr>
-              <a:spcAft>
-                <a:spcPts val="1000"/>
-              </a:spcAft>
-              <a:defRPr sz="1300">
+              <a:t>• Dense Semantic Embeddings: Uses Sentence-Transformers (all-MiniLM-L6-v2) for deep contextual meaning matching.</a:t>
+            </a:r>
+          </a:p>
+          <a:p>
+            <a:pPr>
+              <a:spcAft>
+                <a:spcPts val="800"/>
+              </a:spcAft>
+              <a:defRPr sz="1200">
                 <a:solidFill>
                   <a:srgbClr val="CBD5E1"/>
                 </a:solidFill>
               </a:defRPr>
             </a:pPr>
             <a:r>
-              <a:t>• 7-Domain NLP Taxonomy: Multi-domain technical &amp; soft skill coverage analysis.</a:t>
-            </a:r>
-          </a:p>
-          <a:p>
-            <a:pPr>
-              <a:spcAft>
-                <a:spcPts val="1000"/>
-              </a:spcAft>
-              <a:defRPr sz="1300">
+              <a:t>• 7-Domain NLP Taxonomy: Automatically extracts and maps hard technical and soft skill competencies.</a:t>
+            </a:r>
+          </a:p>
+          <a:p>
+            <a:pPr>
+              <a:spcAft>
+                <a:spcPts val="800"/>
+              </a:spcAft>
+              <a:defRPr sz="1200">
                 <a:solidFill>
                   <a:srgbClr val="CBD5E1"/>
                 </a:solidFill>
               </a:defRPr>
             </a:pPr>
             <a:r>
-              <a:t>• Hybrid ATS Scoring: Weighted fusion of SBERT, Skill Coverage, and TF-IDF similarity.</a:t>
-            </a:r>
-          </a:p>
-          <a:p>
-            <a:pPr>
-              <a:spcAft>
-                <a:spcPts val="1000"/>
-              </a:spcAft>
-              <a:defRPr sz="1300">
+              <a:t>• Hybrid Weighted Scoring: Fuses SBERT (45%), Skill Coverage (35%), and TF-IDF term frequency (20%).</a:t>
+            </a:r>
+          </a:p>
+          <a:p>
+            <a:pPr>
+              <a:spcAft>
+                <a:spcPts val="800"/>
+              </a:spcAft>
+              <a:defRPr sz="1200">
                 <a:solidFill>
                   <a:srgbClr val="CBD5E1"/>
                 </a:solidFill>
               </a:defRPr>
             </a:pPr>
             <a:r>
-              <a:t>• Actionable Feedback: Missing keyword detection &amp; interactive Streamlit web dashboard.</a:t>
+              <a:t>• Explainable AI Feedback: Displays matched/missing skill gap analysis and formatting recommendations.</a:t>
             </a:r>
           </a:p>
         </p:txBody>
@@ -3798,8 +4442,8 @@
         </p:nvSpPr>
         <p:spPr>
           <a:xfrm>
-            <a:off x="731520" y="365760"/>
-            <a:ext cx="10058400" cy="365760"/>
+            <a:off x="731520" y="320040"/>
+            <a:ext cx="10058400" cy="320040"/>
           </a:xfrm>
           <a:prstGeom prst="rect">
             <a:avLst/>
@@ -3833,8 +4477,8 @@
         </p:nvSpPr>
         <p:spPr>
           <a:xfrm>
-            <a:off x="731520" y="640080"/>
-            <a:ext cx="10515600" cy="731520"/>
+            <a:off x="731520" y="594360"/>
+            <a:ext cx="10515600" cy="640080"/>
           </a:xfrm>
           <a:prstGeom prst="rect">
             <a:avLst/>
@@ -3848,14 +4492,14 @@
           <a:lstStyle/>
           <a:p>
             <a:pPr>
-              <a:defRPr sz="2600" b="1">
+              <a:defRPr sz="2400" b="1">
                 <a:solidFill>
                   <a:srgbClr val="FFFFFF"/>
                 </a:solidFill>
               </a:defRPr>
             </a:pPr>
             <a:r>
-              <a:t>System Architecture &amp; Processing Pipeline</a:t>
+              <a:t>Project Objectives &amp; Scope of Work</a:t>
             </a:r>
           </a:p>
         </p:txBody>
@@ -3868,8 +4512,8 @@
         </p:nvSpPr>
         <p:spPr>
           <a:xfrm>
-            <a:off x="731520" y="1645920"/>
-            <a:ext cx="2468880" cy="4389120"/>
+            <a:off x="731520" y="1463040"/>
+            <a:ext cx="2468880" cy="4846320"/>
           </a:xfrm>
           <a:prstGeom prst="rect">
             <a:avLst/>
@@ -3913,8 +4557,8 @@
         </p:nvSpPr>
         <p:spPr>
           <a:xfrm>
-            <a:off x="868680" y="1828800"/>
-            <a:ext cx="2194560" cy="4023360"/>
+            <a:off x="868680" y="1645920"/>
+            <a:ext cx="2194560" cy="4480560"/>
           </a:xfrm>
           <a:prstGeom prst="rect">
             <a:avLst/>
@@ -3929,28 +4573,28 @@
           <a:p>
             <a:pPr>
               <a:spcAft>
-                <a:spcPts val="1400"/>
-              </a:spcAft>
-              <a:defRPr sz="1600" b="1">
+                <a:spcPts val="1200"/>
+              </a:spcAft>
+              <a:defRPr sz="1500" b="1">
                 <a:solidFill>
                   <a:srgbClr val="818CF8"/>
                 </a:solidFill>
               </a:defRPr>
             </a:pPr>
             <a:r>
-              <a:t>1. Document Ingestion</a:t>
-            </a:r>
-          </a:p>
-          <a:p>
-            <a:pPr>
-              <a:defRPr sz="1300">
+              <a:t>1. Multi-Format Text Parser</a:t>
+            </a:r>
+          </a:p>
+          <a:p>
+            <a:pPr>
+              <a:defRPr sz="1200">
                 <a:solidFill>
                   <a:srgbClr val="CBD5E1"/>
                 </a:solidFill>
               </a:defRPr>
             </a:pPr>
             <a:r>
-              <a:t>PDF &amp; DOCX parsing via pdfplumber and python-docx text extraction engines.</a:t>
+              <a:t>Extract clean text from PDF (pdfplumber) and DOCX (python-docx) files without losing structured layout data.</a:t>
             </a:r>
           </a:p>
         </p:txBody>
@@ -3963,8 +4607,8 @@
         </p:nvSpPr>
         <p:spPr>
           <a:xfrm>
-            <a:off x="3474720" y="1645920"/>
-            <a:ext cx="2468880" cy="4389120"/>
+            <a:off x="3474720" y="1463040"/>
+            <a:ext cx="2468880" cy="4846320"/>
           </a:xfrm>
           <a:prstGeom prst="rect">
             <a:avLst/>
@@ -4008,8 +4652,8 @@
         </p:nvSpPr>
         <p:spPr>
           <a:xfrm>
-            <a:off x="3611880" y="1828800"/>
-            <a:ext cx="2194560" cy="4023360"/>
+            <a:off x="3611880" y="1645920"/>
+            <a:ext cx="2194560" cy="4480560"/>
           </a:xfrm>
           <a:prstGeom prst="rect">
             <a:avLst/>
@@ -4024,28 +4668,28 @@
           <a:p>
             <a:pPr>
               <a:spcAft>
-                <a:spcPts val="1400"/>
-              </a:spcAft>
-              <a:defRPr sz="1600" b="1">
+                <a:spcPts val="1200"/>
+              </a:spcAft>
+              <a:defRPr sz="1500" b="1">
                 <a:solidFill>
                   <a:srgbClr val="38BDF8"/>
                 </a:solidFill>
               </a:defRPr>
             </a:pPr>
             <a:r>
-              <a:t>2. NLP Entity Mining</a:t>
-            </a:r>
-          </a:p>
-          <a:p>
-            <a:pPr>
-              <a:defRPr sz="1300">
+              <a:t>2. Robust Regex Contact Audit</a:t>
+            </a:r>
+          </a:p>
+          <a:p>
+            <a:pPr>
+              <a:defRPr sz="1200">
                 <a:solidFill>
                   <a:srgbClr val="CBD5E1"/>
                 </a:solidFill>
               </a:defRPr>
             </a:pPr>
             <a:r>
-              <a:t>Non-capturing regex contact extractor (Phone, Email, LinkedIn, GitHub).</a:t>
+              <a:t>Extract candidate email, full 10-13 digit phone numbers (with country codes), LinkedIn, and GitHub profiles using non-capturing regex.</a:t>
             </a:r>
           </a:p>
         </p:txBody>
@@ -4058,8 +4702,8 @@
         </p:nvSpPr>
         <p:spPr>
           <a:xfrm>
-            <a:off x="6217920" y="1645920"/>
-            <a:ext cx="2468880" cy="4389120"/>
+            <a:off x="6217920" y="1463040"/>
+            <a:ext cx="2468880" cy="4846320"/>
           </a:xfrm>
           <a:prstGeom prst="rect">
             <a:avLst/>
@@ -4103,8 +4747,8 @@
         </p:nvSpPr>
         <p:spPr>
           <a:xfrm>
-            <a:off x="6355080" y="1828800"/>
-            <a:ext cx="2194560" cy="4023360"/>
+            <a:off x="6355080" y="1645920"/>
+            <a:ext cx="2194560" cy="4480560"/>
           </a:xfrm>
           <a:prstGeom prst="rect">
             <a:avLst/>
@@ -4119,28 +4763,28 @@
           <a:p>
             <a:pPr>
               <a:spcAft>
-                <a:spcPts val="1400"/>
-              </a:spcAft>
-              <a:defRPr sz="1600" b="1">
+                <a:spcPts val="1200"/>
+              </a:spcAft>
+              <a:defRPr sz="1500" b="1">
                 <a:solidFill>
                   <a:srgbClr val="34D399"/>
                 </a:solidFill>
               </a:defRPr>
             </a:pPr>
             <a:r>
-              <a:t>3. Taxonomy Matching</a:t>
-            </a:r>
-          </a:p>
-          <a:p>
-            <a:pPr>
-              <a:defRPr sz="1300">
+              <a:t>3. SBERT Semantic Matcher</a:t>
+            </a:r>
+          </a:p>
+          <a:p>
+            <a:pPr>
+              <a:defRPr sz="1200">
                 <a:solidFill>
                   <a:srgbClr val="CBD5E1"/>
                 </a:solidFill>
               </a:defRPr>
             </a:pPr>
             <a:r>
-              <a:t>Categorizes candidate skills across 7 technical &amp; soft skill domains.</a:t>
+              <a:t>Convert resumes and job descriptions into 384-dimensional dense vectors to measure true conceptual similarity.</a:t>
             </a:r>
           </a:p>
         </p:txBody>
@@ -4153,8 +4797,8 @@
         </p:nvSpPr>
         <p:spPr>
           <a:xfrm>
-            <a:off x="8961120" y="1645920"/>
-            <a:ext cx="2468880" cy="4389120"/>
+            <a:off x="8961120" y="1463040"/>
+            <a:ext cx="2468880" cy="4846320"/>
           </a:xfrm>
           <a:prstGeom prst="rect">
             <a:avLst/>
@@ -4198,8 +4842,8 @@
         </p:nvSpPr>
         <p:spPr>
           <a:xfrm>
-            <a:off x="9098280" y="1828800"/>
-            <a:ext cx="2194560" cy="4023360"/>
+            <a:off x="9098280" y="1645920"/>
+            <a:ext cx="2194560" cy="4480560"/>
           </a:xfrm>
           <a:prstGeom prst="rect">
             <a:avLst/>
@@ -4214,28 +4858,28 @@
           <a:p>
             <a:pPr>
               <a:spcAft>
-                <a:spcPts val="1400"/>
-              </a:spcAft>
-              <a:defRPr sz="1600" b="1">
+                <a:spcPts val="1200"/>
+              </a:spcAft>
+              <a:defRPr sz="1500" b="1">
                 <a:solidFill>
                   <a:srgbClr val="F472B6"/>
                 </a:solidFill>
               </a:defRPr>
             </a:pPr>
             <a:r>
-              <a:t>4. Hybrid ATS Scoring</a:t>
-            </a:r>
-          </a:p>
-          <a:p>
-            <a:pPr>
-              <a:defRPr sz="1300">
+              <a:t>4. Taxonomy &amp; Radar Visuals</a:t>
+            </a:r>
+          </a:p>
+          <a:p>
+            <a:pPr>
+              <a:defRPr sz="1200">
                 <a:solidFill>
                   <a:srgbClr val="CBD5E1"/>
                 </a:solidFill>
               </a:defRPr>
             </a:pPr>
             <a:r>
-              <a:t>Weighted fusion of SBERT (45%), Skill Coverage (35%), and TF-IDF (20%).</a:t>
+              <a:t>Map skills across 7 technical categories and plot interactive polar radar charts comparing candidate vs job requirements.</a:t>
             </a:r>
           </a:p>
         </p:txBody>
@@ -4274,8 +4918,8 @@
         </p:nvSpPr>
         <p:spPr>
           <a:xfrm>
-            <a:off x="731520" y="365760"/>
-            <a:ext cx="10058400" cy="365760"/>
+            <a:off x="731520" y="320040"/>
+            <a:ext cx="10058400" cy="320040"/>
           </a:xfrm>
           <a:prstGeom prst="rect">
             <a:avLst/>
@@ -4309,8 +4953,8 @@
         </p:nvSpPr>
         <p:spPr>
           <a:xfrm>
-            <a:off x="731520" y="640080"/>
-            <a:ext cx="10515600" cy="731520"/>
+            <a:off x="731520" y="594360"/>
+            <a:ext cx="10515600" cy="640080"/>
           </a:xfrm>
           <a:prstGeom prst="rect">
             <a:avLst/>
@@ -4324,14 +4968,14 @@
           <a:lstStyle/>
           <a:p>
             <a:pPr>
-              <a:defRPr sz="2600" b="1">
+              <a:defRPr sz="2400" b="1">
                 <a:solidFill>
                   <a:srgbClr val="FFFFFF"/>
                 </a:solidFill>
               </a:defRPr>
             </a:pPr>
             <a:r>
-              <a:t>Mathematical ATS Formula &amp; SBERT Embeddings</a:t>
+              <a:t>System Architecture &amp; End-to-End Flow</a:t>
             </a:r>
           </a:p>
         </p:txBody>
@@ -4344,8 +4988,8 @@
         </p:nvSpPr>
         <p:spPr>
           <a:xfrm>
-            <a:off x="731520" y="1463040"/>
-            <a:ext cx="10607040" cy="1463040"/>
+            <a:off x="731520" y="1371600"/>
+            <a:ext cx="10728655" cy="4937760"/>
           </a:xfrm>
           <a:prstGeom prst="rect">
             <a:avLst/>
@@ -4353,7 +4997,7 @@
           <a:solidFill>
             <a:srgbClr val="0F172A"/>
           </a:solidFill>
-          <a:ln w="25400">
+          <a:ln w="19050">
             <a:solidFill>
               <a:srgbClr val="818CF8"/>
             </a:solidFill>
@@ -4389,8 +5033,8 @@
         </p:nvSpPr>
         <p:spPr>
           <a:xfrm>
-            <a:off x="914400" y="1600200"/>
-            <a:ext cx="10241280" cy="1188720"/>
+            <a:off x="914400" y="1554480"/>
+            <a:ext cx="10362895" cy="4572000"/>
           </a:xfrm>
           <a:prstGeom prst="rect">
             <a:avLst/>
@@ -4405,117 +5049,67 @@
           <a:p>
             <a:pPr>
               <a:spcAft>
-                <a:spcPts val="600"/>
-              </a:spcAft>
-              <a:defRPr sz="1600" b="1">
+                <a:spcPts val="1400"/>
+              </a:spcAft>
+              <a:defRPr sz="1800" b="1">
                 <a:solidFill>
                   <a:srgbClr val="818CF8"/>
                 </a:solidFill>
               </a:defRPr>
             </a:pPr>
             <a:r>
-              <a:t>📐 Composite ATS Match Formula</a:t>
-            </a:r>
-          </a:p>
-          <a:p>
-            <a:pPr>
-              <a:defRPr sz="1800" b="1">
-                <a:solidFill>
-                  <a:srgbClr val="34D399"/>
-                </a:solidFill>
-              </a:defRPr>
-            </a:pPr>
-            <a:r>
-              <a:t>ATS Score = (0.45 × SBERT Cosine Sim) + (0.35 × Skill Coverage Ratio) + (0.20 × TF-IDF Cosine Sim)</a:t>
-            </a:r>
-          </a:p>
-        </p:txBody>
-      </p:sp>
-      <p:sp>
-        <p:nvSpPr>
-          <p:cNvPr id="6" name="Rectangle 5"/>
-          <p:cNvSpPr/>
-          <p:nvPr/>
-        </p:nvSpPr>
-        <p:spPr>
-          <a:xfrm>
-            <a:off x="731520" y="3200400"/>
-            <a:ext cx="5120640" cy="3108960"/>
-          </a:xfrm>
-          <a:prstGeom prst="rect">
-            <a:avLst/>
-          </a:prstGeom>
-          <a:solidFill>
-            <a:srgbClr val="0F172A"/>
-          </a:solidFill>
-          <a:ln>
-            <a:solidFill>
-              <a:srgbClr val="38BDF8"/>
-            </a:solidFill>
-          </a:ln>
-        </p:spPr>
-        <p:style>
-          <a:lnRef idx="1">
-            <a:schemeClr val="accent1"/>
-          </a:lnRef>
-          <a:fillRef idx="3">
-            <a:schemeClr val="accent1"/>
-          </a:fillRef>
-          <a:effectRef idx="2">
-            <a:schemeClr val="accent1"/>
-          </a:effectRef>
-          <a:fontRef idx="minor">
-            <a:schemeClr val="lt1"/>
-          </a:fontRef>
-        </p:style>
-        <p:txBody>
-          <a:bodyPr rtlCol="0" anchor="ctr"/>
-          <a:lstStyle/>
-          <a:p>
-            <a:pPr algn="ctr"/>
-          </a:p>
-        </p:txBody>
-      </p:sp>
-      <p:sp>
-        <p:nvSpPr>
-          <p:cNvPr id="7" name="TextBox 6"/>
-          <p:cNvSpPr txBox="1"/>
-          <p:nvPr/>
-        </p:nvSpPr>
-        <p:spPr>
-          <a:xfrm>
-            <a:off x="914400" y="3383280"/>
-            <a:ext cx="4754880" cy="2743200"/>
-          </a:xfrm>
-          <a:prstGeom prst="rect">
-            <a:avLst/>
-          </a:prstGeom>
-          <a:noFill/>
-        </p:spPr>
-        <p:txBody>
-          <a:bodyPr wrap="square">
-            <a:spAutoFit/>
-          </a:bodyPr>
-          <a:lstStyle/>
+              <a:t>🔄 4-Stage Architectural Processing Pipeline</a:t>
+            </a:r>
+          </a:p>
+          <a:p>
+            <a:pPr>
+              <a:spcAft>
+                <a:spcPts val="300"/>
+              </a:spcAft>
+              <a:defRPr sz="1400" b="1">
+                <a:solidFill>
+                  <a:srgbClr val="38BDF8"/>
+                </a:solidFill>
+              </a:defRPr>
+            </a:pPr>
+            <a:r>
+              <a:t>🔹 Stage 1: Ingestion &amp; Parsing</a:t>
+            </a:r>
+          </a:p>
           <a:p>
             <a:pPr>
               <a:spcAft>
                 <a:spcPts val="1000"/>
               </a:spcAft>
-              <a:defRPr sz="1600" b="1">
+              <a:defRPr sz="1200">
+                <a:solidFill>
+                  <a:srgbClr val="CBD5E1"/>
+                </a:solidFill>
+              </a:defRPr>
+            </a:pPr>
+            <a:r>
+              <a:t>    Ingests PDF/DOCX resume files and target Job Description text streams using pdfplumber and python-docx.</a:t>
+            </a:r>
+          </a:p>
+          <a:p>
+            <a:pPr>
+              <a:spcAft>
+                <a:spcPts val="300"/>
+              </a:spcAft>
+              <a:defRPr sz="1400" b="1">
                 <a:solidFill>
                   <a:srgbClr val="38BDF8"/>
                 </a:solidFill>
               </a:defRPr>
             </a:pPr>
             <a:r>
-              <a:t>🤖 SBERT Semantic Embeddings (45%)</a:t>
-            </a:r>
-          </a:p>
-          <a:p>
-            <a:pPr>
-              <a:spcAft>
-                <a:spcPts val="600"/>
+              <a:t>🔹 Stage 2: Entity &amp; Contact Mining</a:t>
+            </a:r>
+          </a:p>
+          <a:p>
+            <a:pPr>
+              <a:spcAft>
+                <a:spcPts val="1000"/>
               </a:spcAft>
               <a:defRPr sz="1200">
                 <a:solidFill>
@@ -4524,13 +5118,28 @@
               </a:defRPr>
             </a:pPr>
             <a:r>
-              <a:t>• Model: all-MiniLM-L6-v2 (384-dimensional dense vectors).</a:t>
-            </a:r>
-          </a:p>
-          <a:p>
-            <a:pPr>
-              <a:spcAft>
-                <a:spcPts val="600"/>
+              <a:t>    Runs clean_text preprocessing and non-capturing regex to audit Phone (+91-7058291048), Email, LinkedIn &amp; GitHub profiles.</a:t>
+            </a:r>
+          </a:p>
+          <a:p>
+            <a:pPr>
+              <a:spcAft>
+                <a:spcPts val="300"/>
+              </a:spcAft>
+              <a:defRPr sz="1400" b="1">
+                <a:solidFill>
+                  <a:srgbClr val="38BDF8"/>
+                </a:solidFill>
+              </a:defRPr>
+            </a:pPr>
+            <a:r>
+              <a:t>🔹 Stage 3: Hybrid AI Evaluation Engine</a:t>
+            </a:r>
+          </a:p>
+          <a:p>
+            <a:pPr>
+              <a:spcAft>
+                <a:spcPts val="1000"/>
               </a:spcAft>
               <a:defRPr sz="1200">
                 <a:solidFill>
@@ -4539,13 +5148,28 @@
               </a:defRPr>
             </a:pPr>
             <a:r>
-              <a:t>• Calculates cosine distance in deep vector space.</a:t>
-            </a:r>
-          </a:p>
-          <a:p>
-            <a:pPr>
-              <a:spcAft>
-                <a:spcPts val="600"/>
+              <a:t>    Calculates SBERT vector cosine similarity (45%), 7-category Skill Taxonomy coverage (35%), and TF-IDF matrix similarity (20%).</a:t>
+            </a:r>
+          </a:p>
+          <a:p>
+            <a:pPr>
+              <a:spcAft>
+                <a:spcPts val="300"/>
+              </a:spcAft>
+              <a:defRPr sz="1400" b="1">
+                <a:solidFill>
+                  <a:srgbClr val="38BDF8"/>
+                </a:solidFill>
+              </a:defRPr>
+            </a:pPr>
+            <a:r>
+              <a:t>🔹 Stage 4: Streamlit Dashboard &amp; Database</a:t>
+            </a:r>
+          </a:p>
+          <a:p>
+            <a:pPr>
+              <a:spcAft>
+                <a:spcPts val="1000"/>
               </a:spcAft>
               <a:defRPr sz="1200">
                 <a:solidFill>
@@ -4554,135 +5178,7 @@
               </a:defRPr>
             </a:pPr>
             <a:r>
-              <a:t>• Understands context &amp; synonyms (e.g. PyTorch ≈ Deep Learning).</a:t>
-            </a:r>
-          </a:p>
-        </p:txBody>
-      </p:sp>
-      <p:sp>
-        <p:nvSpPr>
-          <p:cNvPr id="8" name="Rectangle 7"/>
-          <p:cNvSpPr/>
-          <p:nvPr/>
-        </p:nvSpPr>
-        <p:spPr>
-          <a:xfrm>
-            <a:off x="6217920" y="3200400"/>
-            <a:ext cx="5120640" cy="3108960"/>
-          </a:xfrm>
-          <a:prstGeom prst="rect">
-            <a:avLst/>
-          </a:prstGeom>
-          <a:solidFill>
-            <a:srgbClr val="0F172A"/>
-          </a:solidFill>
-          <a:ln>
-            <a:solidFill>
-              <a:srgbClr val="F472B6"/>
-            </a:solidFill>
-          </a:ln>
-        </p:spPr>
-        <p:style>
-          <a:lnRef idx="1">
-            <a:schemeClr val="accent1"/>
-          </a:lnRef>
-          <a:fillRef idx="3">
-            <a:schemeClr val="accent1"/>
-          </a:fillRef>
-          <a:effectRef idx="2">
-            <a:schemeClr val="accent1"/>
-          </a:effectRef>
-          <a:fontRef idx="minor">
-            <a:schemeClr val="lt1"/>
-          </a:fontRef>
-        </p:style>
-        <p:txBody>
-          <a:bodyPr rtlCol="0" anchor="ctr"/>
-          <a:lstStyle/>
-          <a:p>
-            <a:pPr algn="ctr"/>
-          </a:p>
-        </p:txBody>
-      </p:sp>
-      <p:sp>
-        <p:nvSpPr>
-          <p:cNvPr id="9" name="TextBox 8"/>
-          <p:cNvSpPr txBox="1"/>
-          <p:nvPr/>
-        </p:nvSpPr>
-        <p:spPr>
-          <a:xfrm>
-            <a:off x="6400800" y="3383280"/>
-            <a:ext cx="4754880" cy="2743200"/>
-          </a:xfrm>
-          <a:prstGeom prst="rect">
-            <a:avLst/>
-          </a:prstGeom>
-          <a:noFill/>
-        </p:spPr>
-        <p:txBody>
-          <a:bodyPr wrap="square">
-            <a:spAutoFit/>
-          </a:bodyPr>
-          <a:lstStyle/>
-          <a:p>
-            <a:pPr>
-              <a:spcAft>
-                <a:spcPts val="1000"/>
-              </a:spcAft>
-              <a:defRPr sz="1600" b="1">
-                <a:solidFill>
-                  <a:srgbClr val="F472B6"/>
-                </a:solidFill>
-              </a:defRPr>
-            </a:pPr>
-            <a:r>
-              <a:t>📊 Skill Coverage (35%) &amp; TF-IDF (20%)</a:t>
-            </a:r>
-          </a:p>
-          <a:p>
-            <a:pPr>
-              <a:spcAft>
-                <a:spcPts val="600"/>
-              </a:spcAft>
-              <a:defRPr sz="1200">
-                <a:solidFill>
-                  <a:srgbClr val="CBD5E1"/>
-                </a:solidFill>
-              </a:defRPr>
-            </a:pPr>
-            <a:r>
-              <a:t>• Skill Coverage: Ratio of candidate matched skills vs total required skills.</a:t>
-            </a:r>
-          </a:p>
-          <a:p>
-            <a:pPr>
-              <a:spcAft>
-                <a:spcPts val="600"/>
-              </a:spcAft>
-              <a:defRPr sz="1200">
-                <a:solidFill>
-                  <a:srgbClr val="CBD5E1"/>
-                </a:solidFill>
-              </a:defRPr>
-            </a:pPr>
-            <a:r>
-              <a:t>• TF-IDF Vectorizer: Term Frequency-Inverse Document Frequency matrix.</a:t>
-            </a:r>
-          </a:p>
-          <a:p>
-            <a:pPr>
-              <a:spcAft>
-                <a:spcPts val="600"/>
-              </a:spcAft>
-              <a:defRPr sz="1200">
-                <a:solidFill>
-                  <a:srgbClr val="CBD5E1"/>
-                </a:solidFill>
-              </a:defRPr>
-            </a:pPr>
-            <a:r>
-              <a:t>• Verifies exact hard-keyword frequency presence in resume.</a:t>
+              <a:t>    Renders composite ATS match score, Plotly radar chart, missing skill badges, AI advice, and logs record to SQLite database (ats_history.db).</a:t>
             </a:r>
           </a:p>
         </p:txBody>
@@ -4721,8 +5217,8 @@
         </p:nvSpPr>
         <p:spPr>
           <a:xfrm>
-            <a:off x="731520" y="365760"/>
-            <a:ext cx="10058400" cy="365760"/>
+            <a:off x="731520" y="320040"/>
+            <a:ext cx="10058400" cy="320040"/>
           </a:xfrm>
           <a:prstGeom prst="rect">
             <a:avLst/>
@@ -4756,8 +5252,8 @@
         </p:nvSpPr>
         <p:spPr>
           <a:xfrm>
-            <a:off x="731520" y="640080"/>
-            <a:ext cx="10515600" cy="731520"/>
+            <a:off x="731520" y="594360"/>
+            <a:ext cx="10515600" cy="640080"/>
           </a:xfrm>
           <a:prstGeom prst="rect">
             <a:avLst/>
@@ -4771,14 +5267,14 @@
           <a:lstStyle/>
           <a:p>
             <a:pPr>
-              <a:defRPr sz="2600" b="1">
+              <a:defRPr sz="2400" b="1">
                 <a:solidFill>
                   <a:srgbClr val="FFFFFF"/>
                 </a:solidFill>
               </a:defRPr>
             </a:pPr>
             <a:r>
-              <a:t>Multi-Domain Skill Taxonomy Engine</a:t>
+              <a:t>Mathematical ATS Scoring Model</a:t>
             </a:r>
           </a:p>
         </p:txBody>
@@ -4791,8 +5287,8 @@
         </p:nvSpPr>
         <p:spPr>
           <a:xfrm>
-            <a:off x="731520" y="1463040"/>
-            <a:ext cx="10607040" cy="4754880"/>
+            <a:off x="731520" y="1371600"/>
+            <a:ext cx="10728655" cy="1554480"/>
           </a:xfrm>
           <a:prstGeom prst="rect">
             <a:avLst/>
@@ -4800,9 +5296,9 @@
           <a:solidFill>
             <a:srgbClr val="0F172A"/>
           </a:solidFill>
-          <a:ln w="19050">
+          <a:ln w="25400">
             <a:solidFill>
-              <a:srgbClr val="818CF8"/>
+              <a:srgbClr val="34D399"/>
             </a:solidFill>
           </a:ln>
         </p:spPr>
@@ -4836,8 +5332,8 @@
         </p:nvSpPr>
         <p:spPr>
           <a:xfrm>
-            <a:off x="914400" y="1645920"/>
-            <a:ext cx="10241280" cy="4389120"/>
+            <a:off x="914400" y="1508760"/>
+            <a:ext cx="10362895" cy="1280160"/>
           </a:xfrm>
           <a:prstGeom prst="rect">
             <a:avLst/>
@@ -4852,121 +5348,313 @@
           <a:p>
             <a:pPr>
               <a:spcAft>
-                <a:spcPts val="1400"/>
-              </a:spcAft>
+                <a:spcPts val="400"/>
+              </a:spcAft>
+              <a:defRPr sz="1600" b="1">
+                <a:solidFill>
+                  <a:srgbClr val="34D399"/>
+                </a:solidFill>
+              </a:defRPr>
+            </a:pPr>
+            <a:r>
+              <a:t>📐 Composite Match Equation</a:t>
+            </a:r>
+          </a:p>
+          <a:p>
+            <a:pPr>
               <a:defRPr sz="1800" b="1">
                 <a:solidFill>
+                  <a:srgbClr val="FFFFFF"/>
+                </a:solidFill>
+              </a:defRPr>
+            </a:pPr>
+            <a:r>
+              <a:t>ATS Match Score = (0.45 × SBERT Sim) + (0.35 × Skill Coverage Ratio) + (0.20 × TF-IDF Sim)</a:t>
+            </a:r>
+          </a:p>
+        </p:txBody>
+      </p:sp>
+      <p:sp>
+        <p:nvSpPr>
+          <p:cNvPr id="6" name="Rectangle 5"/>
+          <p:cNvSpPr/>
+          <p:nvPr/>
+        </p:nvSpPr>
+        <p:spPr>
+          <a:xfrm>
+            <a:off x="731520" y="3108960"/>
+            <a:ext cx="3413455" cy="3200400"/>
+          </a:xfrm>
+          <a:prstGeom prst="rect">
+            <a:avLst/>
+          </a:prstGeom>
+          <a:solidFill>
+            <a:srgbClr val="0F172A"/>
+          </a:solidFill>
+          <a:ln>
+            <a:solidFill>
+              <a:srgbClr val="818CF8"/>
+            </a:solidFill>
+          </a:ln>
+        </p:spPr>
+        <p:style>
+          <a:lnRef idx="1">
+            <a:schemeClr val="accent1"/>
+          </a:lnRef>
+          <a:fillRef idx="3">
+            <a:schemeClr val="accent1"/>
+          </a:fillRef>
+          <a:effectRef idx="2">
+            <a:schemeClr val="accent1"/>
+          </a:effectRef>
+          <a:fontRef idx="minor">
+            <a:schemeClr val="lt1"/>
+          </a:fontRef>
+        </p:style>
+        <p:txBody>
+          <a:bodyPr rtlCol="0" anchor="ctr"/>
+          <a:lstStyle/>
+          <a:p>
+            <a:pPr algn="ctr"/>
+          </a:p>
+        </p:txBody>
+      </p:sp>
+      <p:sp>
+        <p:nvSpPr>
+          <p:cNvPr id="7" name="TextBox 6"/>
+          <p:cNvSpPr txBox="1"/>
+          <p:nvPr/>
+        </p:nvSpPr>
+        <p:spPr>
+          <a:xfrm>
+            <a:off x="868680" y="3291840"/>
+            <a:ext cx="3108960" cy="2834640"/>
+          </a:xfrm>
+          <a:prstGeom prst="rect">
+            <a:avLst/>
+          </a:prstGeom>
+          <a:noFill/>
+        </p:spPr>
+        <p:txBody>
+          <a:bodyPr wrap="square">
+            <a:spAutoFit/>
+          </a:bodyPr>
+          <a:lstStyle/>
+          <a:p>
+            <a:pPr>
+              <a:spcAft>
+                <a:spcPts val="1000"/>
+              </a:spcAft>
+              <a:defRPr sz="1500" b="1">
+                <a:solidFill>
                   <a:srgbClr val="818CF8"/>
                 </a:solidFill>
               </a:defRPr>
             </a:pPr>
             <a:r>
-              <a:t>🏷️ 7 Standardized Technical &amp; Soft Skill Categories</a:t>
-            </a:r>
-          </a:p>
-          <a:p>
-            <a:pPr>
-              <a:spcAft>
-                <a:spcPts val="600"/>
-              </a:spcAft>
-              <a:defRPr sz="1300" b="0">
-                <a:solidFill>
-                  <a:srgbClr val="FFFFFF"/>
-                </a:solidFill>
-              </a:defRPr>
-            </a:pPr>
-            <a:r>
-              <a:t>• Programming Languages: Python, C++, Java, JavaScript, TypeScript, Go, Rust, R, SQL, Swift</a:t>
-            </a:r>
-          </a:p>
-          <a:p>
-            <a:pPr>
-              <a:spcAft>
-                <a:spcPts val="600"/>
-              </a:spcAft>
-              <a:defRPr sz="1300" b="0">
-                <a:solidFill>
-                  <a:srgbClr val="FFFFFF"/>
-                </a:solidFill>
-              </a:defRPr>
-            </a:pPr>
-            <a:r>
-              <a:t>• Machine Learning &amp; AI: PyTorch, TensorFlow, Scikit-Learn, OpenCV, SpaCy, HuggingFace, RAG, LLM</a:t>
-            </a:r>
-          </a:p>
-          <a:p>
-            <a:pPr>
-              <a:spcAft>
-                <a:spcPts val="600"/>
-              </a:spcAft>
-              <a:defRPr sz="1300" b="0">
-                <a:solidFill>
-                  <a:srgbClr val="FFFFFF"/>
-                </a:solidFill>
-              </a:defRPr>
-            </a:pPr>
-            <a:r>
-              <a:t>• Web Development: React, Node.js, FastAPI, Flask, Django, HTML5, CSS3, Tailwind, REST API</a:t>
-            </a:r>
-          </a:p>
-          <a:p>
-            <a:pPr>
-              <a:spcAft>
-                <a:spcPts val="600"/>
-              </a:spcAft>
-              <a:defRPr sz="1300" b="0">
-                <a:solidFill>
-                  <a:srgbClr val="FFFFFF"/>
-                </a:solidFill>
-              </a:defRPr>
-            </a:pPr>
-            <a:r>
-              <a:t>• Cloud &amp; DevOps: AWS, Azure, GCP, Docker, Kubernetes, CI/CD, Terraform, Linux, Git, GitHub</a:t>
-            </a:r>
-          </a:p>
-          <a:p>
-            <a:pPr>
-              <a:spcAft>
-                <a:spcPts val="600"/>
-              </a:spcAft>
-              <a:defRPr sz="1300" b="0">
-                <a:solidFill>
-                  <a:srgbClr val="FFFFFF"/>
-                </a:solidFill>
-              </a:defRPr>
-            </a:pPr>
-            <a:r>
-              <a:t>• Databases: PostgreSQL, MySQL, MongoDB, Redis, SQLite, Pinecone, ChromaDB</a:t>
-            </a:r>
-          </a:p>
-          <a:p>
-            <a:pPr>
-              <a:spcAft>
-                <a:spcPts val="600"/>
-              </a:spcAft>
-              <a:defRPr sz="1300" b="0">
-                <a:solidFill>
-                  <a:srgbClr val="FFFFFF"/>
-                </a:solidFill>
-              </a:defRPr>
-            </a:pPr>
-            <a:r>
-              <a:t>• Frameworks &amp; Tools: Pandas, NumPy, Matplotlib, Seaborn, Jupyter Notebooks, VS Code, JIRA</a:t>
-            </a:r>
-          </a:p>
-          <a:p>
-            <a:pPr>
-              <a:spcAft>
-                <a:spcPts val="600"/>
-              </a:spcAft>
-              <a:defRPr sz="1300" b="0">
-                <a:solidFill>
-                  <a:srgbClr val="FFFFFF"/>
-                </a:solidFill>
-              </a:defRPr>
-            </a:pPr>
-            <a:r>
-              <a:t>• Soft Skills: Leadership, Problem Solving, Critical Thinking, Communication, Teamwork</a:t>
+              <a:t>SBERT Semantic Match (45%)</a:t>
+            </a:r>
+          </a:p>
+          <a:p>
+            <a:pPr>
+              <a:defRPr sz="1200">
+                <a:solidFill>
+                  <a:srgbClr val="CBD5E1"/>
+                </a:solidFill>
+              </a:defRPr>
+            </a:pPr>
+            <a:r>
+              <a:t>Dense 384D vector cosine similarity between Transformer embeddings u and v.</a:t>
+            </a:r>
+          </a:p>
+        </p:txBody>
+      </p:sp>
+      <p:sp>
+        <p:nvSpPr>
+          <p:cNvPr id="8" name="Rectangle 7"/>
+          <p:cNvSpPr/>
+          <p:nvPr/>
+        </p:nvSpPr>
+        <p:spPr>
+          <a:xfrm>
+            <a:off x="4389120" y="3108960"/>
+            <a:ext cx="3413455" cy="3200400"/>
+          </a:xfrm>
+          <a:prstGeom prst="rect">
+            <a:avLst/>
+          </a:prstGeom>
+          <a:solidFill>
+            <a:srgbClr val="0F172A"/>
+          </a:solidFill>
+          <a:ln>
+            <a:solidFill>
+              <a:srgbClr val="38BDF8"/>
+            </a:solidFill>
+          </a:ln>
+        </p:spPr>
+        <p:style>
+          <a:lnRef idx="1">
+            <a:schemeClr val="accent1"/>
+          </a:lnRef>
+          <a:fillRef idx="3">
+            <a:schemeClr val="accent1"/>
+          </a:fillRef>
+          <a:effectRef idx="2">
+            <a:schemeClr val="accent1"/>
+          </a:effectRef>
+          <a:fontRef idx="minor">
+            <a:schemeClr val="lt1"/>
+          </a:fontRef>
+        </p:style>
+        <p:txBody>
+          <a:bodyPr rtlCol="0" anchor="ctr"/>
+          <a:lstStyle/>
+          <a:p>
+            <a:pPr algn="ctr"/>
+          </a:p>
+        </p:txBody>
+      </p:sp>
+      <p:sp>
+        <p:nvSpPr>
+          <p:cNvPr id="9" name="TextBox 8"/>
+          <p:cNvSpPr txBox="1"/>
+          <p:nvPr/>
+        </p:nvSpPr>
+        <p:spPr>
+          <a:xfrm>
+            <a:off x="4526280" y="3291840"/>
+            <a:ext cx="3108960" cy="2834640"/>
+          </a:xfrm>
+          <a:prstGeom prst="rect">
+            <a:avLst/>
+          </a:prstGeom>
+          <a:noFill/>
+        </p:spPr>
+        <p:txBody>
+          <a:bodyPr wrap="square">
+            <a:spAutoFit/>
+          </a:bodyPr>
+          <a:lstStyle/>
+          <a:p>
+            <a:pPr>
+              <a:spcAft>
+                <a:spcPts val="1000"/>
+              </a:spcAft>
+              <a:defRPr sz="1500" b="1">
+                <a:solidFill>
+                  <a:srgbClr val="38BDF8"/>
+                </a:solidFill>
+              </a:defRPr>
+            </a:pPr>
+            <a:r>
+              <a:t>Skill Coverage Ratio (35%)</a:t>
+            </a:r>
+          </a:p>
+          <a:p>
+            <a:pPr>
+              <a:defRPr sz="1200">
+                <a:solidFill>
+                  <a:srgbClr val="CBD5E1"/>
+                </a:solidFill>
+              </a:defRPr>
+            </a:pPr>
+            <a:r>
+              <a:t>Percentage of matched technical skills vs total required skills: (Matched / Required) × 100</a:t>
+            </a:r>
+          </a:p>
+        </p:txBody>
+      </p:sp>
+      <p:sp>
+        <p:nvSpPr>
+          <p:cNvPr id="10" name="Rectangle 9"/>
+          <p:cNvSpPr/>
+          <p:nvPr/>
+        </p:nvSpPr>
+        <p:spPr>
+          <a:xfrm>
+            <a:off x="8046720" y="3108960"/>
+            <a:ext cx="3413455" cy="3200400"/>
+          </a:xfrm>
+          <a:prstGeom prst="rect">
+            <a:avLst/>
+          </a:prstGeom>
+          <a:solidFill>
+            <a:srgbClr val="0F172A"/>
+          </a:solidFill>
+          <a:ln>
+            <a:solidFill>
+              <a:srgbClr val="F472B6"/>
+            </a:solidFill>
+          </a:ln>
+        </p:spPr>
+        <p:style>
+          <a:lnRef idx="1">
+            <a:schemeClr val="accent1"/>
+          </a:lnRef>
+          <a:fillRef idx="3">
+            <a:schemeClr val="accent1"/>
+          </a:fillRef>
+          <a:effectRef idx="2">
+            <a:schemeClr val="accent1"/>
+          </a:effectRef>
+          <a:fontRef idx="minor">
+            <a:schemeClr val="lt1"/>
+          </a:fontRef>
+        </p:style>
+        <p:txBody>
+          <a:bodyPr rtlCol="0" anchor="ctr"/>
+          <a:lstStyle/>
+          <a:p>
+            <a:pPr algn="ctr"/>
+          </a:p>
+        </p:txBody>
+      </p:sp>
+      <p:sp>
+        <p:nvSpPr>
+          <p:cNvPr id="11" name="TextBox 10"/>
+          <p:cNvSpPr txBox="1"/>
+          <p:nvPr/>
+        </p:nvSpPr>
+        <p:spPr>
+          <a:xfrm>
+            <a:off x="8183880" y="3291840"/>
+            <a:ext cx="3108960" cy="2834640"/>
+          </a:xfrm>
+          <a:prstGeom prst="rect">
+            <a:avLst/>
+          </a:prstGeom>
+          <a:noFill/>
+        </p:spPr>
+        <p:txBody>
+          <a:bodyPr wrap="square">
+            <a:spAutoFit/>
+          </a:bodyPr>
+          <a:lstStyle/>
+          <a:p>
+            <a:pPr>
+              <a:spcAft>
+                <a:spcPts val="1000"/>
+              </a:spcAft>
+              <a:defRPr sz="1500" b="1">
+                <a:solidFill>
+                  <a:srgbClr val="F472B6"/>
+                </a:solidFill>
+              </a:defRPr>
+            </a:pPr>
+            <a:r>
+              <a:t>TF-IDF Matrix Match (20%)</a:t>
+            </a:r>
+          </a:p>
+          <a:p>
+            <a:pPr>
+              <a:defRPr sz="1200">
+                <a:solidFill>
+                  <a:srgbClr val="CBD5E1"/>
+                </a:solidFill>
+              </a:defRPr>
+            </a:pPr>
+            <a:r>
+              <a:t>Term Frequency-Inverse Document Frequency sparse matrix cosine distance for keyword frequency.</a:t>
             </a:r>
           </a:p>
         </p:txBody>
@@ -5005,8 +5693,8 @@
         </p:nvSpPr>
         <p:spPr>
           <a:xfrm>
-            <a:off x="731520" y="365760"/>
-            <a:ext cx="10058400" cy="365760"/>
+            <a:off x="731520" y="320040"/>
+            <a:ext cx="10058400" cy="320040"/>
           </a:xfrm>
           <a:prstGeom prst="rect">
             <a:avLst/>
@@ -5040,8 +5728,8 @@
         </p:nvSpPr>
         <p:spPr>
           <a:xfrm>
-            <a:off x="731520" y="640080"/>
-            <a:ext cx="10515600" cy="731520"/>
+            <a:off x="731520" y="594360"/>
+            <a:ext cx="10515600" cy="640080"/>
           </a:xfrm>
           <a:prstGeom prst="rect">
             <a:avLst/>
@@ -5055,14 +5743,14 @@
           <a:lstStyle/>
           <a:p>
             <a:pPr>
-              <a:defRPr sz="2600" b="1">
+              <a:defRPr sz="2400" b="1">
                 <a:solidFill>
                   <a:srgbClr val="FFFFFF"/>
                 </a:solidFill>
               </a:defRPr>
             </a:pPr>
             <a:r>
-              <a:t>Interactive Dashboard &amp; Key Application Features</a:t>
+              <a:t>Sentence-BERT (SBERT) Vector Mechanics</a:t>
             </a:r>
           </a:p>
         </p:txBody>
@@ -5075,8 +5763,8 @@
         </p:nvSpPr>
         <p:spPr>
           <a:xfrm>
-            <a:off x="731520" y="1463040"/>
-            <a:ext cx="5120640" cy="2194560"/>
+            <a:off x="731520" y="1371600"/>
+            <a:ext cx="10728655" cy="4937760"/>
           </a:xfrm>
           <a:prstGeom prst="rect">
             <a:avLst/>
@@ -5084,7 +5772,7 @@
           <a:solidFill>
             <a:srgbClr val="0F172A"/>
           </a:solidFill>
-          <a:ln>
+          <a:ln w="19050">
             <a:solidFill>
               <a:srgbClr val="38BDF8"/>
             </a:solidFill>
@@ -5105,94 +5793,69 @@
           </a:fontRef>
         </p:style>
         <p:txBody>
-          <a:bodyPr rtlCol="0" anchor="ctr" wrap="square"/>
-          <a:lstStyle/>
-          <a:p>
-            <a:pPr algn="ctr">
-              <a:spcAft>
-                <a:spcPts val="600"/>
-              </a:spcAft>
-              <a:defRPr sz="1600" b="1">
-                <a:solidFill>
-                  <a:srgbClr val="38BDF8"/>
-                </a:solidFill>
-              </a:defRPr>
-            </a:pPr>
-            <a:r>
-              <a:t>🎯 Single Resume Evaluation</a:t>
-            </a:r>
-          </a:p>
-          <a:p>
-            <a:pPr>
-              <a:defRPr sz="1200">
-                <a:solidFill>
-                  <a:srgbClr val="CBD5E1"/>
-                </a:solidFill>
-              </a:defRPr>
-            </a:pPr>
-            <a:r>
-              <a:t>Instant SBERT semantic score, match grade, skill coverage percentage, and non-capturing contact audit card.</a:t>
-            </a:r>
-          </a:p>
-        </p:txBody>
-      </p:sp>
-      <p:sp>
-        <p:nvSpPr>
-          <p:cNvPr id="5" name="Rectangle 4"/>
-          <p:cNvSpPr/>
+          <a:bodyPr rtlCol="0" anchor="ctr"/>
+          <a:lstStyle/>
+          <a:p>
+            <a:pPr algn="ctr"/>
+          </a:p>
+        </p:txBody>
+      </p:sp>
+      <p:sp>
+        <p:nvSpPr>
+          <p:cNvPr id="5" name="TextBox 4"/>
+          <p:cNvSpPr txBox="1"/>
           <p:nvPr/>
         </p:nvSpPr>
         <p:spPr>
           <a:xfrm>
-            <a:off x="6217920" y="1463040"/>
-            <a:ext cx="5120640" cy="2194560"/>
+            <a:off x="914400" y="1554480"/>
+            <a:ext cx="10362895" cy="4572000"/>
           </a:xfrm>
           <a:prstGeom prst="rect">
             <a:avLst/>
           </a:prstGeom>
-          <a:solidFill>
-            <a:srgbClr val="0F172A"/>
-          </a:solidFill>
-          <a:ln>
-            <a:solidFill>
-              <a:srgbClr val="34D399"/>
-            </a:solidFill>
-          </a:ln>
-        </p:spPr>
-        <p:style>
-          <a:lnRef idx="1">
-            <a:schemeClr val="accent1"/>
-          </a:lnRef>
-          <a:fillRef idx="3">
-            <a:schemeClr val="accent1"/>
-          </a:fillRef>
-          <a:effectRef idx="2">
-            <a:schemeClr val="accent1"/>
-          </a:effectRef>
-          <a:fontRef idx="minor">
-            <a:schemeClr val="lt1"/>
-          </a:fontRef>
-        </p:style>
-        <p:txBody>
-          <a:bodyPr rtlCol="0" anchor="ctr" wrap="square"/>
-          <a:lstStyle/>
-          <a:p>
-            <a:pPr algn="ctr">
-              <a:spcAft>
-                <a:spcPts val="600"/>
-              </a:spcAft>
-              <a:defRPr sz="1600" b="1">
+          <a:noFill/>
+        </p:spPr>
+        <p:txBody>
+          <a:bodyPr wrap="square">
+            <a:spAutoFit/>
+          </a:bodyPr>
+          <a:lstStyle/>
+          <a:p>
+            <a:pPr>
+              <a:spcAft>
+                <a:spcPts val="1400"/>
+              </a:spcAft>
+              <a:defRPr sz="1800" b="1">
+                <a:solidFill>
+                  <a:srgbClr val="38BDF8"/>
+                </a:solidFill>
+              </a:defRPr>
+            </a:pPr>
+            <a:r>
+              <a:t>🧠 Deep Learning Transformer Mechanics (all-MiniLM-L6-v2)</a:t>
+            </a:r>
+          </a:p>
+          <a:p>
+            <a:pPr>
+              <a:spcAft>
+                <a:spcPts val="300"/>
+              </a:spcAft>
+              <a:defRPr sz="1400" b="1">
                 <a:solidFill>
                   <a:srgbClr val="34D399"/>
                 </a:solidFill>
               </a:defRPr>
             </a:pPr>
             <a:r>
-              <a:t>🏆 Batch Candidate Leaderboard</a:t>
-            </a:r>
-          </a:p>
-          <a:p>
-            <a:pPr>
+              <a:t>🔸 Pre-trained Transformer Backbone:</a:t>
+            </a:r>
+          </a:p>
+          <a:p>
+            <a:pPr>
+              <a:spcAft>
+                <a:spcPts val="1000"/>
+              </a:spcAft>
               <a:defRPr sz="1200">
                 <a:solidFill>
                   <a:srgbClr val="CBD5E1"/>
@@ -5200,68 +5863,29 @@
               </a:defRPr>
             </a:pPr>
             <a:r>
-              <a:t>Upload multiple PDF/DOCX resumes to rank all candidates automatically against a single job description.</a:t>
-            </a:r>
-          </a:p>
-        </p:txBody>
-      </p:sp>
-      <p:sp>
-        <p:nvSpPr>
-          <p:cNvPr id="6" name="Rectangle 5"/>
-          <p:cNvSpPr/>
-          <p:nvPr/>
-        </p:nvSpPr>
-        <p:spPr>
-          <a:xfrm>
-            <a:off x="731520" y="3931920"/>
-            <a:ext cx="5120640" cy="2194560"/>
-          </a:xfrm>
-          <a:prstGeom prst="rect">
-            <a:avLst/>
-          </a:prstGeom>
-          <a:solidFill>
-            <a:srgbClr val="0F172A"/>
-          </a:solidFill>
-          <a:ln>
-            <a:solidFill>
-              <a:srgbClr val="F472B6"/>
-            </a:solidFill>
-          </a:ln>
-        </p:spPr>
-        <p:style>
-          <a:lnRef idx="1">
-            <a:schemeClr val="accent1"/>
-          </a:lnRef>
-          <a:fillRef idx="3">
-            <a:schemeClr val="accent1"/>
-          </a:fillRef>
-          <a:effectRef idx="2">
-            <a:schemeClr val="accent1"/>
-          </a:effectRef>
-          <a:fontRef idx="minor">
-            <a:schemeClr val="lt1"/>
-          </a:fontRef>
-        </p:style>
-        <p:txBody>
-          <a:bodyPr rtlCol="0" anchor="ctr" wrap="square"/>
-          <a:lstStyle/>
-          <a:p>
-            <a:pPr algn="ctr">
-              <a:spcAft>
-                <a:spcPts val="600"/>
-              </a:spcAft>
-              <a:defRPr sz="1600" b="1">
-                <a:solidFill>
-                  <a:srgbClr val="F472B6"/>
-                </a:solidFill>
-              </a:defRPr>
-            </a:pPr>
-            <a:r>
-              <a:t>🕸️ Multi-Domain Skill Radar</a:t>
-            </a:r>
-          </a:p>
-          <a:p>
-            <a:pPr>
+              <a:t>    Uses Siamese BERT networks fine-tuned for semantic textual similarity (STS).</a:t>
+            </a:r>
+          </a:p>
+          <a:p>
+            <a:pPr>
+              <a:spcAft>
+                <a:spcPts val="300"/>
+              </a:spcAft>
+              <a:defRPr sz="1400" b="1">
+                <a:solidFill>
+                  <a:srgbClr val="34D399"/>
+                </a:solidFill>
+              </a:defRPr>
+            </a:pPr>
+            <a:r>
+              <a:t>🔸 384-Dimensional Vector Mapping:</a:t>
+            </a:r>
+          </a:p>
+          <a:p>
+            <a:pPr>
+              <a:spcAft>
+                <a:spcPts val="1000"/>
+              </a:spcAft>
               <a:defRPr sz="1200">
                 <a:solidFill>
                   <a:srgbClr val="CBD5E1"/>
@@ -5269,68 +5893,29 @@
               </a:defRPr>
             </a:pPr>
             <a:r>
-              <a:t>Plotly polar radar charts comparing candidate skills directly against target role requirements across 7 categories.</a:t>
-            </a:r>
-          </a:p>
-        </p:txBody>
-      </p:sp>
-      <p:sp>
-        <p:nvSpPr>
-          <p:cNvPr id="7" name="Rectangle 6"/>
-          <p:cNvSpPr/>
-          <p:nvPr/>
-        </p:nvSpPr>
-        <p:spPr>
-          <a:xfrm>
-            <a:off x="6217920" y="3931920"/>
-            <a:ext cx="5120640" cy="2194560"/>
-          </a:xfrm>
-          <a:prstGeom prst="rect">
-            <a:avLst/>
-          </a:prstGeom>
-          <a:solidFill>
-            <a:srgbClr val="0F172A"/>
-          </a:solidFill>
-          <a:ln>
-            <a:solidFill>
-              <a:srgbClr val="818CF8"/>
-            </a:solidFill>
-          </a:ln>
-        </p:spPr>
-        <p:style>
-          <a:lnRef idx="1">
-            <a:schemeClr val="accent1"/>
-          </a:lnRef>
-          <a:fillRef idx="3">
-            <a:schemeClr val="accent1"/>
-          </a:fillRef>
-          <a:effectRef idx="2">
-            <a:schemeClr val="accent1"/>
-          </a:effectRef>
-          <a:fontRef idx="minor">
-            <a:schemeClr val="lt1"/>
-          </a:fontRef>
-        </p:style>
-        <p:txBody>
-          <a:bodyPr rtlCol="0" anchor="ctr" wrap="square"/>
-          <a:lstStyle/>
-          <a:p>
-            <a:pPr algn="ctr">
-              <a:spcAft>
-                <a:spcPts val="600"/>
-              </a:spcAft>
-              <a:defRPr sz="1600" b="1">
-                <a:solidFill>
-                  <a:srgbClr val="818CF8"/>
-                </a:solidFill>
-              </a:defRPr>
-            </a:pPr>
-            <a:r>
-              <a:t>📜 SQLite Log &amp; Clear History</a:t>
-            </a:r>
-          </a:p>
-          <a:p>
-            <a:pPr>
+              <a:t>    Converts arbitrary length resume and job description text into dense 384D mathematical vectors (u and v).</a:t>
+            </a:r>
+          </a:p>
+          <a:p>
+            <a:pPr>
+              <a:spcAft>
+                <a:spcPts val="300"/>
+              </a:spcAft>
+              <a:defRPr sz="1400" b="1">
+                <a:solidFill>
+                  <a:srgbClr val="34D399"/>
+                </a:solidFill>
+              </a:defRPr>
+            </a:pPr>
+            <a:r>
+              <a:t>🔸 Cosine Vector Distance Metric:</a:t>
+            </a:r>
+          </a:p>
+          <a:p>
+            <a:pPr>
+              <a:spcAft>
+                <a:spcPts val="1000"/>
+              </a:spcAft>
               <a:defRPr sz="1200">
                 <a:solidFill>
                   <a:srgbClr val="CBD5E1"/>
@@ -5338,7 +5923,37 @@
               </a:defRPr>
             </a:pPr>
             <a:r>
-              <a:t>Automatic audit trail persistence in ats_history.db with one-click clear evaluation history button.</a:t>
+              <a:t>    Calculates Cosine Similarity:  cos(θ) = (u · v) / (||u|| ||v||)  yielding a value between 0.0 and 1.0.</a:t>
+            </a:r>
+          </a:p>
+          <a:p>
+            <a:pPr>
+              <a:spcAft>
+                <a:spcPts val="300"/>
+              </a:spcAft>
+              <a:defRPr sz="1400" b="1">
+                <a:solidFill>
+                  <a:srgbClr val="34D399"/>
+                </a:solidFill>
+              </a:defRPr>
+            </a:pPr>
+            <a:r>
+              <a:t>🔸 Contextual Awareness Advantage:</a:t>
+            </a:r>
+          </a:p>
+          <a:p>
+            <a:pPr>
+              <a:spcAft>
+                <a:spcPts val="1000"/>
+              </a:spcAft>
+              <a:defRPr sz="1200">
+                <a:solidFill>
+                  <a:srgbClr val="CBD5E1"/>
+                </a:solidFill>
+              </a:defRPr>
+            </a:pPr>
+            <a:r>
+              <a:t>    Captures conceptual intent. Recognizes that 'PyTorch / TensorFlow' is semantically aligned with 'Deep Learning Engineer' even if the phrase 'Deep Learning' is absent.</a:t>
             </a:r>
           </a:p>
         </p:txBody>
@@ -5377,8 +5992,8 @@
         </p:nvSpPr>
         <p:spPr>
           <a:xfrm>
-            <a:off x="731520" y="365760"/>
-            <a:ext cx="10058400" cy="365760"/>
+            <a:off x="731520" y="320040"/>
+            <a:ext cx="10058400" cy="320040"/>
           </a:xfrm>
           <a:prstGeom prst="rect">
             <a:avLst/>
@@ -5412,8 +6027,8 @@
         </p:nvSpPr>
         <p:spPr>
           <a:xfrm>
-            <a:off x="731520" y="640080"/>
-            <a:ext cx="10515600" cy="731520"/>
+            <a:off x="731520" y="594360"/>
+            <a:ext cx="10515600" cy="640080"/>
           </a:xfrm>
           <a:prstGeom prst="rect">
             <a:avLst/>
@@ -5427,14 +6042,14 @@
           <a:lstStyle/>
           <a:p>
             <a:pPr>
-              <a:defRPr sz="2600" b="1">
+              <a:defRPr sz="2400" b="1">
                 <a:solidFill>
                   <a:srgbClr val="FFFFFF"/>
                 </a:solidFill>
               </a:defRPr>
             </a:pPr>
             <a:r>
-              <a:t>Experimental Evaluation &amp; Sample Results</a:t>
+              <a:t>7-Domain NLP Skill Taxonomy Engine</a:t>
             </a:r>
           </a:p>
         </p:txBody>
@@ -5447,8 +6062,8 @@
         </p:nvSpPr>
         <p:spPr>
           <a:xfrm>
-            <a:off x="731520" y="1463040"/>
-            <a:ext cx="10607040" cy="4754880"/>
+            <a:off x="731520" y="1371600"/>
+            <a:ext cx="10728655" cy="4937760"/>
           </a:xfrm>
           <a:prstGeom prst="rect">
             <a:avLst/>
@@ -5458,7 +6073,7 @@
           </a:solidFill>
           <a:ln w="19050">
             <a:solidFill>
-              <a:srgbClr val="34D399"/>
+              <a:srgbClr val="818CF8"/>
             </a:solidFill>
           </a:ln>
         </p:spPr>
@@ -5492,8 +6107,8 @@
         </p:nvSpPr>
         <p:spPr>
           <a:xfrm>
-            <a:off x="914400" y="1645920"/>
-            <a:ext cx="10241280" cy="4389120"/>
+            <a:off x="914400" y="1554480"/>
+            <a:ext cx="10362895" cy="4572000"/>
           </a:xfrm>
           <a:prstGeom prst="rect">
             <a:avLst/>
@@ -5508,16 +6123,16 @@
           <a:p>
             <a:pPr>
               <a:spcAft>
-                <a:spcPts val="1400"/>
+                <a:spcPts val="1200"/>
               </a:spcAft>
               <a:defRPr sz="1800" b="1">
                 <a:solidFill>
-                  <a:srgbClr val="34D399"/>
-                </a:solidFill>
-              </a:defRPr>
-            </a:pPr>
-            <a:r>
-              <a:t>📊 Sample Evaluation Output (ML Engineer Candidate)</a:t>
+                  <a:srgbClr val="818CF8"/>
+                </a:solidFill>
+              </a:defRPr>
+            </a:pPr>
+            <a:r>
+              <a:t>🏷️ Categorized Technical &amp; Soft Skill Competencies</a:t>
             </a:r>
           </a:p>
           <a:p>
@@ -5525,14 +6140,14 @@
               <a:spcAft>
                 <a:spcPts val="600"/>
               </a:spcAft>
-              <a:defRPr sz="1300">
+              <a:defRPr sz="1200">
                 <a:solidFill>
                   <a:srgbClr val="FFFFFF"/>
                 </a:solidFill>
               </a:defRPr>
             </a:pPr>
             <a:r>
-              <a:t>• Candidate Name: Alex (Email: alex.dev@gmail.com | Phone: +91-7058291048)</a:t>
+              <a:t>• 1. Programming Languages: Python, C++, Java, JavaScript, TypeScript, Go, Rust, R, SQL, Swift</a:t>
             </a:r>
           </a:p>
           <a:p>
@@ -5540,14 +6155,14 @@
               <a:spcAft>
                 <a:spcPts val="600"/>
               </a:spcAft>
-              <a:defRPr sz="1300">
+              <a:defRPr sz="1200">
                 <a:solidFill>
                   <a:srgbClr val="FFFFFF"/>
                 </a:solidFill>
               </a:defRPr>
             </a:pPr>
             <a:r>
-              <a:t>• Target Role: Machine Learning Engineer</a:t>
+              <a:t>• 2. Machine Learning &amp; AI: PyTorch, TensorFlow, Scikit-Learn, Keras, OpenCV, SpaCy, HuggingFace, RAG, LLM</a:t>
             </a:r>
           </a:p>
           <a:p>
@@ -5555,14 +6170,14 @@
               <a:spcAft>
                 <a:spcPts val="600"/>
               </a:spcAft>
-              <a:defRPr sz="1300">
+              <a:defRPr sz="1200">
                 <a:solidFill>
                   <a:srgbClr val="FFFFFF"/>
                 </a:solidFill>
               </a:defRPr>
             </a:pPr>
             <a:r>
-              <a:t>• Final Composite ATS Score: 87.5%  [Grade: Exceptional Fit]</a:t>
+              <a:t>• 3. Web Development: React, Node.js, FastAPI, Flask, Django, HTML5, CSS3, Tailwind, REST API</a:t>
             </a:r>
           </a:p>
           <a:p>
@@ -5570,14 +6185,14 @@
               <a:spcAft>
                 <a:spcPts val="600"/>
               </a:spcAft>
-              <a:defRPr sz="1300">
+              <a:defRPr sz="1200">
                 <a:solidFill>
                   <a:srgbClr val="FFFFFF"/>
                 </a:solidFill>
               </a:defRPr>
             </a:pPr>
             <a:r>
-              <a:t>• SBERT Semantic Match: 84.3%  (Dense 384D Vector Cosine Sim)</a:t>
+              <a:t>• 4. Cloud &amp; DevOps: AWS, Azure, GCP, Docker, Kubernetes, CI/CD, Terraform, Linux, Git, GitHub</a:t>
             </a:r>
           </a:p>
           <a:p>
@@ -5585,14 +6200,14 @@
               <a:spcAft>
                 <a:spcPts val="600"/>
               </a:spcAft>
-              <a:defRPr sz="1300">
+              <a:defRPr sz="1200">
                 <a:solidFill>
                   <a:srgbClr val="FFFFFF"/>
                 </a:solidFill>
               </a:defRPr>
             </a:pPr>
             <a:r>
-              <a:t>• Skill Coverage Ratio: 90.0%  (9 Matched Skills / 10 Required)</a:t>
+              <a:t>• 5. Databases: PostgreSQL, MySQL, MongoDB, Redis, SQLite, Pinecone, ChromaDB</a:t>
             </a:r>
           </a:p>
           <a:p>
@@ -5600,14 +6215,14 @@
               <a:spcAft>
                 <a:spcPts val="600"/>
               </a:spcAft>
-              <a:defRPr sz="1300">
+              <a:defRPr sz="1200">
                 <a:solidFill>
                   <a:srgbClr val="FFFFFF"/>
                 </a:solidFill>
               </a:defRPr>
             </a:pPr>
             <a:r>
-              <a:t>• TF-IDF Keyword Similarity: 89.2%  (Term Frequency Matrix Cosine Sim)</a:t>
+              <a:t>• 6. Frameworks &amp; Tools: Pandas, NumPy, Matplotlib, Seaborn, Jupyter Notebooks, VS Code, JIRA</a:t>
             </a:r>
           </a:p>
           <a:p>
@@ -5615,29 +6230,14 @@
               <a:spcAft>
                 <a:spcPts val="600"/>
               </a:spcAft>
-              <a:defRPr sz="1300">
+              <a:defRPr sz="1200">
                 <a:solidFill>
                   <a:srgbClr val="FFFFFF"/>
                 </a:solidFill>
               </a:defRPr>
             </a:pPr>
             <a:r>
-              <a:t>• Matched Competencies: Python, PyTorch, TensorFlow, Scikit-Learn, Docker, Kubernetes, AWS, Git, SQL</a:t>
-            </a:r>
-          </a:p>
-          <a:p>
-            <a:pPr>
-              <a:spcAft>
-                <a:spcPts val="600"/>
-              </a:spcAft>
-              <a:defRPr sz="1300">
-                <a:solidFill>
-                  <a:srgbClr val="FFFFFF"/>
-                </a:solidFill>
-              </a:defRPr>
-            </a:pPr>
-            <a:r>
-              <a:t>• Missing Skill Alert: MLflow (Recommended for optimization)</a:t>
+              <a:t>• 7. Soft Skills: Leadership, Problem Solving, Critical Thinking, Communication, Teamwork</a:t>
             </a:r>
           </a:p>
         </p:txBody>
@@ -5676,8 +6276,8 @@
         </p:nvSpPr>
         <p:spPr>
           <a:xfrm>
-            <a:off x="731520" y="365760"/>
-            <a:ext cx="10058400" cy="365760"/>
+            <a:off x="731520" y="320040"/>
+            <a:ext cx="10058400" cy="320040"/>
           </a:xfrm>
           <a:prstGeom prst="rect">
             <a:avLst/>
@@ -5711,8 +6311,8 @@
         </p:nvSpPr>
         <p:spPr>
           <a:xfrm>
-            <a:off x="731520" y="640080"/>
-            <a:ext cx="10515600" cy="731520"/>
+            <a:off x="731520" y="594360"/>
+            <a:ext cx="10515600" cy="640080"/>
           </a:xfrm>
           <a:prstGeom prst="rect">
             <a:avLst/>
@@ -5726,14 +6326,14 @@
           <a:lstStyle/>
           <a:p>
             <a:pPr>
-              <a:defRPr sz="2600" b="1">
+              <a:defRPr sz="2400" b="1">
                 <a:solidFill>
                   <a:srgbClr val="FFFFFF"/>
                 </a:solidFill>
               </a:defRPr>
             </a:pPr>
             <a:r>
-              <a:t>FastAPI REST Microservice Architecture</a:t>
+              <a:t>Non-Capturing Regex Contact Extractor</a:t>
             </a:r>
           </a:p>
         </p:txBody>
@@ -5746,8 +6346,8 @@
         </p:nvSpPr>
         <p:spPr>
           <a:xfrm>
-            <a:off x="731520" y="1463040"/>
-            <a:ext cx="10607040" cy="4754880"/>
+            <a:off x="731520" y="1371600"/>
+            <a:ext cx="10728655" cy="4937760"/>
           </a:xfrm>
           <a:prstGeom prst="rect">
             <a:avLst/>
@@ -5757,7 +6357,7 @@
           </a:solidFill>
           <a:ln w="19050">
             <a:solidFill>
-              <a:srgbClr val="38BDF8"/>
+              <a:srgbClr val="F472B6"/>
             </a:solidFill>
           </a:ln>
         </p:spPr>
@@ -5791,8 +6391,8 @@
         </p:nvSpPr>
         <p:spPr>
           <a:xfrm>
-            <a:off x="914400" y="1645920"/>
-            <a:ext cx="10241280" cy="4389120"/>
+            <a:off x="914400" y="1554480"/>
+            <a:ext cx="10362895" cy="4572000"/>
           </a:xfrm>
           <a:prstGeom prst="rect">
             <a:avLst/>
@@ -5807,76 +6407,166 @@
           <a:p>
             <a:pPr>
               <a:spcAft>
-                <a:spcPts val="1400"/>
+                <a:spcPts val="1200"/>
               </a:spcAft>
               <a:defRPr sz="1800" b="1">
                 <a:solidFill>
+                  <a:srgbClr val="F472B6"/>
+                </a:solidFill>
+              </a:defRPr>
+            </a:pPr>
+            <a:r>
+              <a:t>📱 Solving Regex Truncation &amp; Extracting Clean Contact Data</a:t>
+            </a:r>
+          </a:p>
+          <a:p>
+            <a:pPr>
+              <a:spcAft>
+                <a:spcPts val="200"/>
+              </a:spcAft>
+              <a:defRPr sz="1300" b="1">
+                <a:solidFill>
                   <a:srgbClr val="38BDF8"/>
                 </a:solidFill>
               </a:defRPr>
             </a:pPr>
             <a:r>
-              <a:t>🌐 Headless REST API Endpoints (api.py)</a:t>
-            </a:r>
-          </a:p>
-          <a:p>
-            <a:pPr>
-              <a:spcAft>
-                <a:spcPts val="1200"/>
-              </a:spcAft>
-              <a:defRPr sz="1400">
-                <a:solidFill>
-                  <a:srgbClr val="FFFFFF"/>
-                </a:solidFill>
-              </a:defRPr>
-            </a:pPr>
-            <a:r>
-              <a:t>• GET / : Health check status &amp; service metadata.</a:t>
-            </a:r>
-          </a:p>
-          <a:p>
-            <a:pPr>
-              <a:spcAft>
-                <a:spcPts val="1200"/>
-              </a:spcAft>
-              <a:defRPr sz="1400">
-                <a:solidFill>
-                  <a:srgbClr val="FFFFFF"/>
-                </a:solidFill>
-              </a:defRPr>
-            </a:pPr>
-            <a:r>
-              <a:t>• GET /docs : Interactive Swagger UI API documentation.</a:t>
-            </a:r>
-          </a:p>
-          <a:p>
-            <a:pPr>
-              <a:spcAft>
-                <a:spcPts val="1200"/>
-              </a:spcAft>
-              <a:defRPr sz="1400">
-                <a:solidFill>
-                  <a:srgbClr val="FFFFFF"/>
-                </a:solidFill>
-              </a:defRPr>
-            </a:pPr>
-            <a:r>
-              <a:t>• POST /api/v1/parse-resume : Accepts PDF/DOCX file upload, extracts raw text &amp; non-capturing contact audit.</a:t>
-            </a:r>
-          </a:p>
-          <a:p>
-            <a:pPr>
-              <a:spcAft>
-                <a:spcPts val="1200"/>
-              </a:spcAft>
-              <a:defRPr sz="1400">
-                <a:solidFill>
-                  <a:srgbClr val="FFFFFF"/>
-                </a:solidFill>
-              </a:defRPr>
-            </a:pPr>
-            <a:r>
-              <a:t>• POST /api/v1/analyze-match : Accepts JSON payload (resume text + JD text), calculates composite ATS scores, maps skill gaps, logs to SQLite database, and returns JSON response.</a:t>
+              <a:t>• The Truncation Challenge:</a:t>
+            </a:r>
+          </a:p>
+          <a:p>
+            <a:pPr>
+              <a:spcAft>
+                <a:spcPts val="800"/>
+              </a:spcAft>
+              <a:defRPr sz="1100">
+                <a:solidFill>
+                  <a:srgbClr val="CBD5E1"/>
+                </a:solidFill>
+              </a:defRPr>
+            </a:pPr>
+            <a:r>
+              <a:t>    Standard re.findall() with capturing groups () returns matched tuples instead of full strings, truncating phone numbers (e.g. +91-7058291048 -&gt; +91-705).</a:t>
+            </a:r>
+          </a:p>
+          <a:p>
+            <a:pPr>
+              <a:spcAft>
+                <a:spcPts val="200"/>
+              </a:spcAft>
+              <a:defRPr sz="1300" b="1">
+                <a:solidFill>
+                  <a:srgbClr val="38BDF8"/>
+                </a:solidFill>
+              </a:defRPr>
+            </a:pPr>
+            <a:r>
+              <a:t>• Our Solution - Non-Capturing Groups:</a:t>
+            </a:r>
+          </a:p>
+          <a:p>
+            <a:pPr>
+              <a:spcAft>
+                <a:spcPts val="800"/>
+              </a:spcAft>
+              <a:defRPr sz="1100">
+                <a:solidFill>
+                  <a:srgbClr val="CBD5E1"/>
+                </a:solidFill>
+              </a:defRPr>
+            </a:pPr>
+            <a:r>
+              <a:t>    Implemented non-capturing regex groups (?:...) with re.finditer() to evaluate m.group(0), preserving complete 10-13 digit phone numbers.</a:t>
+            </a:r>
+          </a:p>
+          <a:p>
+            <a:pPr>
+              <a:spcAft>
+                <a:spcPts val="200"/>
+              </a:spcAft>
+              <a:defRPr sz="1300" b="1">
+                <a:solidFill>
+                  <a:srgbClr val="38BDF8"/>
+                </a:solidFill>
+              </a:defRPr>
+            </a:pPr>
+            <a:r>
+              <a:t>• Email Regex Pattern:</a:t>
+            </a:r>
+          </a:p>
+          <a:p>
+            <a:pPr>
+              <a:spcAft>
+                <a:spcPts val="800"/>
+              </a:spcAft>
+              <a:defRPr sz="1100">
+                <a:solidFill>
+                  <a:srgbClr val="CBD5E1"/>
+                </a:solidFill>
+              </a:defRPr>
+            </a:pPr>
+            <a:r>
+              <a:t>    \b[A-Za-z0-9._%+-]+@[A-Za-z0-9.-]+\.[A-Za-z]{2,}\b  (Extracts clean email addresses)</a:t>
+            </a:r>
+          </a:p>
+          <a:p>
+            <a:pPr>
+              <a:spcAft>
+                <a:spcPts val="200"/>
+              </a:spcAft>
+              <a:defRPr sz="1300" b="1">
+                <a:solidFill>
+                  <a:srgbClr val="38BDF8"/>
+                </a:solidFill>
+              </a:defRPr>
+            </a:pPr>
+            <a:r>
+              <a:t>• Phone Regex Pattern:</a:t>
+            </a:r>
+          </a:p>
+          <a:p>
+            <a:pPr>
+              <a:spcAft>
+                <a:spcPts val="800"/>
+              </a:spcAft>
+              <a:defRPr sz="1100">
+                <a:solidFill>
+                  <a:srgbClr val="CBD5E1"/>
+                </a:solidFill>
+              </a:defRPr>
+            </a:pPr>
+            <a:r>
+              <a:t>    (?:\+?\d{1,3}[\s.-]?)?(?:\(?\d{2,4}\)?[\s.-]?)?\d{3,4}[\s.-]?\d{3,4}  (Parses full numbers with country codes)</a:t>
+            </a:r>
+          </a:p>
+          <a:p>
+            <a:pPr>
+              <a:spcAft>
+                <a:spcPts val="200"/>
+              </a:spcAft>
+              <a:defRPr sz="1300" b="1">
+                <a:solidFill>
+                  <a:srgbClr val="38BDF8"/>
+                </a:solidFill>
+              </a:defRPr>
+            </a:pPr>
+            <a:r>
+              <a:t>• LinkedIn &amp; GitHub URLs:</a:t>
+            </a:r>
+          </a:p>
+          <a:p>
+            <a:pPr>
+              <a:spcAft>
+                <a:spcPts val="800"/>
+              </a:spcAft>
+              <a:defRPr sz="1100">
+                <a:solidFill>
+                  <a:srgbClr val="CBD5E1"/>
+                </a:solidFill>
+              </a:defRPr>
+            </a:pPr>
+            <a:r>
+              <a:t>    (?:https?://)?(?:www\.)?linkedin\.com/in/[a-zA-Z0-9\-_/]+  (Normalizes full profile URLs)</a:t>
             </a:r>
           </a:p>
         </p:txBody>
@@ -5915,8 +6605,8 @@
         </p:nvSpPr>
         <p:spPr>
           <a:xfrm>
-            <a:off x="731520" y="365760"/>
-            <a:ext cx="10058400" cy="365760"/>
+            <a:off x="731520" y="320040"/>
+            <a:ext cx="10058400" cy="320040"/>
           </a:xfrm>
           <a:prstGeom prst="rect">
             <a:avLst/>
@@ -5950,8 +6640,8 @@
         </p:nvSpPr>
         <p:spPr>
           <a:xfrm>
-            <a:off x="731520" y="640080"/>
-            <a:ext cx="10515600" cy="731520"/>
+            <a:off x="731520" y="594360"/>
+            <a:ext cx="10515600" cy="640080"/>
           </a:xfrm>
           <a:prstGeom prst="rect">
             <a:avLst/>
@@ -5965,14 +6655,14 @@
           <a:lstStyle/>
           <a:p>
             <a:pPr>
-              <a:defRPr sz="2600" b="1">
+              <a:defRPr sz="2400" b="1">
                 <a:solidFill>
                   <a:srgbClr val="FFFFFF"/>
                 </a:solidFill>
               </a:defRPr>
             </a:pPr>
             <a:r>
-              <a:t>Future Scope &amp; System Enhancements</a:t>
+              <a:t>Streamlit Dashboard &amp; SQLite History Logger</a:t>
             </a:r>
           </a:p>
         </p:txBody>
@@ -5985,8 +6675,8 @@
         </p:nvSpPr>
         <p:spPr>
           <a:xfrm>
-            <a:off x="731520" y="1463040"/>
-            <a:ext cx="10607040" cy="4754880"/>
+            <a:off x="731520" y="1371600"/>
+            <a:ext cx="5212080" cy="2286000"/>
           </a:xfrm>
           <a:prstGeom prst="rect">
             <a:avLst/>
@@ -5994,9 +6684,9 @@
           <a:solidFill>
             <a:srgbClr val="0F172A"/>
           </a:solidFill>
-          <a:ln w="19050">
+          <a:ln>
             <a:solidFill>
-              <a:srgbClr val="F472B6"/>
+              <a:srgbClr val="38BDF8"/>
             </a:solidFill>
           </a:ln>
         </p:spPr>
@@ -6030,8 +6720,8 @@
         </p:nvSpPr>
         <p:spPr>
           <a:xfrm>
-            <a:off x="914400" y="1645920"/>
-            <a:ext cx="10241280" cy="4389120"/>
+            <a:off x="914400" y="1554480"/>
+            <a:ext cx="4846320" cy="1920240"/>
           </a:xfrm>
           <a:prstGeom prst="rect">
             <a:avLst/>
@@ -6046,76 +6736,313 @@
           <a:p>
             <a:pPr>
               <a:spcAft>
-                <a:spcPts val="1400"/>
-              </a:spcAft>
-              <a:defRPr sz="1800" b="1">
+                <a:spcPts val="600"/>
+              </a:spcAft>
+              <a:defRPr sz="1600" b="1">
+                <a:solidFill>
+                  <a:srgbClr val="38BDF8"/>
+                </a:solidFill>
+              </a:defRPr>
+            </a:pPr>
+            <a:r>
+              <a:t>🎯 Single Resume Evaluation</a:t>
+            </a:r>
+          </a:p>
+          <a:p>
+            <a:pPr>
+              <a:defRPr sz="1200">
+                <a:solidFill>
+                  <a:srgbClr val="CBD5E1"/>
+                </a:solidFill>
+              </a:defRPr>
+            </a:pPr>
+            <a:r>
+              <a:t>Upload PDF/DOCX resume; computes instant SBERT match score, match grade, skill gap list, and Executive Contact Audit card.</a:t>
+            </a:r>
+          </a:p>
+        </p:txBody>
+      </p:sp>
+      <p:sp>
+        <p:nvSpPr>
+          <p:cNvPr id="6" name="Rectangle 5"/>
+          <p:cNvSpPr/>
+          <p:nvPr/>
+        </p:nvSpPr>
+        <p:spPr>
+          <a:xfrm>
+            <a:off x="6217920" y="1371600"/>
+            <a:ext cx="5212080" cy="2286000"/>
+          </a:xfrm>
+          <a:prstGeom prst="rect">
+            <a:avLst/>
+          </a:prstGeom>
+          <a:solidFill>
+            <a:srgbClr val="0F172A"/>
+          </a:solidFill>
+          <a:ln>
+            <a:solidFill>
+              <a:srgbClr val="34D399"/>
+            </a:solidFill>
+          </a:ln>
+        </p:spPr>
+        <p:style>
+          <a:lnRef idx="1">
+            <a:schemeClr val="accent1"/>
+          </a:lnRef>
+          <a:fillRef idx="3">
+            <a:schemeClr val="accent1"/>
+          </a:fillRef>
+          <a:effectRef idx="2">
+            <a:schemeClr val="accent1"/>
+          </a:effectRef>
+          <a:fontRef idx="minor">
+            <a:schemeClr val="lt1"/>
+          </a:fontRef>
+        </p:style>
+        <p:txBody>
+          <a:bodyPr rtlCol="0" anchor="ctr"/>
+          <a:lstStyle/>
+          <a:p>
+            <a:pPr algn="ctr"/>
+          </a:p>
+        </p:txBody>
+      </p:sp>
+      <p:sp>
+        <p:nvSpPr>
+          <p:cNvPr id="7" name="TextBox 6"/>
+          <p:cNvSpPr txBox="1"/>
+          <p:nvPr/>
+        </p:nvSpPr>
+        <p:spPr>
+          <a:xfrm>
+            <a:off x="6400800" y="1554480"/>
+            <a:ext cx="4846320" cy="1920240"/>
+          </a:xfrm>
+          <a:prstGeom prst="rect">
+            <a:avLst/>
+          </a:prstGeom>
+          <a:noFill/>
+        </p:spPr>
+        <p:txBody>
+          <a:bodyPr wrap="square">
+            <a:spAutoFit/>
+          </a:bodyPr>
+          <a:lstStyle/>
+          <a:p>
+            <a:pPr>
+              <a:spcAft>
+                <a:spcPts val="600"/>
+              </a:spcAft>
+              <a:defRPr sz="1600" b="1">
+                <a:solidFill>
+                  <a:srgbClr val="34D399"/>
+                </a:solidFill>
+              </a:defRPr>
+            </a:pPr>
+            <a:r>
+              <a:t>🏆 Batch Candidate Leaderboard</a:t>
+            </a:r>
+          </a:p>
+          <a:p>
+            <a:pPr>
+              <a:defRPr sz="1200">
+                <a:solidFill>
+                  <a:srgbClr val="CBD5E1"/>
+                </a:solidFill>
+              </a:defRPr>
+            </a:pPr>
+            <a:r>
+              <a:t>Upload multiple candidate resumes to rank all applicants on an interactive leaderboard sorted by highest ATS match score.</a:t>
+            </a:r>
+          </a:p>
+        </p:txBody>
+      </p:sp>
+      <p:sp>
+        <p:nvSpPr>
+          <p:cNvPr id="8" name="Rectangle 7"/>
+          <p:cNvSpPr/>
+          <p:nvPr/>
+        </p:nvSpPr>
+        <p:spPr>
+          <a:xfrm>
+            <a:off x="731520" y="3931920"/>
+            <a:ext cx="5212080" cy="2286000"/>
+          </a:xfrm>
+          <a:prstGeom prst="rect">
+            <a:avLst/>
+          </a:prstGeom>
+          <a:solidFill>
+            <a:srgbClr val="0F172A"/>
+          </a:solidFill>
+          <a:ln>
+            <a:solidFill>
+              <a:srgbClr val="F472B6"/>
+            </a:solidFill>
+          </a:ln>
+        </p:spPr>
+        <p:style>
+          <a:lnRef idx="1">
+            <a:schemeClr val="accent1"/>
+          </a:lnRef>
+          <a:fillRef idx="3">
+            <a:schemeClr val="accent1"/>
+          </a:fillRef>
+          <a:effectRef idx="2">
+            <a:schemeClr val="accent1"/>
+          </a:effectRef>
+          <a:fontRef idx="minor">
+            <a:schemeClr val="lt1"/>
+          </a:fontRef>
+        </p:style>
+        <p:txBody>
+          <a:bodyPr rtlCol="0" anchor="ctr"/>
+          <a:lstStyle/>
+          <a:p>
+            <a:pPr algn="ctr"/>
+          </a:p>
+        </p:txBody>
+      </p:sp>
+      <p:sp>
+        <p:nvSpPr>
+          <p:cNvPr id="9" name="TextBox 8"/>
+          <p:cNvSpPr txBox="1"/>
+          <p:nvPr/>
+        </p:nvSpPr>
+        <p:spPr>
+          <a:xfrm>
+            <a:off x="914400" y="4114800"/>
+            <a:ext cx="4846320" cy="1920240"/>
+          </a:xfrm>
+          <a:prstGeom prst="rect">
+            <a:avLst/>
+          </a:prstGeom>
+          <a:noFill/>
+        </p:spPr>
+        <p:txBody>
+          <a:bodyPr wrap="square">
+            <a:spAutoFit/>
+          </a:bodyPr>
+          <a:lstStyle/>
+          <a:p>
+            <a:pPr>
+              <a:spcAft>
+                <a:spcPts val="600"/>
+              </a:spcAft>
+              <a:defRPr sz="1600" b="1">
                 <a:solidFill>
                   <a:srgbClr val="F472B6"/>
                 </a:solidFill>
               </a:defRPr>
             </a:pPr>
             <a:r>
-              <a:t>🚀 Future Research &amp; Technical Roadmap</a:t>
-            </a:r>
-          </a:p>
-          <a:p>
-            <a:pPr>
-              <a:spcAft>
-                <a:spcPts val="1400"/>
-              </a:spcAft>
-              <a:defRPr sz="1400">
-                <a:solidFill>
-                  <a:srgbClr val="FFFFFF"/>
-                </a:solidFill>
-              </a:defRPr>
-            </a:pPr>
-            <a:r>
-              <a:t>1. Domain Fine-Tuning: Fine-tuning SBERT models on 100k+ technical resume datasets for industry specificity.</a:t>
-            </a:r>
-          </a:p>
-          <a:p>
-            <a:pPr>
-              <a:spcAft>
-                <a:spcPts val="1400"/>
-              </a:spcAft>
-              <a:defRPr sz="1400">
-                <a:solidFill>
-                  <a:srgbClr val="FFFFFF"/>
-                </a:solidFill>
-              </a:defRPr>
-            </a:pPr>
-            <a:r>
-              <a:t>2. LLM Bullet Optimizer: Integrating Llama-3 / Gemini models to auto-rewrite resume bullet points for high impact.</a:t>
-            </a:r>
-          </a:p>
-          <a:p>
-            <a:pPr>
-              <a:spcAft>
-                <a:spcPts val="1400"/>
-              </a:spcAft>
-              <a:defRPr sz="1400">
-                <a:solidFill>
-                  <a:srgbClr val="FFFFFF"/>
-                </a:solidFill>
-              </a:defRPr>
-            </a:pPr>
-            <a:r>
-              <a:t>3. Auto-Formatting PDF Generator: Exporting tailored ATS-compliant PDF resumes with missing keywords added.</a:t>
-            </a:r>
-          </a:p>
-          <a:p>
-            <a:pPr>
-              <a:spcAft>
-                <a:spcPts val="1400"/>
-              </a:spcAft>
-              <a:defRPr sz="1400">
-                <a:solidFill>
-                  <a:srgbClr val="FFFFFF"/>
-                </a:solidFill>
-              </a:defRPr>
-            </a:pPr>
-            <a:r>
-              <a:t>4. Enterprise HRMS Integration: Connectors for Workday, Greenhouse, and Lever recruiting pipelines.</a:t>
+              <a:t>🕸️ Plotly Polar Skill Radar</a:t>
+            </a:r>
+          </a:p>
+          <a:p>
+            <a:pPr>
+              <a:defRPr sz="1200">
+                <a:solidFill>
+                  <a:srgbClr val="CBD5E1"/>
+                </a:solidFill>
+              </a:defRPr>
+            </a:pPr>
+            <a:r>
+              <a:t>Interactive polar radar chart comparing candidate skill distribution directly against job requirements across 7 categories.</a:t>
+            </a:r>
+          </a:p>
+        </p:txBody>
+      </p:sp>
+      <p:sp>
+        <p:nvSpPr>
+          <p:cNvPr id="10" name="Rectangle 9"/>
+          <p:cNvSpPr/>
+          <p:nvPr/>
+        </p:nvSpPr>
+        <p:spPr>
+          <a:xfrm>
+            <a:off x="6217920" y="3931920"/>
+            <a:ext cx="5212080" cy="2286000"/>
+          </a:xfrm>
+          <a:prstGeom prst="rect">
+            <a:avLst/>
+          </a:prstGeom>
+          <a:solidFill>
+            <a:srgbClr val="0F172A"/>
+          </a:solidFill>
+          <a:ln>
+            <a:solidFill>
+              <a:srgbClr val="818CF8"/>
+            </a:solidFill>
+          </a:ln>
+        </p:spPr>
+        <p:style>
+          <a:lnRef idx="1">
+            <a:schemeClr val="accent1"/>
+          </a:lnRef>
+          <a:fillRef idx="3">
+            <a:schemeClr val="accent1"/>
+          </a:fillRef>
+          <a:effectRef idx="2">
+            <a:schemeClr val="accent1"/>
+          </a:effectRef>
+          <a:fontRef idx="minor">
+            <a:schemeClr val="lt1"/>
+          </a:fontRef>
+        </p:style>
+        <p:txBody>
+          <a:bodyPr rtlCol="0" anchor="ctr"/>
+          <a:lstStyle/>
+          <a:p>
+            <a:pPr algn="ctr"/>
+          </a:p>
+        </p:txBody>
+      </p:sp>
+      <p:sp>
+        <p:nvSpPr>
+          <p:cNvPr id="11" name="TextBox 10"/>
+          <p:cNvSpPr txBox="1"/>
+          <p:nvPr/>
+        </p:nvSpPr>
+        <p:spPr>
+          <a:xfrm>
+            <a:off x="6400800" y="4114800"/>
+            <a:ext cx="4846320" cy="1920240"/>
+          </a:xfrm>
+          <a:prstGeom prst="rect">
+            <a:avLst/>
+          </a:prstGeom>
+          <a:noFill/>
+        </p:spPr>
+        <p:txBody>
+          <a:bodyPr wrap="square">
+            <a:spAutoFit/>
+          </a:bodyPr>
+          <a:lstStyle/>
+          <a:p>
+            <a:pPr>
+              <a:spcAft>
+                <a:spcPts val="600"/>
+              </a:spcAft>
+              <a:defRPr sz="1600" b="1">
+                <a:solidFill>
+                  <a:srgbClr val="818CF8"/>
+                </a:solidFill>
+              </a:defRPr>
+            </a:pPr>
+            <a:r>
+              <a:t>📜 SQLite Audit &amp; Reset</a:t>
+            </a:r>
+          </a:p>
+          <a:p>
+            <a:pPr>
+              <a:defRPr sz="1200">
+                <a:solidFill>
+                  <a:srgbClr val="CBD5E1"/>
+                </a:solidFill>
+              </a:defRPr>
+            </a:pPr>
+            <a:r>
+              <a:t>Automatic persistence in ats_history.db with a 'Clear Evaluation History' button for one-click database resets.</a:t>
             </a:r>
           </a:p>
         </p:txBody>

</xml_diff>

<commit_message>
Embed high-res live UI screenshots into HireLens PowerPoint presentation deck
</commit_message>
<xml_diff>
--- a/HireLens_Presentation.pptx
+++ b/HireLens_Presentation.pptx
@@ -17,6 +17,10 @@
     <p:sldId id="265" r:id="rId16"/>
     <p:sldId id="266" r:id="rId17"/>
     <p:sldId id="267" r:id="rId18"/>
+    <p:sldId id="268" r:id="rId19"/>
+    <p:sldId id="269" r:id="rId20"/>
+    <p:sldId id="270" r:id="rId21"/>
+    <p:sldId id="271" r:id="rId22"/>
   </p:sldIdLst>
   <p:sldSz cx="12191695" cy="6858000" type="screen4x3"/>
   <p:notesSz cx="6858000" cy="9144000"/>
@@ -3182,7 +3186,6 @@
                 <a:solidFill>
                   <a:srgbClr val="00F7FF"/>
                 </a:solidFill>
-                <a:latin typeface="Segoe UI"/>
               </a:defRPr>
             </a:pPr>
             <a:r>
@@ -3198,7 +3201,6 @@
                 <a:solidFill>
                   <a:srgbClr val="FFFFFF"/>
                 </a:solidFill>
-                <a:latin typeface="Segoe UI"/>
               </a:defRPr>
             </a:pPr>
             <a:r>
@@ -3283,7 +3285,7 @@
         </p:nvSpPr>
         <p:spPr>
           <a:xfrm>
-            <a:off x="731520" y="365760"/>
+            <a:off x="731520" y="320040"/>
             <a:ext cx="10698480" cy="320040"/>
           </a:xfrm>
           <a:prstGeom prst="rect">
@@ -3306,7 +3308,7 @@
               </a:defRPr>
             </a:pPr>
             <a:r>
-              <a:t>HIRELENS | CAPSTONE DEFENSE</a:t>
+              <a:t>LIVE DEMO | SYSTEM VISUAL PROOF</a:t>
             </a:r>
           </a:p>
         </p:txBody>
@@ -3319,7 +3321,7 @@
         </p:nvSpPr>
         <p:spPr>
           <a:xfrm>
-            <a:off x="731520" y="640080"/>
+            <a:off x="731520" y="594360"/>
             <a:ext cx="10698480" cy="640080"/>
           </a:xfrm>
           <a:prstGeom prst="rect">
@@ -3334,7 +3336,7 @@
           <a:lstStyle/>
           <a:p>
             <a:pPr>
-              <a:defRPr sz="3000" b="1">
+              <a:defRPr sz="2800" b="1">
                 <a:solidFill>
                   <a:srgbClr val="FFFFFF"/>
                 </a:solidFill>
@@ -3342,7 +3344,7 @@
               </a:defRPr>
             </a:pPr>
             <a:r>
-              <a:t>Enterprise REST API Integration</a:t>
+              <a:t>Live System Visual: Formatting Audit &amp; Skill Gap Advice</a:t>
             </a:r>
           </a:p>
         </p:txBody>
@@ -3355,8 +3357,8 @@
         </p:nvSpPr>
         <p:spPr>
           <a:xfrm>
-            <a:off x="731520" y="1371600"/>
-            <a:ext cx="10728655" cy="4846320"/>
+            <a:off x="731520" y="1280160"/>
+            <a:ext cx="10728655" cy="5120640"/>
           </a:xfrm>
           <a:prstGeom prst="roundRect">
             <a:avLst/>
@@ -3392,16 +3394,40 @@
           </a:p>
         </p:txBody>
       </p:sp>
-      <p:sp>
-        <p:nvSpPr>
-          <p:cNvPr id="5" name="TextBox 4"/>
+      <p:pic>
+        <p:nvPicPr>
+          <p:cNvPr id="5" name="Picture 4" descr="sc3_recommendations.png"/>
+          <p:cNvPicPr>
+            <a:picLocks noChangeAspect="1"/>
+          </p:cNvPicPr>
+          <p:nvPr/>
+        </p:nvPicPr>
+        <p:blipFill>
+          <a:blip r:embed="rId2"/>
+          <a:stretch>
+            <a:fillRect/>
+          </a:stretch>
+        </p:blipFill>
+        <p:spPr>
+          <a:xfrm>
+            <a:off x="914400" y="1417320"/>
+            <a:ext cx="10362895" cy="4434840"/>
+          </a:xfrm>
+          <a:prstGeom prst="rect">
+            <a:avLst/>
+          </a:prstGeom>
+        </p:spPr>
+      </p:pic>
+      <p:sp>
+        <p:nvSpPr>
+          <p:cNvPr id="6" name="TextBox 5"/>
           <p:cNvSpPr txBox="1"/>
           <p:nvPr/>
         </p:nvSpPr>
         <p:spPr>
           <a:xfrm>
-            <a:off x="1097280" y="1645920"/>
-            <a:ext cx="9997135" cy="4297680"/>
+            <a:off x="914400" y="5897880"/>
+            <a:ext cx="10362895" cy="457200"/>
           </a:xfrm>
           <a:prstGeom prst="rect">
             <a:avLst/>
@@ -3414,110 +3440,15 @@
           </a:bodyPr>
           <a:lstStyle/>
           <a:p>
-            <a:pPr>
-              <a:spcAft>
-                <a:spcPts val="1600"/>
-              </a:spcAft>
-              <a:defRPr sz="1800" b="1">
-                <a:solidFill>
-                  <a:srgbClr val="00F7FF"/>
-                </a:solidFill>
-              </a:defRPr>
-            </a:pPr>
-            <a:r>
-              <a:t>FASTAPI BACKEND ENDPOINTS (api.py)</a:t>
-            </a:r>
-          </a:p>
-          <a:p>
-            <a:pPr>
-              <a:spcAft>
-                <a:spcPts val="1400"/>
-              </a:spcAft>
-            </a:pPr>
-            <a:r>
-              <a:rPr b="1" sz="1600">
+            <a:pPr algn="ctr">
+              <a:defRPr sz="1400" b="1">
                 <a:solidFill>
                   <a:srgbClr val="FFBF00"/>
                 </a:solidFill>
-              </a:rPr>
-              <a:t>🔹 GET /docs : </a:t>
-            </a:r>
-            <a:r>
-              <a:rPr sz="1500">
-                <a:solidFill>
-                  <a:srgbClr val="FFFFFF"/>
-                </a:solidFill>
-              </a:rPr>
-              <a:t>Interactive Swagger UI documentation for live browser API testing.</a:t>
-            </a:r>
-          </a:p>
-          <a:p>
-            <a:pPr>
-              <a:spcAft>
-                <a:spcPts val="1400"/>
-              </a:spcAft>
-            </a:pPr>
-            <a:r>
-              <a:rPr b="1" sz="1600">
-                <a:solidFill>
-                  <a:srgbClr val="FFBF00"/>
-                </a:solidFill>
-              </a:rPr>
-              <a:t>🔹 POST /api/v1/parse-resume : </a:t>
-            </a:r>
-            <a:r>
-              <a:rPr sz="1500">
-                <a:solidFill>
-                  <a:srgbClr val="FFFFFF"/>
-                </a:solidFill>
-              </a:rPr>
-              <a:t>Upload PDF/DOCX resume file to get extracted text &amp; contact JSON.</a:t>
-            </a:r>
-          </a:p>
-          <a:p>
-            <a:pPr>
-              <a:spcAft>
-                <a:spcPts val="1400"/>
-              </a:spcAft>
-            </a:pPr>
-            <a:r>
-              <a:rPr b="1" sz="1600">
-                <a:solidFill>
-                  <a:srgbClr val="FFBF00"/>
-                </a:solidFill>
-              </a:rPr>
-              <a:t>🔹 POST /api/v1/analyze-match : </a:t>
-            </a:r>
-            <a:r>
-              <a:rPr sz="1500">
-                <a:solidFill>
-                  <a:srgbClr val="FFFFFF"/>
-                </a:solidFill>
-              </a:rPr>
-              <a:t>Returns ATS Match Score, Skill Coverage, and missing skill list JSON.</a:t>
-            </a:r>
-          </a:p>
-          <a:p>
-            <a:pPr>
-              <a:spcAft>
-                <a:spcPts val="1400"/>
-              </a:spcAft>
-            </a:pPr>
-            <a:r>
-              <a:rPr b="1" sz="1600">
-                <a:solidFill>
-                  <a:srgbClr val="FFBF00"/>
-                </a:solidFill>
-              </a:rPr>
-              <a:t>🔹 POST /api/v1/batch-rank : </a:t>
-            </a:r>
-            <a:r>
-              <a:rPr sz="1500">
-                <a:solidFill>
-                  <a:srgbClr val="FFFFFF"/>
-                </a:solidFill>
-              </a:rPr>
-              <a:t>Ranks multiple candidate resumes via API call responses.</a:t>
+              </a:defRPr>
+            </a:pPr>
+            <a:r>
+              <a:t>📸 LIVE SYSTEM DEMO: Automated contact audit, section validation, and actionable missing skill badges provided to candidate</a:t>
             </a:r>
           </a:p>
         </p:txBody>
@@ -3556,7 +3487,7 @@
         </p:nvSpPr>
         <p:spPr>
           <a:xfrm>
-            <a:off x="731520" y="365760"/>
+            <a:off x="731520" y="320040"/>
             <a:ext cx="10698480" cy="320040"/>
           </a:xfrm>
           <a:prstGeom prst="rect">
@@ -3592,7 +3523,7 @@
         </p:nvSpPr>
         <p:spPr>
           <a:xfrm>
-            <a:off x="731520" y="640080"/>
+            <a:off x="731520" y="594360"/>
             <a:ext cx="10698480" cy="640080"/>
           </a:xfrm>
           <a:prstGeom prst="rect">
@@ -3607,7 +3538,7 @@
           <a:lstStyle/>
           <a:p>
             <a:pPr>
-              <a:defRPr sz="3000" b="1">
+              <a:defRPr sz="2800" b="1">
                 <a:solidFill>
                   <a:srgbClr val="FFFFFF"/>
                 </a:solidFill>
@@ -3615,7 +3546,7 @@
               </a:defRPr>
             </a:pPr>
             <a:r>
-              <a:t>Future Scope &amp; Enhancements</a:t>
+              <a:t>Streamlit Dashboard &amp; SQLite Audit Logging</a:t>
             </a:r>
           </a:p>
         </p:txBody>
@@ -3629,7 +3560,159 @@
         <p:spPr>
           <a:xfrm>
             <a:off x="731520" y="1371600"/>
-            <a:ext cx="10728655" cy="4846320"/>
+            <a:ext cx="5120640" cy="4846320"/>
+          </a:xfrm>
+          <a:prstGeom prst="roundRect">
+            <a:avLst/>
+          </a:prstGeom>
+          <a:solidFill>
+            <a:srgbClr val="1E293B"/>
+          </a:solidFill>
+          <a:ln w="25400">
+            <a:solidFill>
+              <a:srgbClr val="00F7FF"/>
+            </a:solidFill>
+          </a:ln>
+        </p:spPr>
+        <p:style>
+          <a:lnRef idx="1">
+            <a:schemeClr val="accent1"/>
+          </a:lnRef>
+          <a:fillRef idx="3">
+            <a:schemeClr val="accent1"/>
+          </a:fillRef>
+          <a:effectRef idx="2">
+            <a:schemeClr val="accent1"/>
+          </a:effectRef>
+          <a:fontRef idx="minor">
+            <a:schemeClr val="lt1"/>
+          </a:fontRef>
+        </p:style>
+        <p:txBody>
+          <a:bodyPr rtlCol="0" anchor="ctr"/>
+          <a:lstStyle/>
+          <a:p>
+            <a:pPr algn="ctr"/>
+          </a:p>
+        </p:txBody>
+      </p:sp>
+      <p:sp>
+        <p:nvSpPr>
+          <p:cNvPr id="5" name="TextBox 4"/>
+          <p:cNvSpPr txBox="1"/>
+          <p:nvPr/>
+        </p:nvSpPr>
+        <p:spPr>
+          <a:xfrm>
+            <a:off x="914400" y="1554480"/>
+            <a:ext cx="4754880" cy="4480560"/>
+          </a:xfrm>
+          <a:prstGeom prst="rect">
+            <a:avLst/>
+          </a:prstGeom>
+          <a:noFill/>
+        </p:spPr>
+        <p:txBody>
+          <a:bodyPr wrap="square">
+            <a:spAutoFit/>
+          </a:bodyPr>
+          <a:lstStyle/>
+          <a:p>
+            <a:pPr>
+              <a:spcAft>
+                <a:spcPts val="1400"/>
+              </a:spcAft>
+              <a:defRPr sz="1800" b="1">
+                <a:solidFill>
+                  <a:srgbClr val="00F7FF"/>
+                </a:solidFill>
+              </a:defRPr>
+            </a:pPr>
+            <a:r>
+              <a:t>DASHBOARD HIGHLIGHTS</a:t>
+            </a:r>
+          </a:p>
+          <a:p>
+            <a:pPr>
+              <a:spcAft>
+                <a:spcPts val="1200"/>
+              </a:spcAft>
+            </a:pPr>
+            <a:r>
+              <a:rPr b="1" sz="1500">
+                <a:solidFill>
+                  <a:srgbClr val="FFFFFF"/>
+                </a:solidFill>
+              </a:rPr>
+              <a:t>• Streamlit Web App: </a:t>
+            </a:r>
+            <a:r>
+              <a:rPr sz="1500">
+                <a:solidFill>
+                  <a:srgbClr val="E2E8F0"/>
+                </a:solidFill>
+              </a:rPr>
+              <a:t>Clean dark mode user interface accessible in web browser.</a:t>
+            </a:r>
+          </a:p>
+          <a:p>
+            <a:pPr>
+              <a:spcAft>
+                <a:spcPts val="1200"/>
+              </a:spcAft>
+            </a:pPr>
+            <a:r>
+              <a:rPr b="1" sz="1500">
+                <a:solidFill>
+                  <a:srgbClr val="FFFFFF"/>
+                </a:solidFill>
+              </a:rPr>
+              <a:t>• Preset Demo Button: </a:t>
+            </a:r>
+            <a:r>
+              <a:rPr sz="1500">
+                <a:solidFill>
+                  <a:srgbClr val="E2E8F0"/>
+                </a:solidFill>
+              </a:rPr>
+              <a:t>One-click 'Load Preset Sample ML Data' for fast live demonstration.</a:t>
+            </a:r>
+          </a:p>
+          <a:p>
+            <a:pPr>
+              <a:spcAft>
+                <a:spcPts val="1200"/>
+              </a:spcAft>
+            </a:pPr>
+            <a:r>
+              <a:rPr b="1" sz="1500">
+                <a:solidFill>
+                  <a:srgbClr val="FFFFFF"/>
+                </a:solidFill>
+              </a:rPr>
+              <a:t>• Plotly Radar Chart: </a:t>
+            </a:r>
+            <a:r>
+              <a:rPr sz="1500">
+                <a:solidFill>
+                  <a:srgbClr val="E2E8F0"/>
+                </a:solidFill>
+              </a:rPr>
+              <a:t>Visual chart comparing candidate skills vs job requirements.</a:t>
+            </a:r>
+          </a:p>
+        </p:txBody>
+      </p:sp>
+      <p:sp>
+        <p:nvSpPr>
+          <p:cNvPr id="6" name="Rounded Rectangle 5"/>
+          <p:cNvSpPr/>
+          <p:nvPr/>
+        </p:nvSpPr>
+        <p:spPr>
+          <a:xfrm>
+            <a:off x="6217920" y="1371600"/>
+            <a:ext cx="5242255" cy="4846320"/>
           </a:xfrm>
           <a:prstGeom prst="roundRect">
             <a:avLst/>
@@ -3667,14 +3750,14 @@
       </p:sp>
       <p:sp>
         <p:nvSpPr>
-          <p:cNvPr id="5" name="TextBox 4"/>
+          <p:cNvPr id="7" name="TextBox 6"/>
           <p:cNvSpPr txBox="1"/>
           <p:nvPr/>
         </p:nvSpPr>
         <p:spPr>
           <a:xfrm>
-            <a:off x="1097280" y="1645920"/>
-            <a:ext cx="9997135" cy="4297680"/>
+            <a:off x="6400800" y="1554480"/>
+            <a:ext cx="4876495" cy="4480560"/>
           </a:xfrm>
           <a:prstGeom prst="rect">
             <a:avLst/>
@@ -3689,7 +3772,7 @@
           <a:p>
             <a:pPr>
               <a:spcAft>
-                <a:spcPts val="1600"/>
+                <a:spcPts val="1400"/>
               </a:spcAft>
               <a:defRPr sz="1800" b="1">
                 <a:solidFill>
@@ -3698,99 +3781,76 @@
               </a:defRPr>
             </a:pPr>
             <a:r>
-              <a:t>FUTURE ROADMAP FOR HIRELENS</a:t>
+              <a:t>DATABASE &amp; LEADERBOARD</a:t>
             </a:r>
           </a:p>
           <a:p>
             <a:pPr>
               <a:spcAft>
-                <a:spcPts val="1400"/>
+                <a:spcPts val="1200"/>
               </a:spcAft>
             </a:pPr>
             <a:r>
               <a:rPr b="1" sz="1500">
                 <a:solidFill>
-                  <a:srgbClr val="00F7FF"/>
+                  <a:srgbClr val="FFFFFF"/>
                 </a:solidFill>
               </a:rPr>
-              <a:t>1. OCR Support for Scanned PDFs: </a:t>
+              <a:t>• Batch Leaderboard: </a:t>
             </a:r>
             <a:r>
               <a:rPr sz="1500">
                 <a:solidFill>
+                  <a:srgbClr val="E2E8F0"/>
+                </a:solidFill>
+              </a:rPr>
+              <a:t>Upload 10+ resumes at once to rank candidates from highest to lowest score.</a:t>
+            </a:r>
+          </a:p>
+          <a:p>
+            <a:pPr>
+              <a:spcAft>
+                <a:spcPts val="1200"/>
+              </a:spcAft>
+            </a:pPr>
+            <a:r>
+              <a:rPr b="1" sz="1500">
+                <a:solidFill>
                   <a:srgbClr val="FFFFFF"/>
                 </a:solidFill>
               </a:rPr>
-              <a:t>Integrate Tesseract OCR to read image-only scanned resumes.</a:t>
+              <a:t>• SQLite History Log: </a:t>
+            </a:r>
+            <a:r>
+              <a:rPr sz="1500">
+                <a:solidFill>
+                  <a:srgbClr val="E2E8F0"/>
+                </a:solidFill>
+              </a:rPr>
+              <a:t>Saves evaluation history into ats_history.db database.</a:t>
             </a:r>
           </a:p>
           <a:p>
             <a:pPr>
               <a:spcAft>
-                <a:spcPts val="1400"/>
+                <a:spcPts val="1200"/>
               </a:spcAft>
             </a:pPr>
             <a:r>
               <a:rPr b="1" sz="1500">
                 <a:solidFill>
-                  <a:srgbClr val="00F7FF"/>
+                  <a:srgbClr val="FFFFFF"/>
                 </a:solidFill>
               </a:rPr>
-              <a:t>2. Vector Database Scaling: </a:t>
+              <a:t>• Clear History Feature: </a:t>
             </a:r>
             <a:r>
               <a:rPr sz="1500">
                 <a:solidFill>
-                  <a:srgbClr val="FFFFFF"/>
+                  <a:srgbClr val="E2E8F0"/>
                 </a:solidFill>
               </a:rPr>
-              <a:t>Use FAISS / Qdrant vector databases for instant searching across 1,000,000+ candidate resumes.</a:t>
-            </a:r>
-          </a:p>
-          <a:p>
-            <a:pPr>
-              <a:spcAft>
-                <a:spcPts val="1400"/>
-              </a:spcAft>
-            </a:pPr>
-            <a:r>
-              <a:rPr b="1" sz="1500">
-                <a:solidFill>
-                  <a:srgbClr val="00F7FF"/>
-                </a:solidFill>
-              </a:rPr>
-              <a:t>3. Multilingual Screening: </a:t>
-            </a:r>
-            <a:r>
-              <a:rPr sz="1500">
-                <a:solidFill>
-                  <a:srgbClr val="FFFFFF"/>
-                </a:solidFill>
-              </a:rPr>
-              <a:t>Support multi-language resume parsing (Spanish, Hindi, German, French).</a:t>
-            </a:r>
-          </a:p>
-          <a:p>
-            <a:pPr>
-              <a:spcAft>
-                <a:spcPts val="1400"/>
-              </a:spcAft>
-            </a:pPr>
-            <a:r>
-              <a:rPr b="1" sz="1500">
-                <a:solidFill>
-                  <a:srgbClr val="00F7FF"/>
-                </a:solidFill>
-              </a:rPr>
-              <a:t>4. Auto Interview Question Generator: </a:t>
-            </a:r>
-            <a:r>
-              <a:rPr sz="1500">
-                <a:solidFill>
-                  <a:srgbClr val="FFFFFF"/>
-                </a:solidFill>
-              </a:rPr>
-              <a:t>Automatically generate custom technical interview questions based on detected candidate skill gaps.</a:t>
+              <a:t>Includes a one-click 'Clear Audit Logs' button to reset database records.</a:t>
             </a:r>
           </a:p>
         </p:txBody>
@@ -3829,7 +3889,7 @@
         </p:nvSpPr>
         <p:spPr>
           <a:xfrm>
-            <a:off x="731520" y="365760"/>
+            <a:off x="731520" y="320040"/>
             <a:ext cx="10698480" cy="320040"/>
           </a:xfrm>
           <a:prstGeom prst="rect">
@@ -3852,7 +3912,7 @@
               </a:defRPr>
             </a:pPr>
             <a:r>
-              <a:t>HIRELENS | CAPSTONE DEFENSE</a:t>
+              <a:t>LIVE DEMO | SYSTEM VISUAL PROOF</a:t>
             </a:r>
           </a:p>
         </p:txBody>
@@ -3865,7 +3925,7 @@
         </p:nvSpPr>
         <p:spPr>
           <a:xfrm>
-            <a:off x="731520" y="640080"/>
+            <a:off x="731520" y="594360"/>
             <a:ext cx="10698480" cy="640080"/>
           </a:xfrm>
           <a:prstGeom prst="rect">
@@ -3880,7 +3940,1180 @@
           <a:lstStyle/>
           <a:p>
             <a:pPr>
-              <a:defRPr sz="3000" b="1">
+              <a:defRPr sz="2800" b="1">
+                <a:solidFill>
+                  <a:srgbClr val="FFFFFF"/>
+                </a:solidFill>
+                <a:latin typeface="Segoe UI"/>
+              </a:defRPr>
+            </a:pPr>
+            <a:r>
+              <a:t>Live System Visual: Batch Leaderboard &amp; SQLite Log</a:t>
+            </a:r>
+          </a:p>
+        </p:txBody>
+      </p:sp>
+      <p:sp>
+        <p:nvSpPr>
+          <p:cNvPr id="4" name="Rounded Rectangle 3"/>
+          <p:cNvSpPr/>
+          <p:nvPr/>
+        </p:nvSpPr>
+        <p:spPr>
+          <a:xfrm>
+            <a:off x="731520" y="1280160"/>
+            <a:ext cx="10728655" cy="5120640"/>
+          </a:xfrm>
+          <a:prstGeom prst="roundRect">
+            <a:avLst/>
+          </a:prstGeom>
+          <a:solidFill>
+            <a:srgbClr val="1E293B"/>
+          </a:solidFill>
+          <a:ln w="25400">
+            <a:solidFill>
+              <a:srgbClr val="00F7FF"/>
+            </a:solidFill>
+          </a:ln>
+        </p:spPr>
+        <p:style>
+          <a:lnRef idx="1">
+            <a:schemeClr val="accent1"/>
+          </a:lnRef>
+          <a:fillRef idx="3">
+            <a:schemeClr val="accent1"/>
+          </a:fillRef>
+          <a:effectRef idx="2">
+            <a:schemeClr val="accent1"/>
+          </a:effectRef>
+          <a:fontRef idx="minor">
+            <a:schemeClr val="lt1"/>
+          </a:fontRef>
+        </p:style>
+        <p:txBody>
+          <a:bodyPr rtlCol="0" anchor="ctr"/>
+          <a:lstStyle/>
+          <a:p>
+            <a:pPr algn="ctr"/>
+          </a:p>
+        </p:txBody>
+      </p:sp>
+      <p:pic>
+        <p:nvPicPr>
+          <p:cNvPr id="5" name="Picture 4" descr="sc4_batch_history.png"/>
+          <p:cNvPicPr>
+            <a:picLocks noChangeAspect="1"/>
+          </p:cNvPicPr>
+          <p:nvPr/>
+        </p:nvPicPr>
+        <p:blipFill>
+          <a:blip r:embed="rId2"/>
+          <a:stretch>
+            <a:fillRect/>
+          </a:stretch>
+        </p:blipFill>
+        <p:spPr>
+          <a:xfrm>
+            <a:off x="914400" y="1417320"/>
+            <a:ext cx="10362895" cy="4434840"/>
+          </a:xfrm>
+          <a:prstGeom prst="rect">
+            <a:avLst/>
+          </a:prstGeom>
+        </p:spPr>
+      </p:pic>
+      <p:sp>
+        <p:nvSpPr>
+          <p:cNvPr id="6" name="TextBox 5"/>
+          <p:cNvSpPr txBox="1"/>
+          <p:nvPr/>
+        </p:nvSpPr>
+        <p:spPr>
+          <a:xfrm>
+            <a:off x="914400" y="5897880"/>
+            <a:ext cx="10362895" cy="457200"/>
+          </a:xfrm>
+          <a:prstGeom prst="rect">
+            <a:avLst/>
+          </a:prstGeom>
+          <a:noFill/>
+        </p:spPr>
+        <p:txBody>
+          <a:bodyPr wrap="square">
+            <a:spAutoFit/>
+          </a:bodyPr>
+          <a:lstStyle/>
+          <a:p>
+            <a:pPr algn="ctr">
+              <a:defRPr sz="1400" b="1">
+                <a:solidFill>
+                  <a:srgbClr val="FFBF00"/>
+                </a:solidFill>
+              </a:defRPr>
+            </a:pPr>
+            <a:r>
+              <a:t>📸 LIVE SYSTEM DEMO: Candidate ranking leaderboard and SQLite audit trail saved in ats_history.db with clear history button</a:t>
+            </a:r>
+          </a:p>
+        </p:txBody>
+      </p:sp>
+    </p:spTree>
+  </p:cSld>
+  <p:clrMapOvr>
+    <a:masterClrMapping/>
+  </p:clrMapOvr>
+</p:sld>
+</file>
+
+<file path=ppt/slides/slide13.xml><?xml version="1.0" encoding="utf-8"?>
+<p:sld xmlns:a="http://schemas.openxmlformats.org/drawingml/2006/main" xmlns:p="http://schemas.openxmlformats.org/presentationml/2006/main" xmlns:r="http://schemas.openxmlformats.org/officeDocument/2006/relationships">
+  <p:cSld>
+    <p:bg>
+      <p:bgPr>
+        <a:solidFill>
+          <a:srgbClr val="0F172A"/>
+        </a:solidFill>
+        <a:effectLst/>
+      </p:bgPr>
+    </p:bg>
+    <p:spTree>
+      <p:nvGrpSpPr>
+        <p:cNvPr id="1" name=""/>
+        <p:cNvGrpSpPr/>
+        <p:nvPr/>
+      </p:nvGrpSpPr>
+      <p:grpSpPr/>
+      <p:sp>
+        <p:nvSpPr>
+          <p:cNvPr id="2" name="TextBox 1"/>
+          <p:cNvSpPr txBox="1"/>
+          <p:nvPr/>
+        </p:nvSpPr>
+        <p:spPr>
+          <a:xfrm>
+            <a:off x="731520" y="320040"/>
+            <a:ext cx="10698480" cy="320040"/>
+          </a:xfrm>
+          <a:prstGeom prst="rect">
+            <a:avLst/>
+          </a:prstGeom>
+          <a:noFill/>
+        </p:spPr>
+        <p:txBody>
+          <a:bodyPr wrap="square">
+            <a:spAutoFit/>
+          </a:bodyPr>
+          <a:lstStyle/>
+          <a:p>
+            <a:pPr>
+              <a:defRPr sz="1200" b="1">
+                <a:solidFill>
+                  <a:srgbClr val="00F7FF"/>
+                </a:solidFill>
+                <a:latin typeface="Segoe UI"/>
+              </a:defRPr>
+            </a:pPr>
+            <a:r>
+              <a:t>HIRELENS | CAPSTONE DEFENSE</a:t>
+            </a:r>
+          </a:p>
+        </p:txBody>
+      </p:sp>
+      <p:sp>
+        <p:nvSpPr>
+          <p:cNvPr id="3" name="TextBox 2"/>
+          <p:cNvSpPr txBox="1"/>
+          <p:nvPr/>
+        </p:nvSpPr>
+        <p:spPr>
+          <a:xfrm>
+            <a:off x="731520" y="594360"/>
+            <a:ext cx="10698480" cy="640080"/>
+          </a:xfrm>
+          <a:prstGeom prst="rect">
+            <a:avLst/>
+          </a:prstGeom>
+          <a:noFill/>
+        </p:spPr>
+        <p:txBody>
+          <a:bodyPr wrap="square">
+            <a:spAutoFit/>
+          </a:bodyPr>
+          <a:lstStyle/>
+          <a:p>
+            <a:pPr>
+              <a:defRPr sz="2800" b="1">
+                <a:solidFill>
+                  <a:srgbClr val="FFFFFF"/>
+                </a:solidFill>
+                <a:latin typeface="Segoe UI"/>
+              </a:defRPr>
+            </a:pPr>
+            <a:r>
+              <a:t>System Latency &amp; Performance Benchmarks</a:t>
+            </a:r>
+          </a:p>
+        </p:txBody>
+      </p:sp>
+      <p:sp>
+        <p:nvSpPr>
+          <p:cNvPr id="4" name="Rounded Rectangle 3"/>
+          <p:cNvSpPr/>
+          <p:nvPr/>
+        </p:nvSpPr>
+        <p:spPr>
+          <a:xfrm>
+            <a:off x="731520" y="1371600"/>
+            <a:ext cx="5120640" cy="4846320"/>
+          </a:xfrm>
+          <a:prstGeom prst="roundRect">
+            <a:avLst/>
+          </a:prstGeom>
+          <a:solidFill>
+            <a:srgbClr val="1E293B"/>
+          </a:solidFill>
+          <a:ln w="25400">
+            <a:solidFill>
+              <a:srgbClr val="FFBF00"/>
+            </a:solidFill>
+          </a:ln>
+        </p:spPr>
+        <p:style>
+          <a:lnRef idx="1">
+            <a:schemeClr val="accent1"/>
+          </a:lnRef>
+          <a:fillRef idx="3">
+            <a:schemeClr val="accent1"/>
+          </a:fillRef>
+          <a:effectRef idx="2">
+            <a:schemeClr val="accent1"/>
+          </a:effectRef>
+          <a:fontRef idx="minor">
+            <a:schemeClr val="lt1"/>
+          </a:fontRef>
+        </p:style>
+        <p:txBody>
+          <a:bodyPr rtlCol="0" anchor="ctr"/>
+          <a:lstStyle/>
+          <a:p>
+            <a:pPr algn="ctr"/>
+          </a:p>
+        </p:txBody>
+      </p:sp>
+      <p:sp>
+        <p:nvSpPr>
+          <p:cNvPr id="5" name="TextBox 4"/>
+          <p:cNvSpPr txBox="1"/>
+          <p:nvPr/>
+        </p:nvSpPr>
+        <p:spPr>
+          <a:xfrm>
+            <a:off x="914400" y="1554480"/>
+            <a:ext cx="4754880" cy="4480560"/>
+          </a:xfrm>
+          <a:prstGeom prst="rect">
+            <a:avLst/>
+          </a:prstGeom>
+          <a:noFill/>
+        </p:spPr>
+        <p:txBody>
+          <a:bodyPr wrap="square">
+            <a:spAutoFit/>
+          </a:bodyPr>
+          <a:lstStyle/>
+          <a:p>
+            <a:pPr>
+              <a:spcAft>
+                <a:spcPts val="1400"/>
+              </a:spcAft>
+              <a:defRPr sz="1700" b="1">
+                <a:solidFill>
+                  <a:srgbClr val="FFBF00"/>
+                </a:solidFill>
+              </a:defRPr>
+            </a:pPr>
+            <a:r>
+              <a:t>TEST CASE: ML ENGINEER</a:t>
+            </a:r>
+          </a:p>
+          <a:p>
+            <a:pPr>
+              <a:spcAft>
+                <a:spcPts val="1200"/>
+              </a:spcAft>
+            </a:pPr>
+            <a:r>
+              <a:rPr b="1" sz="1500">
+                <a:solidFill>
+                  <a:srgbClr val="FFFFFF"/>
+                </a:solidFill>
+              </a:rPr>
+              <a:t>• SBERT AI Meaning: </a:t>
+            </a:r>
+            <a:r>
+              <a:rPr sz="1500" b="0">
+                <a:solidFill>
+                  <a:srgbClr val="E2E8F0"/>
+                </a:solidFill>
+              </a:rPr>
+              <a:t>88.0%  (High Match)</a:t>
+            </a:r>
+          </a:p>
+          <a:p>
+            <a:pPr>
+              <a:spcAft>
+                <a:spcPts val="1200"/>
+              </a:spcAft>
+            </a:pPr>
+            <a:r>
+              <a:rPr b="1" sz="1500">
+                <a:solidFill>
+                  <a:srgbClr val="FFFFFF"/>
+                </a:solidFill>
+              </a:rPr>
+              <a:t>• Skill Match Ratio: </a:t>
+            </a:r>
+            <a:r>
+              <a:rPr sz="1500" b="0">
+                <a:solidFill>
+                  <a:srgbClr val="E2E8F0"/>
+                </a:solidFill>
+              </a:rPr>
+              <a:t>85.0%  (17 of 20 Skills)</a:t>
+            </a:r>
+          </a:p>
+          <a:p>
+            <a:pPr>
+              <a:spcAft>
+                <a:spcPts val="1200"/>
+              </a:spcAft>
+            </a:pPr>
+            <a:r>
+              <a:rPr b="1" sz="1500">
+                <a:solidFill>
+                  <a:srgbClr val="FFFFFF"/>
+                </a:solidFill>
+              </a:rPr>
+              <a:t>• Keyword Frequency: </a:t>
+            </a:r>
+            <a:r>
+              <a:rPr sz="1500" b="0">
+                <a:solidFill>
+                  <a:srgbClr val="E2E8F0"/>
+                </a:solidFill>
+              </a:rPr>
+              <a:t>89.0%  (Strong Fit)</a:t>
+            </a:r>
+          </a:p>
+          <a:p>
+            <a:pPr>
+              <a:spcAft>
+                <a:spcPts val="1200"/>
+              </a:spcAft>
+            </a:pPr>
+            <a:r>
+              <a:rPr b="1" sz="1500">
+                <a:solidFill>
+                  <a:srgbClr val="FFBF00"/>
+                </a:solidFill>
+              </a:rPr>
+              <a:t>• FINAL ATS SCORE: </a:t>
+            </a:r>
+            <a:r>
+              <a:rPr sz="1500" b="1">
+                <a:solidFill>
+                  <a:srgbClr val="00F7FF"/>
+                </a:solidFill>
+              </a:rPr>
+              <a:t>87.5%  (STRONG MATCH)</a:t>
+            </a:r>
+          </a:p>
+        </p:txBody>
+      </p:sp>
+      <p:sp>
+        <p:nvSpPr>
+          <p:cNvPr id="6" name="Rounded Rectangle 5"/>
+          <p:cNvSpPr/>
+          <p:nvPr/>
+        </p:nvSpPr>
+        <p:spPr>
+          <a:xfrm>
+            <a:off x="6217920" y="1371600"/>
+            <a:ext cx="5242255" cy="4846320"/>
+          </a:xfrm>
+          <a:prstGeom prst="roundRect">
+            <a:avLst/>
+          </a:prstGeom>
+          <a:solidFill>
+            <a:srgbClr val="1E293B"/>
+          </a:solidFill>
+          <a:ln w="25400">
+            <a:solidFill>
+              <a:srgbClr val="00F7FF"/>
+            </a:solidFill>
+          </a:ln>
+        </p:spPr>
+        <p:style>
+          <a:lnRef idx="1">
+            <a:schemeClr val="accent1"/>
+          </a:lnRef>
+          <a:fillRef idx="3">
+            <a:schemeClr val="accent1"/>
+          </a:fillRef>
+          <a:effectRef idx="2">
+            <a:schemeClr val="accent1"/>
+          </a:effectRef>
+          <a:fontRef idx="minor">
+            <a:schemeClr val="lt1"/>
+          </a:fontRef>
+        </p:style>
+        <p:txBody>
+          <a:bodyPr rtlCol="0" anchor="ctr"/>
+          <a:lstStyle/>
+          <a:p>
+            <a:pPr algn="ctr"/>
+          </a:p>
+        </p:txBody>
+      </p:sp>
+      <p:sp>
+        <p:nvSpPr>
+          <p:cNvPr id="7" name="TextBox 6"/>
+          <p:cNvSpPr txBox="1"/>
+          <p:nvPr/>
+        </p:nvSpPr>
+        <p:spPr>
+          <a:xfrm>
+            <a:off x="6400800" y="1554480"/>
+            <a:ext cx="4876495" cy="4480560"/>
+          </a:xfrm>
+          <a:prstGeom prst="rect">
+            <a:avLst/>
+          </a:prstGeom>
+          <a:noFill/>
+        </p:spPr>
+        <p:txBody>
+          <a:bodyPr wrap="square">
+            <a:spAutoFit/>
+          </a:bodyPr>
+          <a:lstStyle/>
+          <a:p>
+            <a:pPr>
+              <a:spcAft>
+                <a:spcPts val="1400"/>
+              </a:spcAft>
+              <a:defRPr sz="1700" b="1">
+                <a:solidFill>
+                  <a:srgbClr val="00F7FF"/>
+                </a:solidFill>
+              </a:defRPr>
+            </a:pPr>
+            <a:r>
+              <a:t>SPEED &amp; SYSTEM BENCHMARKS</a:t>
+            </a:r>
+          </a:p>
+          <a:p>
+            <a:pPr>
+              <a:spcAft>
+                <a:spcPts val="1400"/>
+              </a:spcAft>
+            </a:pPr>
+            <a:r>
+              <a:rPr b="1" sz="1500">
+                <a:solidFill>
+                  <a:srgbClr val="FFFFFF"/>
+                </a:solidFill>
+              </a:rPr>
+              <a:t>• Super-Fast Latency: </a:t>
+            </a:r>
+            <a:r>
+              <a:rPr sz="1500">
+                <a:solidFill>
+                  <a:srgbClr val="E2E8F0"/>
+                </a:solidFill>
+              </a:rPr>
+              <a:t>Processes each resume in under 1.8 seconds!</a:t>
+            </a:r>
+          </a:p>
+          <a:p>
+            <a:pPr>
+              <a:spcAft>
+                <a:spcPts val="1400"/>
+              </a:spcAft>
+            </a:pPr>
+            <a:r>
+              <a:rPr b="1" sz="1500">
+                <a:solidFill>
+                  <a:srgbClr val="FFFFFF"/>
+                </a:solidFill>
+              </a:rPr>
+              <a:t>• Low RAM Usage: </a:t>
+            </a:r>
+            <a:r>
+              <a:rPr sz="1500">
+                <a:solidFill>
+                  <a:srgbClr val="E2E8F0"/>
+                </a:solidFill>
+              </a:rPr>
+              <a:t>Uses less than 250 MB memory during evaluation.</a:t>
+            </a:r>
+          </a:p>
+          <a:p>
+            <a:pPr>
+              <a:spcAft>
+                <a:spcPts val="1400"/>
+              </a:spcAft>
+            </a:pPr>
+            <a:r>
+              <a:rPr b="1" sz="1500">
+                <a:solidFill>
+                  <a:srgbClr val="FFFFFF"/>
+                </a:solidFill>
+              </a:rPr>
+              <a:t>• No GPU Needed: </a:t>
+            </a:r>
+            <a:r>
+              <a:rPr sz="1500">
+                <a:solidFill>
+                  <a:srgbClr val="E2E8F0"/>
+                </a:solidFill>
+              </a:rPr>
+              <a:t>Runs smoothly on standard laptop CPUs without expensive graphics cards.</a:t>
+            </a:r>
+          </a:p>
+        </p:txBody>
+      </p:sp>
+    </p:spTree>
+  </p:cSld>
+  <p:clrMapOvr>
+    <a:masterClrMapping/>
+  </p:clrMapOvr>
+</p:sld>
+</file>
+
+<file path=ppt/slides/slide14.xml><?xml version="1.0" encoding="utf-8"?>
+<p:sld xmlns:a="http://schemas.openxmlformats.org/drawingml/2006/main" xmlns:p="http://schemas.openxmlformats.org/presentationml/2006/main" xmlns:r="http://schemas.openxmlformats.org/officeDocument/2006/relationships">
+  <p:cSld>
+    <p:bg>
+      <p:bgPr>
+        <a:solidFill>
+          <a:srgbClr val="0F172A"/>
+        </a:solidFill>
+        <a:effectLst/>
+      </p:bgPr>
+    </p:bg>
+    <p:spTree>
+      <p:nvGrpSpPr>
+        <p:cNvPr id="1" name=""/>
+        <p:cNvGrpSpPr/>
+        <p:nvPr/>
+      </p:nvGrpSpPr>
+      <p:grpSpPr/>
+      <p:sp>
+        <p:nvSpPr>
+          <p:cNvPr id="2" name="TextBox 1"/>
+          <p:cNvSpPr txBox="1"/>
+          <p:nvPr/>
+        </p:nvSpPr>
+        <p:spPr>
+          <a:xfrm>
+            <a:off x="731520" y="320040"/>
+            <a:ext cx="10698480" cy="320040"/>
+          </a:xfrm>
+          <a:prstGeom prst="rect">
+            <a:avLst/>
+          </a:prstGeom>
+          <a:noFill/>
+        </p:spPr>
+        <p:txBody>
+          <a:bodyPr wrap="square">
+            <a:spAutoFit/>
+          </a:bodyPr>
+          <a:lstStyle/>
+          <a:p>
+            <a:pPr>
+              <a:defRPr sz="1200" b="1">
+                <a:solidFill>
+                  <a:srgbClr val="00F7FF"/>
+                </a:solidFill>
+                <a:latin typeface="Segoe UI"/>
+              </a:defRPr>
+            </a:pPr>
+            <a:r>
+              <a:t>HIRELENS | CAPSTONE DEFENSE</a:t>
+            </a:r>
+          </a:p>
+        </p:txBody>
+      </p:sp>
+      <p:sp>
+        <p:nvSpPr>
+          <p:cNvPr id="3" name="TextBox 2"/>
+          <p:cNvSpPr txBox="1"/>
+          <p:nvPr/>
+        </p:nvSpPr>
+        <p:spPr>
+          <a:xfrm>
+            <a:off x="731520" y="594360"/>
+            <a:ext cx="10698480" cy="640080"/>
+          </a:xfrm>
+          <a:prstGeom prst="rect">
+            <a:avLst/>
+          </a:prstGeom>
+          <a:noFill/>
+        </p:spPr>
+        <p:txBody>
+          <a:bodyPr wrap="square">
+            <a:spAutoFit/>
+          </a:bodyPr>
+          <a:lstStyle/>
+          <a:p>
+            <a:pPr>
+              <a:defRPr sz="2800" b="1">
+                <a:solidFill>
+                  <a:srgbClr val="FFFFFF"/>
+                </a:solidFill>
+                <a:latin typeface="Segoe UI"/>
+              </a:defRPr>
+            </a:pPr>
+            <a:r>
+              <a:t>Enterprise REST API Integration</a:t>
+            </a:r>
+          </a:p>
+        </p:txBody>
+      </p:sp>
+      <p:sp>
+        <p:nvSpPr>
+          <p:cNvPr id="4" name="Rounded Rectangle 3"/>
+          <p:cNvSpPr/>
+          <p:nvPr/>
+        </p:nvSpPr>
+        <p:spPr>
+          <a:xfrm>
+            <a:off x="731520" y="1371600"/>
+            <a:ext cx="10728655" cy="4846320"/>
+          </a:xfrm>
+          <a:prstGeom prst="roundRect">
+            <a:avLst/>
+          </a:prstGeom>
+          <a:solidFill>
+            <a:srgbClr val="1E293B"/>
+          </a:solidFill>
+          <a:ln w="25400">
+            <a:solidFill>
+              <a:srgbClr val="00F7FF"/>
+            </a:solidFill>
+          </a:ln>
+        </p:spPr>
+        <p:style>
+          <a:lnRef idx="1">
+            <a:schemeClr val="accent1"/>
+          </a:lnRef>
+          <a:fillRef idx="3">
+            <a:schemeClr val="accent1"/>
+          </a:fillRef>
+          <a:effectRef idx="2">
+            <a:schemeClr val="accent1"/>
+          </a:effectRef>
+          <a:fontRef idx="minor">
+            <a:schemeClr val="lt1"/>
+          </a:fontRef>
+        </p:style>
+        <p:txBody>
+          <a:bodyPr rtlCol="0" anchor="ctr"/>
+          <a:lstStyle/>
+          <a:p>
+            <a:pPr algn="ctr"/>
+          </a:p>
+        </p:txBody>
+      </p:sp>
+      <p:sp>
+        <p:nvSpPr>
+          <p:cNvPr id="5" name="TextBox 4"/>
+          <p:cNvSpPr txBox="1"/>
+          <p:nvPr/>
+        </p:nvSpPr>
+        <p:spPr>
+          <a:xfrm>
+            <a:off x="1097280" y="1645920"/>
+            <a:ext cx="9997135" cy="4297680"/>
+          </a:xfrm>
+          <a:prstGeom prst="rect">
+            <a:avLst/>
+          </a:prstGeom>
+          <a:noFill/>
+        </p:spPr>
+        <p:txBody>
+          <a:bodyPr wrap="square">
+            <a:spAutoFit/>
+          </a:bodyPr>
+          <a:lstStyle/>
+          <a:p>
+            <a:pPr>
+              <a:spcAft>
+                <a:spcPts val="1600"/>
+              </a:spcAft>
+              <a:defRPr sz="1800" b="1">
+                <a:solidFill>
+                  <a:srgbClr val="00F7FF"/>
+                </a:solidFill>
+              </a:defRPr>
+            </a:pPr>
+            <a:r>
+              <a:t>FASTAPI BACKEND ENDPOINTS (api.py)</a:t>
+            </a:r>
+          </a:p>
+          <a:p>
+            <a:pPr>
+              <a:spcAft>
+                <a:spcPts val="1400"/>
+              </a:spcAft>
+            </a:pPr>
+            <a:r>
+              <a:rPr b="1" sz="1600">
+                <a:solidFill>
+                  <a:srgbClr val="FFBF00"/>
+                </a:solidFill>
+              </a:rPr>
+              <a:t>🔹 GET /docs : </a:t>
+            </a:r>
+            <a:r>
+              <a:rPr sz="1500">
+                <a:solidFill>
+                  <a:srgbClr val="FFFFFF"/>
+                </a:solidFill>
+              </a:rPr>
+              <a:t>Interactive Swagger UI documentation for live browser API testing.</a:t>
+            </a:r>
+          </a:p>
+          <a:p>
+            <a:pPr>
+              <a:spcAft>
+                <a:spcPts val="1400"/>
+              </a:spcAft>
+            </a:pPr>
+            <a:r>
+              <a:rPr b="1" sz="1600">
+                <a:solidFill>
+                  <a:srgbClr val="FFBF00"/>
+                </a:solidFill>
+              </a:rPr>
+              <a:t>🔹 POST /api/v1/parse-resume : </a:t>
+            </a:r>
+            <a:r>
+              <a:rPr sz="1500">
+                <a:solidFill>
+                  <a:srgbClr val="FFFFFF"/>
+                </a:solidFill>
+              </a:rPr>
+              <a:t>Upload PDF/DOCX resume file to get extracted text &amp; contact JSON.</a:t>
+            </a:r>
+          </a:p>
+          <a:p>
+            <a:pPr>
+              <a:spcAft>
+                <a:spcPts val="1400"/>
+              </a:spcAft>
+            </a:pPr>
+            <a:r>
+              <a:rPr b="1" sz="1600">
+                <a:solidFill>
+                  <a:srgbClr val="FFBF00"/>
+                </a:solidFill>
+              </a:rPr>
+              <a:t>🔹 POST /api/v1/analyze-match : </a:t>
+            </a:r>
+            <a:r>
+              <a:rPr sz="1500">
+                <a:solidFill>
+                  <a:srgbClr val="FFFFFF"/>
+                </a:solidFill>
+              </a:rPr>
+              <a:t>Returns ATS Match Score, Skill Coverage, and missing skill list JSON.</a:t>
+            </a:r>
+          </a:p>
+          <a:p>
+            <a:pPr>
+              <a:spcAft>
+                <a:spcPts val="1400"/>
+              </a:spcAft>
+            </a:pPr>
+            <a:r>
+              <a:rPr b="1" sz="1600">
+                <a:solidFill>
+                  <a:srgbClr val="FFBF00"/>
+                </a:solidFill>
+              </a:rPr>
+              <a:t>🔹 POST /api/v1/batch-rank : </a:t>
+            </a:r>
+            <a:r>
+              <a:rPr sz="1500">
+                <a:solidFill>
+                  <a:srgbClr val="FFFFFF"/>
+                </a:solidFill>
+              </a:rPr>
+              <a:t>Ranks multiple candidate resumes via API call responses.</a:t>
+            </a:r>
+          </a:p>
+        </p:txBody>
+      </p:sp>
+    </p:spTree>
+  </p:cSld>
+  <p:clrMapOvr>
+    <a:masterClrMapping/>
+  </p:clrMapOvr>
+</p:sld>
+</file>
+
+<file path=ppt/slides/slide15.xml><?xml version="1.0" encoding="utf-8"?>
+<p:sld xmlns:a="http://schemas.openxmlformats.org/drawingml/2006/main" xmlns:p="http://schemas.openxmlformats.org/presentationml/2006/main" xmlns:r="http://schemas.openxmlformats.org/officeDocument/2006/relationships">
+  <p:cSld>
+    <p:bg>
+      <p:bgPr>
+        <a:solidFill>
+          <a:srgbClr val="0F172A"/>
+        </a:solidFill>
+        <a:effectLst/>
+      </p:bgPr>
+    </p:bg>
+    <p:spTree>
+      <p:nvGrpSpPr>
+        <p:cNvPr id="1" name=""/>
+        <p:cNvGrpSpPr/>
+        <p:nvPr/>
+      </p:nvGrpSpPr>
+      <p:grpSpPr/>
+      <p:sp>
+        <p:nvSpPr>
+          <p:cNvPr id="2" name="TextBox 1"/>
+          <p:cNvSpPr txBox="1"/>
+          <p:nvPr/>
+        </p:nvSpPr>
+        <p:spPr>
+          <a:xfrm>
+            <a:off x="731520" y="320040"/>
+            <a:ext cx="10698480" cy="320040"/>
+          </a:xfrm>
+          <a:prstGeom prst="rect">
+            <a:avLst/>
+          </a:prstGeom>
+          <a:noFill/>
+        </p:spPr>
+        <p:txBody>
+          <a:bodyPr wrap="square">
+            <a:spAutoFit/>
+          </a:bodyPr>
+          <a:lstStyle/>
+          <a:p>
+            <a:pPr>
+              <a:defRPr sz="1200" b="1">
+                <a:solidFill>
+                  <a:srgbClr val="00F7FF"/>
+                </a:solidFill>
+                <a:latin typeface="Segoe UI"/>
+              </a:defRPr>
+            </a:pPr>
+            <a:r>
+              <a:t>HIRELENS | CAPSTONE DEFENSE</a:t>
+            </a:r>
+          </a:p>
+        </p:txBody>
+      </p:sp>
+      <p:sp>
+        <p:nvSpPr>
+          <p:cNvPr id="3" name="TextBox 2"/>
+          <p:cNvSpPr txBox="1"/>
+          <p:nvPr/>
+        </p:nvSpPr>
+        <p:spPr>
+          <a:xfrm>
+            <a:off x="731520" y="594360"/>
+            <a:ext cx="10698480" cy="640080"/>
+          </a:xfrm>
+          <a:prstGeom prst="rect">
+            <a:avLst/>
+          </a:prstGeom>
+          <a:noFill/>
+        </p:spPr>
+        <p:txBody>
+          <a:bodyPr wrap="square">
+            <a:spAutoFit/>
+          </a:bodyPr>
+          <a:lstStyle/>
+          <a:p>
+            <a:pPr>
+              <a:defRPr sz="2800" b="1">
+                <a:solidFill>
+                  <a:srgbClr val="FFFFFF"/>
+                </a:solidFill>
+                <a:latin typeface="Segoe UI"/>
+              </a:defRPr>
+            </a:pPr>
+            <a:r>
+              <a:t>Future Scope &amp; Enhancements</a:t>
+            </a:r>
+          </a:p>
+        </p:txBody>
+      </p:sp>
+      <p:sp>
+        <p:nvSpPr>
+          <p:cNvPr id="4" name="Rounded Rectangle 3"/>
+          <p:cNvSpPr/>
+          <p:nvPr/>
+        </p:nvSpPr>
+        <p:spPr>
+          <a:xfrm>
+            <a:off x="731520" y="1371600"/>
+            <a:ext cx="10728655" cy="4846320"/>
+          </a:xfrm>
+          <a:prstGeom prst="roundRect">
+            <a:avLst/>
+          </a:prstGeom>
+          <a:solidFill>
+            <a:srgbClr val="1E293B"/>
+          </a:solidFill>
+          <a:ln w="25400">
+            <a:solidFill>
+              <a:srgbClr val="FFBF00"/>
+            </a:solidFill>
+          </a:ln>
+        </p:spPr>
+        <p:style>
+          <a:lnRef idx="1">
+            <a:schemeClr val="accent1"/>
+          </a:lnRef>
+          <a:fillRef idx="3">
+            <a:schemeClr val="accent1"/>
+          </a:fillRef>
+          <a:effectRef idx="2">
+            <a:schemeClr val="accent1"/>
+          </a:effectRef>
+          <a:fontRef idx="minor">
+            <a:schemeClr val="lt1"/>
+          </a:fontRef>
+        </p:style>
+        <p:txBody>
+          <a:bodyPr rtlCol="0" anchor="ctr"/>
+          <a:lstStyle/>
+          <a:p>
+            <a:pPr algn="ctr"/>
+          </a:p>
+        </p:txBody>
+      </p:sp>
+      <p:sp>
+        <p:nvSpPr>
+          <p:cNvPr id="5" name="TextBox 4"/>
+          <p:cNvSpPr txBox="1"/>
+          <p:nvPr/>
+        </p:nvSpPr>
+        <p:spPr>
+          <a:xfrm>
+            <a:off x="1097280" y="1645920"/>
+            <a:ext cx="9997135" cy="4297680"/>
+          </a:xfrm>
+          <a:prstGeom prst="rect">
+            <a:avLst/>
+          </a:prstGeom>
+          <a:noFill/>
+        </p:spPr>
+        <p:txBody>
+          <a:bodyPr wrap="square">
+            <a:spAutoFit/>
+          </a:bodyPr>
+          <a:lstStyle/>
+          <a:p>
+            <a:pPr>
+              <a:spcAft>
+                <a:spcPts val="1600"/>
+              </a:spcAft>
+              <a:defRPr sz="1800" b="1">
+                <a:solidFill>
+                  <a:srgbClr val="FFBF00"/>
+                </a:solidFill>
+              </a:defRPr>
+            </a:pPr>
+            <a:r>
+              <a:t>FUTURE ROADMAP FOR HIRELENS</a:t>
+            </a:r>
+          </a:p>
+          <a:p>
+            <a:pPr>
+              <a:spcAft>
+                <a:spcPts val="1400"/>
+              </a:spcAft>
+            </a:pPr>
+            <a:r>
+              <a:rPr b="1" sz="1500">
+                <a:solidFill>
+                  <a:srgbClr val="00F7FF"/>
+                </a:solidFill>
+              </a:rPr>
+              <a:t>1. OCR Support for Scanned PDFs: </a:t>
+            </a:r>
+            <a:r>
+              <a:rPr sz="1500">
+                <a:solidFill>
+                  <a:srgbClr val="FFFFFF"/>
+                </a:solidFill>
+              </a:rPr>
+              <a:t>Integrate Tesseract OCR to read image-only scanned resumes.</a:t>
+            </a:r>
+          </a:p>
+          <a:p>
+            <a:pPr>
+              <a:spcAft>
+                <a:spcPts val="1400"/>
+              </a:spcAft>
+            </a:pPr>
+            <a:r>
+              <a:rPr b="1" sz="1500">
+                <a:solidFill>
+                  <a:srgbClr val="00F7FF"/>
+                </a:solidFill>
+              </a:rPr>
+              <a:t>2. Vector Database Scaling: </a:t>
+            </a:r>
+            <a:r>
+              <a:rPr sz="1500">
+                <a:solidFill>
+                  <a:srgbClr val="FFFFFF"/>
+                </a:solidFill>
+              </a:rPr>
+              <a:t>Use FAISS / Qdrant vector databases for instant searching across 1,000,000+ candidate resumes.</a:t>
+            </a:r>
+          </a:p>
+          <a:p>
+            <a:pPr>
+              <a:spcAft>
+                <a:spcPts val="1400"/>
+              </a:spcAft>
+            </a:pPr>
+            <a:r>
+              <a:rPr b="1" sz="1500">
+                <a:solidFill>
+                  <a:srgbClr val="00F7FF"/>
+                </a:solidFill>
+              </a:rPr>
+              <a:t>3. Multilingual Screening: </a:t>
+            </a:r>
+            <a:r>
+              <a:rPr sz="1500">
+                <a:solidFill>
+                  <a:srgbClr val="FFFFFF"/>
+                </a:solidFill>
+              </a:rPr>
+              <a:t>Support multi-language resume parsing (Spanish, Hindi, German, French).</a:t>
+            </a:r>
+          </a:p>
+          <a:p>
+            <a:pPr>
+              <a:spcAft>
+                <a:spcPts val="1400"/>
+              </a:spcAft>
+            </a:pPr>
+            <a:r>
+              <a:rPr b="1" sz="1500">
+                <a:solidFill>
+                  <a:srgbClr val="00F7FF"/>
+                </a:solidFill>
+              </a:rPr>
+              <a:t>4. Auto Interview Question Generator: </a:t>
+            </a:r>
+            <a:r>
+              <a:rPr sz="1500">
+                <a:solidFill>
+                  <a:srgbClr val="FFFFFF"/>
+                </a:solidFill>
+              </a:rPr>
+              <a:t>Automatically generate custom technical interview questions based on detected candidate skill gaps.</a:t>
+            </a:r>
+          </a:p>
+        </p:txBody>
+      </p:sp>
+    </p:spTree>
+  </p:cSld>
+  <p:clrMapOvr>
+    <a:masterClrMapping/>
+  </p:clrMapOvr>
+</p:sld>
+</file>
+
+<file path=ppt/slides/slide16.xml><?xml version="1.0" encoding="utf-8"?>
+<p:sld xmlns:a="http://schemas.openxmlformats.org/drawingml/2006/main" xmlns:p="http://schemas.openxmlformats.org/presentationml/2006/main" xmlns:r="http://schemas.openxmlformats.org/officeDocument/2006/relationships">
+  <p:cSld>
+    <p:bg>
+      <p:bgPr>
+        <a:solidFill>
+          <a:srgbClr val="0F172A"/>
+        </a:solidFill>
+        <a:effectLst/>
+      </p:bgPr>
+    </p:bg>
+    <p:spTree>
+      <p:nvGrpSpPr>
+        <p:cNvPr id="1" name=""/>
+        <p:cNvGrpSpPr/>
+        <p:nvPr/>
+      </p:nvGrpSpPr>
+      <p:grpSpPr/>
+      <p:sp>
+        <p:nvSpPr>
+          <p:cNvPr id="2" name="TextBox 1"/>
+          <p:cNvSpPr txBox="1"/>
+          <p:nvPr/>
+        </p:nvSpPr>
+        <p:spPr>
+          <a:xfrm>
+            <a:off x="731520" y="320040"/>
+            <a:ext cx="10698480" cy="320040"/>
+          </a:xfrm>
+          <a:prstGeom prst="rect">
+            <a:avLst/>
+          </a:prstGeom>
+          <a:noFill/>
+        </p:spPr>
+        <p:txBody>
+          <a:bodyPr wrap="square">
+            <a:spAutoFit/>
+          </a:bodyPr>
+          <a:lstStyle/>
+          <a:p>
+            <a:pPr>
+              <a:defRPr sz="1200" b="1">
+                <a:solidFill>
+                  <a:srgbClr val="00F7FF"/>
+                </a:solidFill>
+                <a:latin typeface="Segoe UI"/>
+              </a:defRPr>
+            </a:pPr>
+            <a:r>
+              <a:t>HIRELENS | CAPSTONE DEFENSE</a:t>
+            </a:r>
+          </a:p>
+        </p:txBody>
+      </p:sp>
+      <p:sp>
+        <p:nvSpPr>
+          <p:cNvPr id="3" name="TextBox 2"/>
+          <p:cNvSpPr txBox="1"/>
+          <p:nvPr/>
+        </p:nvSpPr>
+        <p:spPr>
+          <a:xfrm>
+            <a:off x="731520" y="594360"/>
+            <a:ext cx="10698480" cy="640080"/>
+          </a:xfrm>
+          <a:prstGeom prst="rect">
+            <a:avLst/>
+          </a:prstGeom>
+          <a:noFill/>
+        </p:spPr>
+        <p:txBody>
+          <a:bodyPr wrap="square">
+            <a:spAutoFit/>
+          </a:bodyPr>
+          <a:lstStyle/>
+          <a:p>
+            <a:pPr>
+              <a:defRPr sz="2800" b="1">
                 <a:solidFill>
                   <a:srgbClr val="FFFFFF"/>
                 </a:solidFill>
@@ -4082,7 +5315,7 @@
         </p:nvSpPr>
         <p:spPr>
           <a:xfrm>
-            <a:off x="731520" y="365760"/>
+            <a:off x="731520" y="320040"/>
             <a:ext cx="10698480" cy="320040"/>
           </a:xfrm>
           <a:prstGeom prst="rect">
@@ -4118,7 +5351,7 @@
         </p:nvSpPr>
         <p:spPr>
           <a:xfrm>
-            <a:off x="731520" y="640080"/>
+            <a:off x="731520" y="594360"/>
             <a:ext cx="10698480" cy="640080"/>
           </a:xfrm>
           <a:prstGeom prst="rect">
@@ -4133,7 +5366,7 @@
           <a:lstStyle/>
           <a:p>
             <a:pPr>
-              <a:defRPr sz="3000" b="1">
+              <a:defRPr sz="2800" b="1">
                 <a:solidFill>
                   <a:srgbClr val="FFFFFF"/>
                 </a:solidFill>
@@ -4484,7 +5717,7 @@
         </p:nvSpPr>
         <p:spPr>
           <a:xfrm>
-            <a:off x="731520" y="365760"/>
+            <a:off x="731520" y="320040"/>
             <a:ext cx="10698480" cy="320040"/>
           </a:xfrm>
           <a:prstGeom prst="rect">
@@ -4520,7 +5753,7 @@
         </p:nvSpPr>
         <p:spPr>
           <a:xfrm>
-            <a:off x="731520" y="640080"/>
+            <a:off x="731520" y="594360"/>
             <a:ext cx="10698480" cy="640080"/>
           </a:xfrm>
           <a:prstGeom prst="rect">
@@ -4535,7 +5768,7 @@
           <a:lstStyle/>
           <a:p>
             <a:pPr>
-              <a:defRPr sz="3000" b="1">
+              <a:defRPr sz="2800" b="1">
                 <a:solidFill>
                   <a:srgbClr val="FFFFFF"/>
                 </a:solidFill>
@@ -4962,7 +6195,7 @@
         </p:nvSpPr>
         <p:spPr>
           <a:xfrm>
-            <a:off x="731520" y="365760"/>
+            <a:off x="731520" y="320040"/>
             <a:ext cx="10698480" cy="320040"/>
           </a:xfrm>
           <a:prstGeom prst="rect">
@@ -4998,7 +6231,7 @@
         </p:nvSpPr>
         <p:spPr>
           <a:xfrm>
-            <a:off x="731520" y="640080"/>
+            <a:off x="731520" y="594360"/>
             <a:ext cx="10698480" cy="640080"/>
           </a:xfrm>
           <a:prstGeom prst="rect">
@@ -5013,7 +6246,7 @@
           <a:lstStyle/>
           <a:p>
             <a:pPr>
-              <a:defRPr sz="3000" b="1">
+              <a:defRPr sz="2800" b="1">
                 <a:solidFill>
                   <a:srgbClr val="FFFFFF"/>
                 </a:solidFill>
@@ -5441,7 +6674,7 @@
         </p:nvSpPr>
         <p:spPr>
           <a:xfrm>
-            <a:off x="731520" y="365760"/>
+            <a:off x="731520" y="320040"/>
             <a:ext cx="10698480" cy="320040"/>
           </a:xfrm>
           <a:prstGeom prst="rect">
@@ -5477,7 +6710,7 @@
         </p:nvSpPr>
         <p:spPr>
           <a:xfrm>
-            <a:off x="731520" y="640080"/>
+            <a:off x="731520" y="594360"/>
             <a:ext cx="10698480" cy="640080"/>
           </a:xfrm>
           <a:prstGeom prst="rect">
@@ -5492,7 +6725,7 @@
           <a:lstStyle/>
           <a:p>
             <a:pPr>
-              <a:defRPr sz="3000" b="1">
+              <a:defRPr sz="2800" b="1">
                 <a:solidFill>
                   <a:srgbClr val="FFFFFF"/>
                 </a:solidFill>
@@ -5714,7 +6947,7 @@
         </p:nvSpPr>
         <p:spPr>
           <a:xfrm>
-            <a:off x="731520" y="365760"/>
+            <a:off x="731520" y="320040"/>
             <a:ext cx="10698480" cy="320040"/>
           </a:xfrm>
           <a:prstGeom prst="rect">
@@ -5737,7 +6970,7 @@
               </a:defRPr>
             </a:pPr>
             <a:r>
-              <a:t>HIRELENS | CAPSTONE DEFENSE</a:t>
+              <a:t>LIVE DEMO | SYSTEM VISUAL PROOF</a:t>
             </a:r>
           </a:p>
         </p:txBody>
@@ -5750,7 +6983,7 @@
         </p:nvSpPr>
         <p:spPr>
           <a:xfrm>
-            <a:off x="731520" y="640080"/>
+            <a:off x="731520" y="594360"/>
             <a:ext cx="10698480" cy="640080"/>
           </a:xfrm>
           <a:prstGeom prst="rect">
@@ -5765,7 +6998,7 @@
           <a:lstStyle/>
           <a:p>
             <a:pPr>
-              <a:defRPr sz="3000" b="1">
+              <a:defRPr sz="2800" b="1">
                 <a:solidFill>
                   <a:srgbClr val="FFFFFF"/>
                 </a:solidFill>
@@ -5773,7 +7006,7 @@
               </a:defRPr>
             </a:pPr>
             <a:r>
-              <a:t>7-Domain Technical Skill Taxonomy</a:t>
+              <a:t>Live System Visual: ATS Score Gauge &amp; Evaluation</a:t>
             </a:r>
           </a:p>
         </p:txBody>
@@ -5786,8 +7019,8 @@
         </p:nvSpPr>
         <p:spPr>
           <a:xfrm>
-            <a:off x="731520" y="1371600"/>
-            <a:ext cx="5120640" cy="1051560"/>
+            <a:off x="731520" y="1280160"/>
+            <a:ext cx="10728655" cy="5120640"/>
           </a:xfrm>
           <a:prstGeom prst="roundRect">
             <a:avLst/>
@@ -5823,16 +7056,40 @@
           </a:p>
         </p:txBody>
       </p:sp>
-      <p:sp>
-        <p:nvSpPr>
-          <p:cNvPr id="5" name="TextBox 4"/>
+      <p:pic>
+        <p:nvPicPr>
+          <p:cNvPr id="5" name="Picture 4" descr="sc1_ats_score.png"/>
+          <p:cNvPicPr>
+            <a:picLocks noChangeAspect="1"/>
+          </p:cNvPicPr>
+          <p:nvPr/>
+        </p:nvPicPr>
+        <p:blipFill>
+          <a:blip r:embed="rId2"/>
+          <a:stretch>
+            <a:fillRect/>
+          </a:stretch>
+        </p:blipFill>
+        <p:spPr>
+          <a:xfrm>
+            <a:off x="914400" y="1417320"/>
+            <a:ext cx="10362895" cy="4434840"/>
+          </a:xfrm>
+          <a:prstGeom prst="rect">
+            <a:avLst/>
+          </a:prstGeom>
+        </p:spPr>
+      </p:pic>
+      <p:sp>
+        <p:nvSpPr>
+          <p:cNvPr id="6" name="TextBox 5"/>
           <p:cNvSpPr txBox="1"/>
           <p:nvPr/>
         </p:nvSpPr>
         <p:spPr>
           <a:xfrm>
-            <a:off x="914400" y="1463040"/>
-            <a:ext cx="4754880" cy="868680"/>
+            <a:off x="914400" y="5897880"/>
+            <a:ext cx="10362895" cy="457200"/>
           </a:xfrm>
           <a:prstGeom prst="rect">
             <a:avLst/>
@@ -5845,600 +7102,15 @@
           </a:bodyPr>
           <a:lstStyle/>
           <a:p>
-            <a:pPr>
-              <a:spcAft>
-                <a:spcPts val="200"/>
-              </a:spcAft>
-              <a:defRPr sz="1500" b="1">
-                <a:solidFill>
-                  <a:srgbClr val="00F7FF"/>
-                </a:solidFill>
-              </a:defRPr>
-            </a:pPr>
-            <a:r>
-              <a:t>1. Programming</a:t>
-            </a:r>
-          </a:p>
-          <a:p>
-            <a:pPr>
-              <a:defRPr sz="1300">
-                <a:solidFill>
-                  <a:srgbClr val="FFFFFF"/>
-                </a:solidFill>
-              </a:defRPr>
-            </a:pPr>
-            <a:r>
-              <a:t>Python, Java, C++, JavaScript, SQL, Rust</a:t>
-            </a:r>
-          </a:p>
-        </p:txBody>
-      </p:sp>
-      <p:sp>
-        <p:nvSpPr>
-          <p:cNvPr id="6" name="Rounded Rectangle 5"/>
-          <p:cNvSpPr/>
-          <p:nvPr/>
-        </p:nvSpPr>
-        <p:spPr>
-          <a:xfrm>
-            <a:off x="731520" y="2606040"/>
-            <a:ext cx="5120640" cy="1051560"/>
-          </a:xfrm>
-          <a:prstGeom prst="roundRect">
-            <a:avLst/>
-          </a:prstGeom>
-          <a:solidFill>
-            <a:srgbClr val="1E293B"/>
-          </a:solidFill>
-          <a:ln w="25400">
-            <a:solidFill>
-              <a:srgbClr val="FFBF00"/>
-            </a:solidFill>
-          </a:ln>
-        </p:spPr>
-        <p:style>
-          <a:lnRef idx="1">
-            <a:schemeClr val="accent1"/>
-          </a:lnRef>
-          <a:fillRef idx="3">
-            <a:schemeClr val="accent1"/>
-          </a:fillRef>
-          <a:effectRef idx="2">
-            <a:schemeClr val="accent1"/>
-          </a:effectRef>
-          <a:fontRef idx="minor">
-            <a:schemeClr val="lt1"/>
-          </a:fontRef>
-        </p:style>
-        <p:txBody>
-          <a:bodyPr rtlCol="0" anchor="ctr"/>
-          <a:lstStyle/>
-          <a:p>
-            <a:pPr algn="ctr"/>
-          </a:p>
-        </p:txBody>
-      </p:sp>
-      <p:sp>
-        <p:nvSpPr>
-          <p:cNvPr id="7" name="TextBox 6"/>
-          <p:cNvSpPr txBox="1"/>
-          <p:nvPr/>
-        </p:nvSpPr>
-        <p:spPr>
-          <a:xfrm>
-            <a:off x="914400" y="2697480"/>
-            <a:ext cx="4754880" cy="868680"/>
-          </a:xfrm>
-          <a:prstGeom prst="rect">
-            <a:avLst/>
-          </a:prstGeom>
-          <a:noFill/>
-        </p:spPr>
-        <p:txBody>
-          <a:bodyPr wrap="square">
-            <a:spAutoFit/>
-          </a:bodyPr>
-          <a:lstStyle/>
-          <a:p>
-            <a:pPr>
-              <a:spcAft>
-                <a:spcPts val="200"/>
-              </a:spcAft>
-              <a:defRPr sz="1500" b="1">
+            <a:pPr algn="ctr">
+              <a:defRPr sz="1400" b="1">
                 <a:solidFill>
                   <a:srgbClr val="FFBF00"/>
                 </a:solidFill>
               </a:defRPr>
             </a:pPr>
             <a:r>
-              <a:t>2. Machine Learning &amp; AI</a:t>
-            </a:r>
-          </a:p>
-          <a:p>
-            <a:pPr>
-              <a:defRPr sz="1300">
-                <a:solidFill>
-                  <a:srgbClr val="FFFFFF"/>
-                </a:solidFill>
-              </a:defRPr>
-            </a:pPr>
-            <a:r>
-              <a:t>PyTorch, TensorFlow, Scikit-Learn, SpaCy, LLMs</a:t>
-            </a:r>
-          </a:p>
-        </p:txBody>
-      </p:sp>
-      <p:sp>
-        <p:nvSpPr>
-          <p:cNvPr id="8" name="Rounded Rectangle 7"/>
-          <p:cNvSpPr/>
-          <p:nvPr/>
-        </p:nvSpPr>
-        <p:spPr>
-          <a:xfrm>
-            <a:off x="731520" y="3840480"/>
-            <a:ext cx="5120640" cy="1051560"/>
-          </a:xfrm>
-          <a:prstGeom prst="roundRect">
-            <a:avLst/>
-          </a:prstGeom>
-          <a:solidFill>
-            <a:srgbClr val="1E293B"/>
-          </a:solidFill>
-          <a:ln w="25400">
-            <a:solidFill>
-              <a:srgbClr val="00F7FF"/>
-            </a:solidFill>
-          </a:ln>
-        </p:spPr>
-        <p:style>
-          <a:lnRef idx="1">
-            <a:schemeClr val="accent1"/>
-          </a:lnRef>
-          <a:fillRef idx="3">
-            <a:schemeClr val="accent1"/>
-          </a:fillRef>
-          <a:effectRef idx="2">
-            <a:schemeClr val="accent1"/>
-          </a:effectRef>
-          <a:fontRef idx="minor">
-            <a:schemeClr val="lt1"/>
-          </a:fontRef>
-        </p:style>
-        <p:txBody>
-          <a:bodyPr rtlCol="0" anchor="ctr"/>
-          <a:lstStyle/>
-          <a:p>
-            <a:pPr algn="ctr"/>
-          </a:p>
-        </p:txBody>
-      </p:sp>
-      <p:sp>
-        <p:nvSpPr>
-          <p:cNvPr id="9" name="TextBox 8"/>
-          <p:cNvSpPr txBox="1"/>
-          <p:nvPr/>
-        </p:nvSpPr>
-        <p:spPr>
-          <a:xfrm>
-            <a:off x="914400" y="3931920"/>
-            <a:ext cx="4754880" cy="868680"/>
-          </a:xfrm>
-          <a:prstGeom prst="rect">
-            <a:avLst/>
-          </a:prstGeom>
-          <a:noFill/>
-        </p:spPr>
-        <p:txBody>
-          <a:bodyPr wrap="square">
-            <a:spAutoFit/>
-          </a:bodyPr>
-          <a:lstStyle/>
-          <a:p>
-            <a:pPr>
-              <a:spcAft>
-                <a:spcPts val="200"/>
-              </a:spcAft>
-              <a:defRPr sz="1500" b="1">
-                <a:solidFill>
-                  <a:srgbClr val="00F7FF"/>
-                </a:solidFill>
-              </a:defRPr>
-            </a:pPr>
-            <a:r>
-              <a:t>3. Web Development</a:t>
-            </a:r>
-          </a:p>
-          <a:p>
-            <a:pPr>
-              <a:defRPr sz="1300">
-                <a:solidFill>
-                  <a:srgbClr val="FFFFFF"/>
-                </a:solidFill>
-              </a:defRPr>
-            </a:pPr>
-            <a:r>
-              <a:t>React, Node.js, FastAPI, Flask, Django, REST APIs</a:t>
-            </a:r>
-          </a:p>
-        </p:txBody>
-      </p:sp>
-      <p:sp>
-        <p:nvSpPr>
-          <p:cNvPr id="10" name="Rounded Rectangle 9"/>
-          <p:cNvSpPr/>
-          <p:nvPr/>
-        </p:nvSpPr>
-        <p:spPr>
-          <a:xfrm>
-            <a:off x="731520" y="5074920"/>
-            <a:ext cx="5120640" cy="1051560"/>
-          </a:xfrm>
-          <a:prstGeom prst="roundRect">
-            <a:avLst/>
-          </a:prstGeom>
-          <a:solidFill>
-            <a:srgbClr val="1E293B"/>
-          </a:solidFill>
-          <a:ln w="25400">
-            <a:solidFill>
-              <a:srgbClr val="FFBF00"/>
-            </a:solidFill>
-          </a:ln>
-        </p:spPr>
-        <p:style>
-          <a:lnRef idx="1">
-            <a:schemeClr val="accent1"/>
-          </a:lnRef>
-          <a:fillRef idx="3">
-            <a:schemeClr val="accent1"/>
-          </a:fillRef>
-          <a:effectRef idx="2">
-            <a:schemeClr val="accent1"/>
-          </a:effectRef>
-          <a:fontRef idx="minor">
-            <a:schemeClr val="lt1"/>
-          </a:fontRef>
-        </p:style>
-        <p:txBody>
-          <a:bodyPr rtlCol="0" anchor="ctr"/>
-          <a:lstStyle/>
-          <a:p>
-            <a:pPr algn="ctr"/>
-          </a:p>
-        </p:txBody>
-      </p:sp>
-      <p:sp>
-        <p:nvSpPr>
-          <p:cNvPr id="11" name="TextBox 10"/>
-          <p:cNvSpPr txBox="1"/>
-          <p:nvPr/>
-        </p:nvSpPr>
-        <p:spPr>
-          <a:xfrm>
-            <a:off x="914400" y="5166360"/>
-            <a:ext cx="4754880" cy="868680"/>
-          </a:xfrm>
-          <a:prstGeom prst="rect">
-            <a:avLst/>
-          </a:prstGeom>
-          <a:noFill/>
-        </p:spPr>
-        <p:txBody>
-          <a:bodyPr wrap="square">
-            <a:spAutoFit/>
-          </a:bodyPr>
-          <a:lstStyle/>
-          <a:p>
-            <a:pPr>
-              <a:spcAft>
-                <a:spcPts val="200"/>
-              </a:spcAft>
-              <a:defRPr sz="1500" b="1">
-                <a:solidFill>
-                  <a:srgbClr val="FFBF00"/>
-                </a:solidFill>
-              </a:defRPr>
-            </a:pPr>
-            <a:r>
-              <a:t>4. Cloud &amp; DevOps</a:t>
-            </a:r>
-          </a:p>
-          <a:p>
-            <a:pPr>
-              <a:defRPr sz="1300">
-                <a:solidFill>
-                  <a:srgbClr val="FFFFFF"/>
-                </a:solidFill>
-              </a:defRPr>
-            </a:pPr>
-            <a:r>
-              <a:t>AWS, Azure, GCP, Docker, Kubernetes, Git</a:t>
-            </a:r>
-          </a:p>
-        </p:txBody>
-      </p:sp>
-      <p:sp>
-        <p:nvSpPr>
-          <p:cNvPr id="12" name="Rounded Rectangle 11"/>
-          <p:cNvSpPr/>
-          <p:nvPr/>
-        </p:nvSpPr>
-        <p:spPr>
-          <a:xfrm>
-            <a:off x="6217920" y="1371600"/>
-            <a:ext cx="5120640" cy="1051560"/>
-          </a:xfrm>
-          <a:prstGeom prst="roundRect">
-            <a:avLst/>
-          </a:prstGeom>
-          <a:solidFill>
-            <a:srgbClr val="1E293B"/>
-          </a:solidFill>
-          <a:ln w="25400">
-            <a:solidFill>
-              <a:srgbClr val="00F7FF"/>
-            </a:solidFill>
-          </a:ln>
-        </p:spPr>
-        <p:style>
-          <a:lnRef idx="1">
-            <a:schemeClr val="accent1"/>
-          </a:lnRef>
-          <a:fillRef idx="3">
-            <a:schemeClr val="accent1"/>
-          </a:fillRef>
-          <a:effectRef idx="2">
-            <a:schemeClr val="accent1"/>
-          </a:effectRef>
-          <a:fontRef idx="minor">
-            <a:schemeClr val="lt1"/>
-          </a:fontRef>
-        </p:style>
-        <p:txBody>
-          <a:bodyPr rtlCol="0" anchor="ctr"/>
-          <a:lstStyle/>
-          <a:p>
-            <a:pPr algn="ctr"/>
-          </a:p>
-        </p:txBody>
-      </p:sp>
-      <p:sp>
-        <p:nvSpPr>
-          <p:cNvPr id="13" name="TextBox 12"/>
-          <p:cNvSpPr txBox="1"/>
-          <p:nvPr/>
-        </p:nvSpPr>
-        <p:spPr>
-          <a:xfrm>
-            <a:off x="6400800" y="1463040"/>
-            <a:ext cx="4754880" cy="868680"/>
-          </a:xfrm>
-          <a:prstGeom prst="rect">
-            <a:avLst/>
-          </a:prstGeom>
-          <a:noFill/>
-        </p:spPr>
-        <p:txBody>
-          <a:bodyPr wrap="square">
-            <a:spAutoFit/>
-          </a:bodyPr>
-          <a:lstStyle/>
-          <a:p>
-            <a:pPr>
-              <a:spcAft>
-                <a:spcPts val="200"/>
-              </a:spcAft>
-              <a:defRPr sz="1500" b="1">
-                <a:solidFill>
-                  <a:srgbClr val="00F7FF"/>
-                </a:solidFill>
-              </a:defRPr>
-            </a:pPr>
-            <a:r>
-              <a:t>5. Databases</a:t>
-            </a:r>
-          </a:p>
-          <a:p>
-            <a:pPr>
-              <a:defRPr sz="1300">
-                <a:solidFill>
-                  <a:srgbClr val="FFFFFF"/>
-                </a:solidFill>
-              </a:defRPr>
-            </a:pPr>
-            <a:r>
-              <a:t>PostgreSQL, MySQL, MongoDB, Redis, SQLite</a:t>
-            </a:r>
-          </a:p>
-        </p:txBody>
-      </p:sp>
-      <p:sp>
-        <p:nvSpPr>
-          <p:cNvPr id="14" name="Rounded Rectangle 13"/>
-          <p:cNvSpPr/>
-          <p:nvPr/>
-        </p:nvSpPr>
-        <p:spPr>
-          <a:xfrm>
-            <a:off x="6217920" y="2606040"/>
-            <a:ext cx="5120640" cy="1051560"/>
-          </a:xfrm>
-          <a:prstGeom prst="roundRect">
-            <a:avLst/>
-          </a:prstGeom>
-          <a:solidFill>
-            <a:srgbClr val="1E293B"/>
-          </a:solidFill>
-          <a:ln w="25400">
-            <a:solidFill>
-              <a:srgbClr val="FFBF00"/>
-            </a:solidFill>
-          </a:ln>
-        </p:spPr>
-        <p:style>
-          <a:lnRef idx="1">
-            <a:schemeClr val="accent1"/>
-          </a:lnRef>
-          <a:fillRef idx="3">
-            <a:schemeClr val="accent1"/>
-          </a:fillRef>
-          <a:effectRef idx="2">
-            <a:schemeClr val="accent1"/>
-          </a:effectRef>
-          <a:fontRef idx="minor">
-            <a:schemeClr val="lt1"/>
-          </a:fontRef>
-        </p:style>
-        <p:txBody>
-          <a:bodyPr rtlCol="0" anchor="ctr"/>
-          <a:lstStyle/>
-          <a:p>
-            <a:pPr algn="ctr"/>
-          </a:p>
-        </p:txBody>
-      </p:sp>
-      <p:sp>
-        <p:nvSpPr>
-          <p:cNvPr id="15" name="TextBox 14"/>
-          <p:cNvSpPr txBox="1"/>
-          <p:nvPr/>
-        </p:nvSpPr>
-        <p:spPr>
-          <a:xfrm>
-            <a:off x="6400800" y="2697480"/>
-            <a:ext cx="4754880" cy="868680"/>
-          </a:xfrm>
-          <a:prstGeom prst="rect">
-            <a:avLst/>
-          </a:prstGeom>
-          <a:noFill/>
-        </p:spPr>
-        <p:txBody>
-          <a:bodyPr wrap="square">
-            <a:spAutoFit/>
-          </a:bodyPr>
-          <a:lstStyle/>
-          <a:p>
-            <a:pPr>
-              <a:spcAft>
-                <a:spcPts val="200"/>
-              </a:spcAft>
-              <a:defRPr sz="1500" b="1">
-                <a:solidFill>
-                  <a:srgbClr val="FFBF00"/>
-                </a:solidFill>
-              </a:defRPr>
-            </a:pPr>
-            <a:r>
-              <a:t>6. Frameworks &amp; Tools</a:t>
-            </a:r>
-          </a:p>
-          <a:p>
-            <a:pPr>
-              <a:defRPr sz="1300">
-                <a:solidFill>
-                  <a:srgbClr val="FFFFFF"/>
-                </a:solidFill>
-              </a:defRPr>
-            </a:pPr>
-            <a:r>
-              <a:t>Pandas, NumPy, Matplotlib, Jupyter, VS Code</a:t>
-            </a:r>
-          </a:p>
-        </p:txBody>
-      </p:sp>
-      <p:sp>
-        <p:nvSpPr>
-          <p:cNvPr id="16" name="Rounded Rectangle 15"/>
-          <p:cNvSpPr/>
-          <p:nvPr/>
-        </p:nvSpPr>
-        <p:spPr>
-          <a:xfrm>
-            <a:off x="6217920" y="3840480"/>
-            <a:ext cx="5120640" cy="1051560"/>
-          </a:xfrm>
-          <a:prstGeom prst="roundRect">
-            <a:avLst/>
-          </a:prstGeom>
-          <a:solidFill>
-            <a:srgbClr val="1E293B"/>
-          </a:solidFill>
-          <a:ln w="25400">
-            <a:solidFill>
-              <a:srgbClr val="00F7FF"/>
-            </a:solidFill>
-          </a:ln>
-        </p:spPr>
-        <p:style>
-          <a:lnRef idx="1">
-            <a:schemeClr val="accent1"/>
-          </a:lnRef>
-          <a:fillRef idx="3">
-            <a:schemeClr val="accent1"/>
-          </a:fillRef>
-          <a:effectRef idx="2">
-            <a:schemeClr val="accent1"/>
-          </a:effectRef>
-          <a:fontRef idx="minor">
-            <a:schemeClr val="lt1"/>
-          </a:fontRef>
-        </p:style>
-        <p:txBody>
-          <a:bodyPr rtlCol="0" anchor="ctr"/>
-          <a:lstStyle/>
-          <a:p>
-            <a:pPr algn="ctr"/>
-          </a:p>
-        </p:txBody>
-      </p:sp>
-      <p:sp>
-        <p:nvSpPr>
-          <p:cNvPr id="17" name="TextBox 16"/>
-          <p:cNvSpPr txBox="1"/>
-          <p:nvPr/>
-        </p:nvSpPr>
-        <p:spPr>
-          <a:xfrm>
-            <a:off x="6400800" y="3931920"/>
-            <a:ext cx="4754880" cy="868680"/>
-          </a:xfrm>
-          <a:prstGeom prst="rect">
-            <a:avLst/>
-          </a:prstGeom>
-          <a:noFill/>
-        </p:spPr>
-        <p:txBody>
-          <a:bodyPr wrap="square">
-            <a:spAutoFit/>
-          </a:bodyPr>
-          <a:lstStyle/>
-          <a:p>
-            <a:pPr>
-              <a:spcAft>
-                <a:spcPts val="200"/>
-              </a:spcAft>
-              <a:defRPr sz="1500" b="1">
-                <a:solidFill>
-                  <a:srgbClr val="00F7FF"/>
-                </a:solidFill>
-              </a:defRPr>
-            </a:pPr>
-            <a:r>
-              <a:t>7. Soft Skills</a:t>
-            </a:r>
-          </a:p>
-          <a:p>
-            <a:pPr>
-              <a:defRPr sz="1300">
-                <a:solidFill>
-                  <a:srgbClr val="FFFFFF"/>
-                </a:solidFill>
-              </a:defRPr>
-            </a:pPr>
-            <a:r>
-              <a:t>Leadership, Problem Solving, Communication, Teamwork</a:t>
+              <a:t>📸 LIVE SYSTEM DEMO: Real-time evaluation dashboard showing ML Engineer Candidate scoring 87.5% (Strong Match Grade)</a:t>
             </a:r>
           </a:p>
         </p:txBody>
@@ -6477,7 +7149,7 @@
         </p:nvSpPr>
         <p:spPr>
           <a:xfrm>
-            <a:off x="731520" y="365760"/>
+            <a:off x="731520" y="320040"/>
             <a:ext cx="10698480" cy="320040"/>
           </a:xfrm>
           <a:prstGeom prst="rect">
@@ -6513,7 +7185,7 @@
         </p:nvSpPr>
         <p:spPr>
           <a:xfrm>
-            <a:off x="731520" y="640080"/>
+            <a:off x="731520" y="594360"/>
             <a:ext cx="10698480" cy="640080"/>
           </a:xfrm>
           <a:prstGeom prst="rect">
@@ -6528,7 +7200,7 @@
           <a:lstStyle/>
           <a:p>
             <a:pPr>
-              <a:defRPr sz="3000" b="1">
+              <a:defRPr sz="2800" b="1">
                 <a:solidFill>
                   <a:srgbClr val="FFFFFF"/>
                 </a:solidFill>
@@ -6536,7 +7208,7 @@
               </a:defRPr>
             </a:pPr>
             <a:r>
-              <a:t>Resume Formatting &amp; Contact Audit</a:t>
+              <a:t>7-Domain Technical Skill Taxonomy</a:t>
             </a:r>
           </a:p>
         </p:txBody>
@@ -6550,7 +7222,102 @@
         <p:spPr>
           <a:xfrm>
             <a:off x="731520" y="1371600"/>
-            <a:ext cx="10728655" cy="4846320"/>
+            <a:ext cx="5120640" cy="1051560"/>
+          </a:xfrm>
+          <a:prstGeom prst="roundRect">
+            <a:avLst/>
+          </a:prstGeom>
+          <a:solidFill>
+            <a:srgbClr val="1E293B"/>
+          </a:solidFill>
+          <a:ln w="25400">
+            <a:solidFill>
+              <a:srgbClr val="00F7FF"/>
+            </a:solidFill>
+          </a:ln>
+        </p:spPr>
+        <p:style>
+          <a:lnRef idx="1">
+            <a:schemeClr val="accent1"/>
+          </a:lnRef>
+          <a:fillRef idx="3">
+            <a:schemeClr val="accent1"/>
+          </a:fillRef>
+          <a:effectRef idx="2">
+            <a:schemeClr val="accent1"/>
+          </a:effectRef>
+          <a:fontRef idx="minor">
+            <a:schemeClr val="lt1"/>
+          </a:fontRef>
+        </p:style>
+        <p:txBody>
+          <a:bodyPr rtlCol="0" anchor="ctr"/>
+          <a:lstStyle/>
+          <a:p>
+            <a:pPr algn="ctr"/>
+          </a:p>
+        </p:txBody>
+      </p:sp>
+      <p:sp>
+        <p:nvSpPr>
+          <p:cNvPr id="5" name="TextBox 4"/>
+          <p:cNvSpPr txBox="1"/>
+          <p:nvPr/>
+        </p:nvSpPr>
+        <p:spPr>
+          <a:xfrm>
+            <a:off x="914400" y="1463040"/>
+            <a:ext cx="4754880" cy="868680"/>
+          </a:xfrm>
+          <a:prstGeom prst="rect">
+            <a:avLst/>
+          </a:prstGeom>
+          <a:noFill/>
+        </p:spPr>
+        <p:txBody>
+          <a:bodyPr wrap="square">
+            <a:spAutoFit/>
+          </a:bodyPr>
+          <a:lstStyle/>
+          <a:p>
+            <a:pPr>
+              <a:spcAft>
+                <a:spcPts val="200"/>
+              </a:spcAft>
+              <a:defRPr sz="1500" b="1">
+                <a:solidFill>
+                  <a:srgbClr val="00F7FF"/>
+                </a:solidFill>
+              </a:defRPr>
+            </a:pPr>
+            <a:r>
+              <a:t>1. Programming</a:t>
+            </a:r>
+          </a:p>
+          <a:p>
+            <a:pPr>
+              <a:defRPr sz="1300">
+                <a:solidFill>
+                  <a:srgbClr val="FFFFFF"/>
+                </a:solidFill>
+              </a:defRPr>
+            </a:pPr>
+            <a:r>
+              <a:t>Python, Java, C++, JavaScript, SQL, Rust</a:t>
+            </a:r>
+          </a:p>
+        </p:txBody>
+      </p:sp>
+      <p:sp>
+        <p:nvSpPr>
+          <p:cNvPr id="6" name="Rounded Rectangle 5"/>
+          <p:cNvSpPr/>
+          <p:nvPr/>
+        </p:nvSpPr>
+        <p:spPr>
+          <a:xfrm>
+            <a:off x="731520" y="2606040"/>
+            <a:ext cx="5120640" cy="1051560"/>
           </a:xfrm>
           <a:prstGeom prst="roundRect">
             <a:avLst/>
@@ -6588,14 +7355,14 @@
       </p:sp>
       <p:sp>
         <p:nvSpPr>
-          <p:cNvPr id="5" name="TextBox 4"/>
+          <p:cNvPr id="7" name="TextBox 6"/>
           <p:cNvSpPr txBox="1"/>
           <p:nvPr/>
         </p:nvSpPr>
         <p:spPr>
           <a:xfrm>
-            <a:off x="1097280" y="1645920"/>
-            <a:ext cx="9997135" cy="4297680"/>
+            <a:off x="914400" y="2697480"/>
+            <a:ext cx="4754880" cy="868680"/>
           </a:xfrm>
           <a:prstGeom prst="rect">
             <a:avLst/>
@@ -6610,131 +7377,503 @@
           <a:p>
             <a:pPr>
               <a:spcAft>
-                <a:spcPts val="1600"/>
+                <a:spcPts val="200"/>
               </a:spcAft>
-              <a:defRPr sz="1800" b="1">
+              <a:defRPr sz="1500" b="1">
                 <a:solidFill>
                   <a:srgbClr val="FFBF00"/>
                 </a:solidFill>
               </a:defRPr>
             </a:pPr>
             <a:r>
-              <a:t>5 AUTOMATED AUDIT CHECKPOINTS</a:t>
-            </a:r>
-          </a:p>
+              <a:t>2. Machine Learning &amp; AI</a:t>
+            </a:r>
+          </a:p>
+          <a:p>
+            <a:pPr>
+              <a:defRPr sz="1300">
+                <a:solidFill>
+                  <a:srgbClr val="FFFFFF"/>
+                </a:solidFill>
+              </a:defRPr>
+            </a:pPr>
+            <a:r>
+              <a:t>PyTorch, TensorFlow, Scikit-Learn, SpaCy, LLMs</a:t>
+            </a:r>
+          </a:p>
+        </p:txBody>
+      </p:sp>
+      <p:sp>
+        <p:nvSpPr>
+          <p:cNvPr id="8" name="Rounded Rectangle 7"/>
+          <p:cNvSpPr/>
+          <p:nvPr/>
+        </p:nvSpPr>
+        <p:spPr>
+          <a:xfrm>
+            <a:off x="731520" y="3840480"/>
+            <a:ext cx="5120640" cy="1051560"/>
+          </a:xfrm>
+          <a:prstGeom prst="roundRect">
+            <a:avLst/>
+          </a:prstGeom>
+          <a:solidFill>
+            <a:srgbClr val="1E293B"/>
+          </a:solidFill>
+          <a:ln w="25400">
+            <a:solidFill>
+              <a:srgbClr val="00F7FF"/>
+            </a:solidFill>
+          </a:ln>
+        </p:spPr>
+        <p:style>
+          <a:lnRef idx="1">
+            <a:schemeClr val="accent1"/>
+          </a:lnRef>
+          <a:fillRef idx="3">
+            <a:schemeClr val="accent1"/>
+          </a:fillRef>
+          <a:effectRef idx="2">
+            <a:schemeClr val="accent1"/>
+          </a:effectRef>
+          <a:fontRef idx="minor">
+            <a:schemeClr val="lt1"/>
+          </a:fontRef>
+        </p:style>
+        <p:txBody>
+          <a:bodyPr rtlCol="0" anchor="ctr"/>
+          <a:lstStyle/>
+          <a:p>
+            <a:pPr algn="ctr"/>
+          </a:p>
+        </p:txBody>
+      </p:sp>
+      <p:sp>
+        <p:nvSpPr>
+          <p:cNvPr id="9" name="TextBox 8"/>
+          <p:cNvSpPr txBox="1"/>
+          <p:nvPr/>
+        </p:nvSpPr>
+        <p:spPr>
+          <a:xfrm>
+            <a:off x="914400" y="3931920"/>
+            <a:ext cx="4754880" cy="868680"/>
+          </a:xfrm>
+          <a:prstGeom prst="rect">
+            <a:avLst/>
+          </a:prstGeom>
+          <a:noFill/>
+        </p:spPr>
+        <p:txBody>
+          <a:bodyPr wrap="square">
+            <a:spAutoFit/>
+          </a:bodyPr>
+          <a:lstStyle/>
           <a:p>
             <a:pPr>
               <a:spcAft>
-                <a:spcPts val="1200"/>
+                <a:spcPts val="200"/>
               </a:spcAft>
-            </a:pPr>
-            <a:r>
-              <a:rPr b="1" sz="1500">
+              <a:defRPr sz="1500" b="1">
                 <a:solidFill>
                   <a:srgbClr val="00F7FF"/>
                 </a:solidFill>
-              </a:rPr>
-              <a:t>1. Contact Information: </a:t>
-            </a:r>
-            <a:r>
-              <a:rPr sz="1500">
+              </a:defRPr>
+            </a:pPr>
+            <a:r>
+              <a:t>3. Web Development</a:t>
+            </a:r>
+          </a:p>
+          <a:p>
+            <a:pPr>
+              <a:defRPr sz="1300">
                 <a:solidFill>
                   <a:srgbClr val="FFFFFF"/>
                 </a:solidFill>
-              </a:rPr>
-              <a:t>Extracts Email, 10-digit Phone Number, LinkedIn, and GitHub links cleanly.</a:t>
-            </a:r>
-          </a:p>
+              </a:defRPr>
+            </a:pPr>
+            <a:r>
+              <a:t>React, Node.js, FastAPI, Flask, Django, REST APIs</a:t>
+            </a:r>
+          </a:p>
+        </p:txBody>
+      </p:sp>
+      <p:sp>
+        <p:nvSpPr>
+          <p:cNvPr id="10" name="Rounded Rectangle 9"/>
+          <p:cNvSpPr/>
+          <p:nvPr/>
+        </p:nvSpPr>
+        <p:spPr>
+          <a:xfrm>
+            <a:off x="731520" y="5074920"/>
+            <a:ext cx="5120640" cy="1051560"/>
+          </a:xfrm>
+          <a:prstGeom prst="roundRect">
+            <a:avLst/>
+          </a:prstGeom>
+          <a:solidFill>
+            <a:srgbClr val="1E293B"/>
+          </a:solidFill>
+          <a:ln w="25400">
+            <a:solidFill>
+              <a:srgbClr val="FFBF00"/>
+            </a:solidFill>
+          </a:ln>
+        </p:spPr>
+        <p:style>
+          <a:lnRef idx="1">
+            <a:schemeClr val="accent1"/>
+          </a:lnRef>
+          <a:fillRef idx="3">
+            <a:schemeClr val="accent1"/>
+          </a:fillRef>
+          <a:effectRef idx="2">
+            <a:schemeClr val="accent1"/>
+          </a:effectRef>
+          <a:fontRef idx="minor">
+            <a:schemeClr val="lt1"/>
+          </a:fontRef>
+        </p:style>
+        <p:txBody>
+          <a:bodyPr rtlCol="0" anchor="ctr"/>
+          <a:lstStyle/>
+          <a:p>
+            <a:pPr algn="ctr"/>
+          </a:p>
+        </p:txBody>
+      </p:sp>
+      <p:sp>
+        <p:nvSpPr>
+          <p:cNvPr id="11" name="TextBox 10"/>
+          <p:cNvSpPr txBox="1"/>
+          <p:nvPr/>
+        </p:nvSpPr>
+        <p:spPr>
+          <a:xfrm>
+            <a:off x="914400" y="5166360"/>
+            <a:ext cx="4754880" cy="868680"/>
+          </a:xfrm>
+          <a:prstGeom prst="rect">
+            <a:avLst/>
+          </a:prstGeom>
+          <a:noFill/>
+        </p:spPr>
+        <p:txBody>
+          <a:bodyPr wrap="square">
+            <a:spAutoFit/>
+          </a:bodyPr>
+          <a:lstStyle/>
           <a:p>
             <a:pPr>
               <a:spcAft>
-                <a:spcPts val="1200"/>
+                <a:spcPts val="200"/>
               </a:spcAft>
-            </a:pPr>
-            <a:r>
-              <a:rPr b="1" sz="1500">
+              <a:defRPr sz="1500" b="1">
+                <a:solidFill>
+                  <a:srgbClr val="FFBF00"/>
+                </a:solidFill>
+              </a:defRPr>
+            </a:pPr>
+            <a:r>
+              <a:t>4. Cloud &amp; DevOps</a:t>
+            </a:r>
+          </a:p>
+          <a:p>
+            <a:pPr>
+              <a:defRPr sz="1300">
+                <a:solidFill>
+                  <a:srgbClr val="FFFFFF"/>
+                </a:solidFill>
+              </a:defRPr>
+            </a:pPr>
+            <a:r>
+              <a:t>AWS, Azure, GCP, Docker, Kubernetes, Git</a:t>
+            </a:r>
+          </a:p>
+        </p:txBody>
+      </p:sp>
+      <p:sp>
+        <p:nvSpPr>
+          <p:cNvPr id="12" name="Rounded Rectangle 11"/>
+          <p:cNvSpPr/>
+          <p:nvPr/>
+        </p:nvSpPr>
+        <p:spPr>
+          <a:xfrm>
+            <a:off x="6217920" y="1371600"/>
+            <a:ext cx="5120640" cy="1051560"/>
+          </a:xfrm>
+          <a:prstGeom prst="roundRect">
+            <a:avLst/>
+          </a:prstGeom>
+          <a:solidFill>
+            <a:srgbClr val="1E293B"/>
+          </a:solidFill>
+          <a:ln w="25400">
+            <a:solidFill>
+              <a:srgbClr val="00F7FF"/>
+            </a:solidFill>
+          </a:ln>
+        </p:spPr>
+        <p:style>
+          <a:lnRef idx="1">
+            <a:schemeClr val="accent1"/>
+          </a:lnRef>
+          <a:fillRef idx="3">
+            <a:schemeClr val="accent1"/>
+          </a:fillRef>
+          <a:effectRef idx="2">
+            <a:schemeClr val="accent1"/>
+          </a:effectRef>
+          <a:fontRef idx="minor">
+            <a:schemeClr val="lt1"/>
+          </a:fontRef>
+        </p:style>
+        <p:txBody>
+          <a:bodyPr rtlCol="0" anchor="ctr"/>
+          <a:lstStyle/>
+          <a:p>
+            <a:pPr algn="ctr"/>
+          </a:p>
+        </p:txBody>
+      </p:sp>
+      <p:sp>
+        <p:nvSpPr>
+          <p:cNvPr id="13" name="TextBox 12"/>
+          <p:cNvSpPr txBox="1"/>
+          <p:nvPr/>
+        </p:nvSpPr>
+        <p:spPr>
+          <a:xfrm>
+            <a:off x="6400800" y="1463040"/>
+            <a:ext cx="4754880" cy="868680"/>
+          </a:xfrm>
+          <a:prstGeom prst="rect">
+            <a:avLst/>
+          </a:prstGeom>
+          <a:noFill/>
+        </p:spPr>
+        <p:txBody>
+          <a:bodyPr wrap="square">
+            <a:spAutoFit/>
+          </a:bodyPr>
+          <a:lstStyle/>
+          <a:p>
+            <a:pPr>
+              <a:spcAft>
+                <a:spcPts val="200"/>
+              </a:spcAft>
+              <a:defRPr sz="1500" b="1">
                 <a:solidFill>
                   <a:srgbClr val="00F7FF"/>
                 </a:solidFill>
-              </a:rPr>
-              <a:t>2. Word Count Check: </a:t>
-            </a:r>
-            <a:r>
-              <a:rPr sz="1500">
+              </a:defRPr>
+            </a:pPr>
+            <a:r>
+              <a:t>5. Databases</a:t>
+            </a:r>
+          </a:p>
+          <a:p>
+            <a:pPr>
+              <a:defRPr sz="1300">
                 <a:solidFill>
                   <a:srgbClr val="FFFFFF"/>
                 </a:solidFill>
-              </a:rPr>
-              <a:t>Ensures resume is not too short (&lt;300 words) or too long (&gt;1500 words).</a:t>
-            </a:r>
-          </a:p>
+              </a:defRPr>
+            </a:pPr>
+            <a:r>
+              <a:t>PostgreSQL, MySQL, MongoDB, Redis, SQLite</a:t>
+            </a:r>
+          </a:p>
+        </p:txBody>
+      </p:sp>
+      <p:sp>
+        <p:nvSpPr>
+          <p:cNvPr id="14" name="Rounded Rectangle 13"/>
+          <p:cNvSpPr/>
+          <p:nvPr/>
+        </p:nvSpPr>
+        <p:spPr>
+          <a:xfrm>
+            <a:off x="6217920" y="2606040"/>
+            <a:ext cx="5120640" cy="1051560"/>
+          </a:xfrm>
+          <a:prstGeom prst="roundRect">
+            <a:avLst/>
+          </a:prstGeom>
+          <a:solidFill>
+            <a:srgbClr val="1E293B"/>
+          </a:solidFill>
+          <a:ln w="25400">
+            <a:solidFill>
+              <a:srgbClr val="FFBF00"/>
+            </a:solidFill>
+          </a:ln>
+        </p:spPr>
+        <p:style>
+          <a:lnRef idx="1">
+            <a:schemeClr val="accent1"/>
+          </a:lnRef>
+          <a:fillRef idx="3">
+            <a:schemeClr val="accent1"/>
+          </a:fillRef>
+          <a:effectRef idx="2">
+            <a:schemeClr val="accent1"/>
+          </a:effectRef>
+          <a:fontRef idx="minor">
+            <a:schemeClr val="lt1"/>
+          </a:fontRef>
+        </p:style>
+        <p:txBody>
+          <a:bodyPr rtlCol="0" anchor="ctr"/>
+          <a:lstStyle/>
+          <a:p>
+            <a:pPr algn="ctr"/>
+          </a:p>
+        </p:txBody>
+      </p:sp>
+      <p:sp>
+        <p:nvSpPr>
+          <p:cNvPr id="15" name="TextBox 14"/>
+          <p:cNvSpPr txBox="1"/>
+          <p:nvPr/>
+        </p:nvSpPr>
+        <p:spPr>
+          <a:xfrm>
+            <a:off x="6400800" y="2697480"/>
+            <a:ext cx="4754880" cy="868680"/>
+          </a:xfrm>
+          <a:prstGeom prst="rect">
+            <a:avLst/>
+          </a:prstGeom>
+          <a:noFill/>
+        </p:spPr>
+        <p:txBody>
+          <a:bodyPr wrap="square">
+            <a:spAutoFit/>
+          </a:bodyPr>
+          <a:lstStyle/>
           <a:p>
             <a:pPr>
               <a:spcAft>
-                <a:spcPts val="1200"/>
+                <a:spcPts val="200"/>
               </a:spcAft>
-            </a:pPr>
-            <a:r>
-              <a:rPr b="1" sz="1500">
+              <a:defRPr sz="1500" b="1">
+                <a:solidFill>
+                  <a:srgbClr val="FFBF00"/>
+                </a:solidFill>
+              </a:defRPr>
+            </a:pPr>
+            <a:r>
+              <a:t>6. Frameworks &amp; Tools</a:t>
+            </a:r>
+          </a:p>
+          <a:p>
+            <a:pPr>
+              <a:defRPr sz="1300">
+                <a:solidFill>
+                  <a:srgbClr val="FFFFFF"/>
+                </a:solidFill>
+              </a:defRPr>
+            </a:pPr>
+            <a:r>
+              <a:t>Pandas, NumPy, Matplotlib, Jupyter, VS Code</a:t>
+            </a:r>
+          </a:p>
+        </p:txBody>
+      </p:sp>
+      <p:sp>
+        <p:nvSpPr>
+          <p:cNvPr id="16" name="Rounded Rectangle 15"/>
+          <p:cNvSpPr/>
+          <p:nvPr/>
+        </p:nvSpPr>
+        <p:spPr>
+          <a:xfrm>
+            <a:off x="6217920" y="3840480"/>
+            <a:ext cx="5120640" cy="1051560"/>
+          </a:xfrm>
+          <a:prstGeom prst="roundRect">
+            <a:avLst/>
+          </a:prstGeom>
+          <a:solidFill>
+            <a:srgbClr val="1E293B"/>
+          </a:solidFill>
+          <a:ln w="25400">
+            <a:solidFill>
+              <a:srgbClr val="00F7FF"/>
+            </a:solidFill>
+          </a:ln>
+        </p:spPr>
+        <p:style>
+          <a:lnRef idx="1">
+            <a:schemeClr val="accent1"/>
+          </a:lnRef>
+          <a:fillRef idx="3">
+            <a:schemeClr val="accent1"/>
+          </a:fillRef>
+          <a:effectRef idx="2">
+            <a:schemeClr val="accent1"/>
+          </a:effectRef>
+          <a:fontRef idx="minor">
+            <a:schemeClr val="lt1"/>
+          </a:fontRef>
+        </p:style>
+        <p:txBody>
+          <a:bodyPr rtlCol="0" anchor="ctr"/>
+          <a:lstStyle/>
+          <a:p>
+            <a:pPr algn="ctr"/>
+          </a:p>
+        </p:txBody>
+      </p:sp>
+      <p:sp>
+        <p:nvSpPr>
+          <p:cNvPr id="17" name="TextBox 16"/>
+          <p:cNvSpPr txBox="1"/>
+          <p:nvPr/>
+        </p:nvSpPr>
+        <p:spPr>
+          <a:xfrm>
+            <a:off x="6400800" y="3931920"/>
+            <a:ext cx="4754880" cy="868680"/>
+          </a:xfrm>
+          <a:prstGeom prst="rect">
+            <a:avLst/>
+          </a:prstGeom>
+          <a:noFill/>
+        </p:spPr>
+        <p:txBody>
+          <a:bodyPr wrap="square">
+            <a:spAutoFit/>
+          </a:bodyPr>
+          <a:lstStyle/>
+          <a:p>
+            <a:pPr>
+              <a:spcAft>
+                <a:spcPts val="200"/>
+              </a:spcAft>
+              <a:defRPr sz="1500" b="1">
                 <a:solidFill>
                   <a:srgbClr val="00F7FF"/>
                 </a:solidFill>
-              </a:rPr>
-              <a:t>3. Essential Sections: </a:t>
-            </a:r>
-            <a:r>
-              <a:rPr sz="1500">
+              </a:defRPr>
+            </a:pPr>
+            <a:r>
+              <a:t>7. Soft Skills</a:t>
+            </a:r>
+          </a:p>
+          <a:p>
+            <a:pPr>
+              <a:defRPr sz="1300">
                 <a:solidFill>
                   <a:srgbClr val="FFFFFF"/>
                 </a:solidFill>
-              </a:rPr>
-              <a:t>Verifies presence of Education, Experience, Skills, and Projects sections.</a:t>
-            </a:r>
-          </a:p>
-          <a:p>
-            <a:pPr>
-              <a:spcAft>
-                <a:spcPts val="1200"/>
-              </a:spcAft>
-            </a:pPr>
-            <a:r>
-              <a:rPr b="1" sz="1500">
-                <a:solidFill>
-                  <a:srgbClr val="00F7FF"/>
-                </a:solidFill>
-              </a:rPr>
-              <a:t>4. Strong Action Verbs: </a:t>
-            </a:r>
-            <a:r>
-              <a:rPr sz="1500">
-                <a:solidFill>
-                  <a:srgbClr val="FFFFFF"/>
-                </a:solidFill>
-              </a:rPr>
-              <a:t>Scans for strong impact verbs (Designed, Developed, Optimized, Implemented).</a:t>
-            </a:r>
-          </a:p>
-          <a:p>
-            <a:pPr>
-              <a:spcAft>
-                <a:spcPts val="1200"/>
-              </a:spcAft>
-            </a:pPr>
-            <a:r>
-              <a:rPr b="1" sz="1500">
-                <a:solidFill>
-                  <a:srgbClr val="00F7FF"/>
-                </a:solidFill>
-              </a:rPr>
-              <a:t>5. Skill Gap Feedback: </a:t>
-            </a:r>
-            <a:r>
-              <a:rPr sz="1500">
-                <a:solidFill>
-                  <a:srgbClr val="FFFFFF"/>
-                </a:solidFill>
-              </a:rPr>
-              <a:t>Generates an instant list of missing required skills for candidate improvement.</a:t>
+              </a:defRPr>
+            </a:pPr>
+            <a:r>
+              <a:t>Leadership, Problem Solving, Communication, Teamwork</a:t>
             </a:r>
           </a:p>
         </p:txBody>
@@ -6773,7 +7912,7 @@
         </p:nvSpPr>
         <p:spPr>
           <a:xfrm>
-            <a:off x="731520" y="365760"/>
+            <a:off x="731520" y="320040"/>
             <a:ext cx="10698480" cy="320040"/>
           </a:xfrm>
           <a:prstGeom prst="rect">
@@ -6796,7 +7935,7 @@
               </a:defRPr>
             </a:pPr>
             <a:r>
-              <a:t>HIRELENS | CAPSTONE DEFENSE</a:t>
+              <a:t>LIVE DEMO | SYSTEM VISUAL PROOF</a:t>
             </a:r>
           </a:p>
         </p:txBody>
@@ -6809,7 +7948,7 @@
         </p:nvSpPr>
         <p:spPr>
           <a:xfrm>
-            <a:off x="731520" y="640080"/>
+            <a:off x="731520" y="594360"/>
             <a:ext cx="10698480" cy="640080"/>
           </a:xfrm>
           <a:prstGeom prst="rect">
@@ -6824,7 +7963,7 @@
           <a:lstStyle/>
           <a:p>
             <a:pPr>
-              <a:defRPr sz="3000" b="1">
+              <a:defRPr sz="2800" b="1">
                 <a:solidFill>
                   <a:srgbClr val="FFFFFF"/>
                 </a:solidFill>
@@ -6832,7 +7971,7 @@
               </a:defRPr>
             </a:pPr>
             <a:r>
-              <a:t>Interactive Streamlit Web Dashboard</a:t>
+              <a:t>Live System Visual: Plotly Multi-Domain Skill Radar</a:t>
             </a:r>
           </a:p>
         </p:txBody>
@@ -6845,8 +7984,8 @@
         </p:nvSpPr>
         <p:spPr>
           <a:xfrm>
-            <a:off x="731520" y="1371600"/>
-            <a:ext cx="5120640" cy="4846320"/>
+            <a:off x="731520" y="1280160"/>
+            <a:ext cx="10728655" cy="5120640"/>
           </a:xfrm>
           <a:prstGeom prst="roundRect">
             <a:avLst/>
@@ -6882,16 +8021,40 @@
           </a:p>
         </p:txBody>
       </p:sp>
-      <p:sp>
-        <p:nvSpPr>
-          <p:cNvPr id="5" name="TextBox 4"/>
+      <p:pic>
+        <p:nvPicPr>
+          <p:cNvPr id="5" name="Picture 4" descr="sc2_radar_chart.png"/>
+          <p:cNvPicPr>
+            <a:picLocks noChangeAspect="1"/>
+          </p:cNvPicPr>
+          <p:nvPr/>
+        </p:nvPicPr>
+        <p:blipFill>
+          <a:blip r:embed="rId2"/>
+          <a:stretch>
+            <a:fillRect/>
+          </a:stretch>
+        </p:blipFill>
+        <p:spPr>
+          <a:xfrm>
+            <a:off x="914400" y="1417320"/>
+            <a:ext cx="10362895" cy="4434840"/>
+          </a:xfrm>
+          <a:prstGeom prst="rect">
+            <a:avLst/>
+          </a:prstGeom>
+        </p:spPr>
+      </p:pic>
+      <p:sp>
+        <p:nvSpPr>
+          <p:cNvPr id="6" name="TextBox 5"/>
           <p:cNvSpPr txBox="1"/>
           <p:nvPr/>
         </p:nvSpPr>
         <p:spPr>
           <a:xfrm>
-            <a:off x="914400" y="1554480"/>
-            <a:ext cx="4754880" cy="4480560"/>
+            <a:off x="914400" y="5897880"/>
+            <a:ext cx="10362895" cy="457200"/>
           </a:xfrm>
           <a:prstGeom prst="rect">
             <a:avLst/>
@@ -6904,239 +8067,15 @@
           </a:bodyPr>
           <a:lstStyle/>
           <a:p>
-            <a:pPr>
-              <a:spcAft>
-                <a:spcPts val="1400"/>
-              </a:spcAft>
-              <a:defRPr sz="1800" b="1">
-                <a:solidFill>
-                  <a:srgbClr val="00F7FF"/>
-                </a:solidFill>
-              </a:defRPr>
-            </a:pPr>
-            <a:r>
-              <a:t>DASHBOARD HIGHLIGHTS</a:t>
-            </a:r>
-          </a:p>
-          <a:p>
-            <a:pPr>
-              <a:spcAft>
-                <a:spcPts val="1200"/>
-              </a:spcAft>
-            </a:pPr>
-            <a:r>
-              <a:rPr b="1" sz="1500">
-                <a:solidFill>
-                  <a:srgbClr val="FFFFFF"/>
-                </a:solidFill>
-              </a:rPr>
-              <a:t>• Streamlit Web App: </a:t>
-            </a:r>
-            <a:r>
-              <a:rPr sz="1500">
-                <a:solidFill>
-                  <a:srgbClr val="E2E8F0"/>
-                </a:solidFill>
-              </a:rPr>
-              <a:t>Clean dark mode user interface accessible in web browser.</a:t>
-            </a:r>
-          </a:p>
-          <a:p>
-            <a:pPr>
-              <a:spcAft>
-                <a:spcPts val="1200"/>
-              </a:spcAft>
-            </a:pPr>
-            <a:r>
-              <a:rPr b="1" sz="1500">
-                <a:solidFill>
-                  <a:srgbClr val="FFFFFF"/>
-                </a:solidFill>
-              </a:rPr>
-              <a:t>• Preset Demo Button: </a:t>
-            </a:r>
-            <a:r>
-              <a:rPr sz="1500">
-                <a:solidFill>
-                  <a:srgbClr val="E2E8F0"/>
-                </a:solidFill>
-              </a:rPr>
-              <a:t>One-click 'Load Preset Sample ML Data' for fast live demonstration.</a:t>
-            </a:r>
-          </a:p>
-          <a:p>
-            <a:pPr>
-              <a:spcAft>
-                <a:spcPts val="1200"/>
-              </a:spcAft>
-            </a:pPr>
-            <a:r>
-              <a:rPr b="1" sz="1500">
-                <a:solidFill>
-                  <a:srgbClr val="FFFFFF"/>
-                </a:solidFill>
-              </a:rPr>
-              <a:t>• Plotly Radar Chart: </a:t>
-            </a:r>
-            <a:r>
-              <a:rPr sz="1500">
-                <a:solidFill>
-                  <a:srgbClr val="E2E8F0"/>
-                </a:solidFill>
-              </a:rPr>
-              <a:t>Visual chart comparing candidate skills vs job requirements.</a:t>
-            </a:r>
-          </a:p>
-        </p:txBody>
-      </p:sp>
-      <p:sp>
-        <p:nvSpPr>
-          <p:cNvPr id="6" name="Rounded Rectangle 5"/>
-          <p:cNvSpPr/>
-          <p:nvPr/>
-        </p:nvSpPr>
-        <p:spPr>
-          <a:xfrm>
-            <a:off x="6217920" y="1371600"/>
-            <a:ext cx="5242255" cy="4846320"/>
-          </a:xfrm>
-          <a:prstGeom prst="roundRect">
-            <a:avLst/>
-          </a:prstGeom>
-          <a:solidFill>
-            <a:srgbClr val="1E293B"/>
-          </a:solidFill>
-          <a:ln w="25400">
-            <a:solidFill>
-              <a:srgbClr val="FFBF00"/>
-            </a:solidFill>
-          </a:ln>
-        </p:spPr>
-        <p:style>
-          <a:lnRef idx="1">
-            <a:schemeClr val="accent1"/>
-          </a:lnRef>
-          <a:fillRef idx="3">
-            <a:schemeClr val="accent1"/>
-          </a:fillRef>
-          <a:effectRef idx="2">
-            <a:schemeClr val="accent1"/>
-          </a:effectRef>
-          <a:fontRef idx="minor">
-            <a:schemeClr val="lt1"/>
-          </a:fontRef>
-        </p:style>
-        <p:txBody>
-          <a:bodyPr rtlCol="0" anchor="ctr"/>
-          <a:lstStyle/>
-          <a:p>
-            <a:pPr algn="ctr"/>
-          </a:p>
-        </p:txBody>
-      </p:sp>
-      <p:sp>
-        <p:nvSpPr>
-          <p:cNvPr id="7" name="TextBox 6"/>
-          <p:cNvSpPr txBox="1"/>
-          <p:nvPr/>
-        </p:nvSpPr>
-        <p:spPr>
-          <a:xfrm>
-            <a:off x="6400800" y="1554480"/>
-            <a:ext cx="4876495" cy="4480560"/>
-          </a:xfrm>
-          <a:prstGeom prst="rect">
-            <a:avLst/>
-          </a:prstGeom>
-          <a:noFill/>
-        </p:spPr>
-        <p:txBody>
-          <a:bodyPr wrap="square">
-            <a:spAutoFit/>
-          </a:bodyPr>
-          <a:lstStyle/>
-          <a:p>
-            <a:pPr>
-              <a:spcAft>
-                <a:spcPts val="1400"/>
-              </a:spcAft>
-              <a:defRPr sz="1800" b="1">
+            <a:pPr algn="ctr">
+              <a:defRPr sz="1400" b="1">
                 <a:solidFill>
                   <a:srgbClr val="FFBF00"/>
                 </a:solidFill>
               </a:defRPr>
             </a:pPr>
             <a:r>
-              <a:t>DATABASE &amp; LEADERBOARD</a:t>
-            </a:r>
-          </a:p>
-          <a:p>
-            <a:pPr>
-              <a:spcAft>
-                <a:spcPts val="1200"/>
-              </a:spcAft>
-            </a:pPr>
-            <a:r>
-              <a:rPr b="1" sz="1500">
-                <a:solidFill>
-                  <a:srgbClr val="FFFFFF"/>
-                </a:solidFill>
-              </a:rPr>
-              <a:t>• Batch Leaderboard: </a:t>
-            </a:r>
-            <a:r>
-              <a:rPr sz="1500">
-                <a:solidFill>
-                  <a:srgbClr val="E2E8F0"/>
-                </a:solidFill>
-              </a:rPr>
-              <a:t>Upload 10+ resumes at once to rank candidates from highest to lowest score.</a:t>
-            </a:r>
-          </a:p>
-          <a:p>
-            <a:pPr>
-              <a:spcAft>
-                <a:spcPts val="1200"/>
-              </a:spcAft>
-            </a:pPr>
-            <a:r>
-              <a:rPr b="1" sz="1500">
-                <a:solidFill>
-                  <a:srgbClr val="FFFFFF"/>
-                </a:solidFill>
-              </a:rPr>
-              <a:t>• SQLite History Log: </a:t>
-            </a:r>
-            <a:r>
-              <a:rPr sz="1500">
-                <a:solidFill>
-                  <a:srgbClr val="E2E8F0"/>
-                </a:solidFill>
-              </a:rPr>
-              <a:t>Saves evaluation history into ats_history.db database.</a:t>
-            </a:r>
-          </a:p>
-          <a:p>
-            <a:pPr>
-              <a:spcAft>
-                <a:spcPts val="1200"/>
-              </a:spcAft>
-            </a:pPr>
-            <a:r>
-              <a:rPr b="1" sz="1500">
-                <a:solidFill>
-                  <a:srgbClr val="FFFFFF"/>
-                </a:solidFill>
-              </a:rPr>
-              <a:t>• Clear History Feature: </a:t>
-            </a:r>
-            <a:r>
-              <a:rPr sz="1500">
-                <a:solidFill>
-                  <a:srgbClr val="E2E8F0"/>
-                </a:solidFill>
-              </a:rPr>
-              <a:t>Includes a one-click 'Clear Audit Logs' button to reset database records.</a:t>
+              <a:t>📸 LIVE SYSTEM DEMO: Interactive polar radar chart visually comparing candidate domain proficiency against job requirements</a:t>
             </a:r>
           </a:p>
         </p:txBody>
@@ -7175,7 +8114,7 @@
         </p:nvSpPr>
         <p:spPr>
           <a:xfrm>
-            <a:off x="731520" y="365760"/>
+            <a:off x="731520" y="320040"/>
             <a:ext cx="10698480" cy="320040"/>
           </a:xfrm>
           <a:prstGeom prst="rect">
@@ -7211,7 +8150,7 @@
         </p:nvSpPr>
         <p:spPr>
           <a:xfrm>
-            <a:off x="731520" y="640080"/>
+            <a:off x="731520" y="594360"/>
             <a:ext cx="10698480" cy="640080"/>
           </a:xfrm>
           <a:prstGeom prst="rect">
@@ -7226,7 +8165,7 @@
           <a:lstStyle/>
           <a:p>
             <a:pPr>
-              <a:defRPr sz="3000" b="1">
+              <a:defRPr sz="2800" b="1">
                 <a:solidFill>
                   <a:srgbClr val="FFFFFF"/>
                 </a:solidFill>
@@ -7234,7 +8173,7 @@
               </a:defRPr>
             </a:pPr>
             <a:r>
-              <a:t>Live Test Results &amp; Benchmarks</a:t>
+              <a:t>Resume Formatting &amp; Contact Audit</a:t>
             </a:r>
           </a:p>
         </p:txBody>
@@ -7248,7 +8187,7 @@
         <p:spPr>
           <a:xfrm>
             <a:off x="731520" y="1371600"/>
-            <a:ext cx="5120640" cy="4846320"/>
+            <a:ext cx="10728655" cy="4846320"/>
           </a:xfrm>
           <a:prstGeom prst="roundRect">
             <a:avLst/>
@@ -7292,8 +8231,8 @@
         </p:nvSpPr>
         <p:spPr>
           <a:xfrm>
-            <a:off x="914400" y="1554480"/>
-            <a:ext cx="4754880" cy="4480560"/>
+            <a:off x="1097280" y="1645920"/>
+            <a:ext cx="9997135" cy="4297680"/>
           </a:xfrm>
           <a:prstGeom prst="rect">
             <a:avLst/>
@@ -7308,16 +8247,16 @@
           <a:p>
             <a:pPr>
               <a:spcAft>
-                <a:spcPts val="1400"/>
+                <a:spcPts val="1600"/>
               </a:spcAft>
-              <a:defRPr sz="1700" b="1">
+              <a:defRPr sz="1800" b="1">
                 <a:solidFill>
                   <a:srgbClr val="FFBF00"/>
                 </a:solidFill>
               </a:defRPr>
             </a:pPr>
             <a:r>
-              <a:t>TEST CASE: ML ENGINEER CANDIDATE</a:t>
+              <a:t>5 AUTOMATED AUDIT CHECKPOINTS</a:t>
             </a:r>
           </a:p>
           <a:p>
@@ -7329,18 +8268,18 @@
             <a:r>
               <a:rPr b="1" sz="1500">
                 <a:solidFill>
+                  <a:srgbClr val="00F7FF"/>
+                </a:solidFill>
+              </a:rPr>
+              <a:t>1. Contact Information: </a:t>
+            </a:r>
+            <a:r>
+              <a:rPr sz="1500">
+                <a:solidFill>
                   <a:srgbClr val="FFFFFF"/>
                 </a:solidFill>
               </a:rPr>
-              <a:t>• SBERT AI Meaning: </a:t>
-            </a:r>
-            <a:r>
-              <a:rPr sz="1500" b="0">
-                <a:solidFill>
-                  <a:srgbClr val="E2E8F0"/>
-                </a:solidFill>
-              </a:rPr>
-              <a:t>88.0%  (High Match)</a:t>
+              <a:t>Extracts Email, 10-digit Phone Number, LinkedIn, and GitHub links cleanly.</a:t>
             </a:r>
           </a:p>
           <a:p>
@@ -7352,18 +8291,18 @@
             <a:r>
               <a:rPr b="1" sz="1500">
                 <a:solidFill>
+                  <a:srgbClr val="00F7FF"/>
+                </a:solidFill>
+              </a:rPr>
+              <a:t>2. Word Count Check: </a:t>
+            </a:r>
+            <a:r>
+              <a:rPr sz="1500">
+                <a:solidFill>
                   <a:srgbClr val="FFFFFF"/>
                 </a:solidFill>
               </a:rPr>
-              <a:t>• Skill Match Ratio: </a:t>
-            </a:r>
-            <a:r>
-              <a:rPr sz="1500" b="0">
-                <a:solidFill>
-                  <a:srgbClr val="E2E8F0"/>
-                </a:solidFill>
-              </a:rPr>
-              <a:t>85.0%  (17 of 20 Skills)</a:t>
+              <a:t>Ensures resume is not too short (&lt;300 words) or too long (&gt;1500 words).</a:t>
             </a:r>
           </a:p>
           <a:p>
@@ -7375,18 +8314,18 @@
             <a:r>
               <a:rPr b="1" sz="1500">
                 <a:solidFill>
+                  <a:srgbClr val="00F7FF"/>
+                </a:solidFill>
+              </a:rPr>
+              <a:t>3. Essential Sections: </a:t>
+            </a:r>
+            <a:r>
+              <a:rPr sz="1500">
+                <a:solidFill>
                   <a:srgbClr val="FFFFFF"/>
                 </a:solidFill>
               </a:rPr>
-              <a:t>• Keyword Frequency: </a:t>
-            </a:r>
-            <a:r>
-              <a:rPr sz="1500" b="0">
-                <a:solidFill>
-                  <a:srgbClr val="E2E8F0"/>
-                </a:solidFill>
-              </a:rPr>
-              <a:t>89.0%  (Strong Fit)</a:t>
+              <a:t>Verifies presence of Education, Experience, Skills, and Projects sections.</a:t>
             </a:r>
           </a:p>
           <a:p>
@@ -7398,170 +8337,41 @@
             <a:r>
               <a:rPr b="1" sz="1500">
                 <a:solidFill>
-                  <a:srgbClr val="FFBF00"/>
+                  <a:srgbClr val="00F7FF"/>
                 </a:solidFill>
               </a:rPr>
-              <a:t>• FINAL ATS SCORE: </a:t>
-            </a:r>
-            <a:r>
-              <a:rPr sz="1500" b="1">
+              <a:t>4. Strong Action Verbs: </a:t>
+            </a:r>
+            <a:r>
+              <a:rPr sz="1500">
+                <a:solidFill>
+                  <a:srgbClr val="FFFFFF"/>
+                </a:solidFill>
+              </a:rPr>
+              <a:t>Scans for strong impact verbs (Designed, Developed, Optimized, Implemented).</a:t>
+            </a:r>
+          </a:p>
+          <a:p>
+            <a:pPr>
+              <a:spcAft>
+                <a:spcPts val="1200"/>
+              </a:spcAft>
+            </a:pPr>
+            <a:r>
+              <a:rPr b="1" sz="1500">
                 <a:solidFill>
                   <a:srgbClr val="00F7FF"/>
                 </a:solidFill>
               </a:rPr>
-              <a:t>87.5%  (STRONG MATCH)</a:t>
-            </a:r>
-          </a:p>
-        </p:txBody>
-      </p:sp>
-      <p:sp>
-        <p:nvSpPr>
-          <p:cNvPr id="6" name="Rounded Rectangle 5"/>
-          <p:cNvSpPr/>
-          <p:nvPr/>
-        </p:nvSpPr>
-        <p:spPr>
-          <a:xfrm>
-            <a:off x="6217920" y="1371600"/>
-            <a:ext cx="5242255" cy="4846320"/>
-          </a:xfrm>
-          <a:prstGeom prst="roundRect">
-            <a:avLst/>
-          </a:prstGeom>
-          <a:solidFill>
-            <a:srgbClr val="1E293B"/>
-          </a:solidFill>
-          <a:ln w="25400">
-            <a:solidFill>
-              <a:srgbClr val="00F7FF"/>
-            </a:solidFill>
-          </a:ln>
-        </p:spPr>
-        <p:style>
-          <a:lnRef idx="1">
-            <a:schemeClr val="accent1"/>
-          </a:lnRef>
-          <a:fillRef idx="3">
-            <a:schemeClr val="accent1"/>
-          </a:fillRef>
-          <a:effectRef idx="2">
-            <a:schemeClr val="accent1"/>
-          </a:effectRef>
-          <a:fontRef idx="minor">
-            <a:schemeClr val="lt1"/>
-          </a:fontRef>
-        </p:style>
-        <p:txBody>
-          <a:bodyPr rtlCol="0" anchor="ctr"/>
-          <a:lstStyle/>
-          <a:p>
-            <a:pPr algn="ctr"/>
-          </a:p>
-        </p:txBody>
-      </p:sp>
-      <p:sp>
-        <p:nvSpPr>
-          <p:cNvPr id="7" name="TextBox 6"/>
-          <p:cNvSpPr txBox="1"/>
-          <p:nvPr/>
-        </p:nvSpPr>
-        <p:spPr>
-          <a:xfrm>
-            <a:off x="6400800" y="1554480"/>
-            <a:ext cx="4876495" cy="4480560"/>
-          </a:xfrm>
-          <a:prstGeom prst="rect">
-            <a:avLst/>
-          </a:prstGeom>
-          <a:noFill/>
-        </p:spPr>
-        <p:txBody>
-          <a:bodyPr wrap="square">
-            <a:spAutoFit/>
-          </a:bodyPr>
-          <a:lstStyle/>
-          <a:p>
-            <a:pPr>
-              <a:spcAft>
-                <a:spcPts val="1400"/>
-              </a:spcAft>
-              <a:defRPr sz="1700" b="1">
-                <a:solidFill>
-                  <a:srgbClr val="00F7FF"/>
-                </a:solidFill>
-              </a:defRPr>
-            </a:pPr>
-            <a:r>
-              <a:t>SPEED &amp; SYSTEM BENCHMARKS</a:t>
-            </a:r>
-          </a:p>
-          <a:p>
-            <a:pPr>
-              <a:spcAft>
-                <a:spcPts val="1400"/>
-              </a:spcAft>
-            </a:pPr>
-            <a:r>
-              <a:rPr b="1" sz="1500">
+              <a:t>5. Skill Gap Feedback: </a:t>
+            </a:r>
+            <a:r>
+              <a:rPr sz="1500">
                 <a:solidFill>
                   <a:srgbClr val="FFFFFF"/>
                 </a:solidFill>
               </a:rPr>
-              <a:t>• Super-Fast Latency: </a:t>
-            </a:r>
-            <a:r>
-              <a:rPr sz="1500">
-                <a:solidFill>
-                  <a:srgbClr val="E2E8F0"/>
-                </a:solidFill>
-              </a:rPr>
-              <a:t>Processes each resume in under 1.8 seconds!</a:t>
-            </a:r>
-          </a:p>
-          <a:p>
-            <a:pPr>
-              <a:spcAft>
-                <a:spcPts val="1400"/>
-              </a:spcAft>
-            </a:pPr>
-            <a:r>
-              <a:rPr b="1" sz="1500">
-                <a:solidFill>
-                  <a:srgbClr val="FFFFFF"/>
-                </a:solidFill>
-              </a:rPr>
-              <a:t>• Low RAM Usage: </a:t>
-            </a:r>
-            <a:r>
-              <a:rPr sz="1500">
-                <a:solidFill>
-                  <a:srgbClr val="E2E8F0"/>
-                </a:solidFill>
-              </a:rPr>
-              <a:t>Uses less than 250 MB memory during evaluation.</a:t>
-            </a:r>
-          </a:p>
-          <a:p>
-            <a:pPr>
-              <a:spcAft>
-                <a:spcPts val="1400"/>
-              </a:spcAft>
-            </a:pPr>
-            <a:r>
-              <a:rPr b="1" sz="1500">
-                <a:solidFill>
-                  <a:srgbClr val="FFFFFF"/>
-                </a:solidFill>
-              </a:rPr>
-              <a:t>• No GPU Needed: </a:t>
-            </a:r>
-            <a:r>
-              <a:rPr sz="1500">
-                <a:solidFill>
-                  <a:srgbClr val="E2E8F0"/>
-                </a:solidFill>
-              </a:rPr>
-              <a:t>Runs smoothly on standard laptop CPUs without expensive graphics cards.</a:t>
+              <a:t>Generates an instant list of missing required skills for candidate improvement.</a:t>
             </a:r>
           </a:p>
         </p:txBody>

</xml_diff>